<commit_message>
docs(lab05): integrate scenario listings and publish corrected deliverables
</commit_message>
<xml_diff>
--- a/labs/lab05/presentation/simulation-modeling-lab05-presentation.pptx
+++ b/labs/lab05/presentation/simulation-modeling-lab05-presentation.pptx
@@ -2,36 +2,37 @@
 <file path=ppt/presentation.xml><?xml version="1.0" encoding="utf-8"?>
 <p:presentation xmlns:p="http://schemas.openxmlformats.org/presentationml/2006/main">
   <p:sldMasterIdLst>
-    <p:sldMasterId xmlns:r="http://schemas.openxmlformats.org/officeDocument/2006/relationships" id="2147483648" r:id="Rd1ee21e7ee684fb2"/>
+    <p:sldMasterId xmlns:r="http://schemas.openxmlformats.org/officeDocument/2006/relationships" id="2147483648" r:id="Rffb25e84e71c4bff"/>
   </p:sldMasterIdLst>
   <p:notesMasterIdLst>
-    <p:notesMasterId xmlns:r="http://schemas.openxmlformats.org/officeDocument/2006/relationships" r:id="R13fc5bd1119b4deb"/>
+    <p:notesMasterId xmlns:r="http://schemas.openxmlformats.org/officeDocument/2006/relationships" r:id="Re5f4a600bf774dd3"/>
   </p:notesMasterIdLst>
   <p:sldIdLst>
-    <p:sldId xmlns:r="http://schemas.openxmlformats.org/officeDocument/2006/relationships" id="256" r:id="R91437a2a20ed491f"/>
-    <p:sldId xmlns:r="http://schemas.openxmlformats.org/officeDocument/2006/relationships" id="257" r:id="Rb5b362bf1d764007"/>
-    <p:sldId xmlns:r="http://schemas.openxmlformats.org/officeDocument/2006/relationships" id="258" r:id="Rb00ddd382a804ef0"/>
-    <p:sldId xmlns:r="http://schemas.openxmlformats.org/officeDocument/2006/relationships" id="259" r:id="R18168f42a2ff423f"/>
-    <p:sldId xmlns:r="http://schemas.openxmlformats.org/officeDocument/2006/relationships" id="260" r:id="R29e622af0273455b"/>
-    <p:sldId xmlns:r="http://schemas.openxmlformats.org/officeDocument/2006/relationships" id="261" r:id="R01497d3c7d2443e3"/>
-    <p:sldId xmlns:r="http://schemas.openxmlformats.org/officeDocument/2006/relationships" id="262" r:id="R3276b0ce6e194517"/>
-    <p:sldId xmlns:r="http://schemas.openxmlformats.org/officeDocument/2006/relationships" id="263" r:id="R888ba0497a844ef8"/>
-    <p:sldId xmlns:r="http://schemas.openxmlformats.org/officeDocument/2006/relationships" id="264" r:id="Re070a2a9fc5f4e96"/>
-    <p:sldId xmlns:r="http://schemas.openxmlformats.org/officeDocument/2006/relationships" id="265" r:id="Re292bd8baabb4212"/>
-    <p:sldId xmlns:r="http://schemas.openxmlformats.org/officeDocument/2006/relationships" id="266" r:id="Rc1ad5a5a7c814b9a"/>
-    <p:sldId xmlns:r="http://schemas.openxmlformats.org/officeDocument/2006/relationships" id="267" r:id="R82f9874aca1e46c5"/>
-    <p:sldId xmlns:r="http://schemas.openxmlformats.org/officeDocument/2006/relationships" id="268" r:id="Rd989058050834aee"/>
-    <p:sldId xmlns:r="http://schemas.openxmlformats.org/officeDocument/2006/relationships" id="269" r:id="Rf38c5b3be6104767"/>
-    <p:sldId xmlns:r="http://schemas.openxmlformats.org/officeDocument/2006/relationships" id="270" r:id="R6e1c71b392c143c2"/>
-    <p:sldId xmlns:r="http://schemas.openxmlformats.org/officeDocument/2006/relationships" id="271" r:id="Rb5c6ff5046f44fe8"/>
-    <p:sldId xmlns:r="http://schemas.openxmlformats.org/officeDocument/2006/relationships" id="272" r:id="R500f4448d0914b98"/>
-    <p:sldId xmlns:r="http://schemas.openxmlformats.org/officeDocument/2006/relationships" id="273" r:id="Rc95bdff2898b4c57"/>
-    <p:sldId xmlns:r="http://schemas.openxmlformats.org/officeDocument/2006/relationships" id="274" r:id="R8f2c447570534c2e"/>
-    <p:sldId xmlns:r="http://schemas.openxmlformats.org/officeDocument/2006/relationships" id="275" r:id="R837f393bccd74e2c"/>
-    <p:sldId xmlns:r="http://schemas.openxmlformats.org/officeDocument/2006/relationships" id="276" r:id="R6d868ad8efbd4553"/>
-    <p:sldId xmlns:r="http://schemas.openxmlformats.org/officeDocument/2006/relationships" id="277" r:id="Rbda0b955d514448b"/>
-    <p:sldId xmlns:r="http://schemas.openxmlformats.org/officeDocument/2006/relationships" id="278" r:id="R6fe32089e2b44e7a"/>
-    <p:sldId xmlns:r="http://schemas.openxmlformats.org/officeDocument/2006/relationships" id="279" r:id="R767ac92d27fa450e"/>
+    <p:sldId xmlns:r="http://schemas.openxmlformats.org/officeDocument/2006/relationships" id="256" r:id="R738a15b0fb024a00"/>
+    <p:sldId xmlns:r="http://schemas.openxmlformats.org/officeDocument/2006/relationships" id="257" r:id="Rabe7824c8d044017"/>
+    <p:sldId xmlns:r="http://schemas.openxmlformats.org/officeDocument/2006/relationships" id="258" r:id="R11f2be58ef884fdf"/>
+    <p:sldId xmlns:r="http://schemas.openxmlformats.org/officeDocument/2006/relationships" id="259" r:id="Ra681fcf3f92245b5"/>
+    <p:sldId xmlns:r="http://schemas.openxmlformats.org/officeDocument/2006/relationships" id="260" r:id="R5536f5cff2774fde"/>
+    <p:sldId xmlns:r="http://schemas.openxmlformats.org/officeDocument/2006/relationships" id="261" r:id="R40e378c6d451446f"/>
+    <p:sldId xmlns:r="http://schemas.openxmlformats.org/officeDocument/2006/relationships" id="262" r:id="R9fcb8dd2f2df4c53"/>
+    <p:sldId xmlns:r="http://schemas.openxmlformats.org/officeDocument/2006/relationships" id="263" r:id="Re3f99eecc70d4c4f"/>
+    <p:sldId xmlns:r="http://schemas.openxmlformats.org/officeDocument/2006/relationships" id="264" r:id="R2fd4c29b6ebf45b0"/>
+    <p:sldId xmlns:r="http://schemas.openxmlformats.org/officeDocument/2006/relationships" id="265" r:id="R8ba3a0ca4d674c3f"/>
+    <p:sldId xmlns:r="http://schemas.openxmlformats.org/officeDocument/2006/relationships" id="266" r:id="R8885de4a59204ab2"/>
+    <p:sldId xmlns:r="http://schemas.openxmlformats.org/officeDocument/2006/relationships" id="267" r:id="Rd68b58c66e424969"/>
+    <p:sldId xmlns:r="http://schemas.openxmlformats.org/officeDocument/2006/relationships" id="268" r:id="Rc62af5bb47a94216"/>
+    <p:sldId xmlns:r="http://schemas.openxmlformats.org/officeDocument/2006/relationships" id="269" r:id="Rdc498406c9b84193"/>
+    <p:sldId xmlns:r="http://schemas.openxmlformats.org/officeDocument/2006/relationships" id="270" r:id="R6151e06181694526"/>
+    <p:sldId xmlns:r="http://schemas.openxmlformats.org/officeDocument/2006/relationships" id="271" r:id="R06c1303fb63d40b4"/>
+    <p:sldId xmlns:r="http://schemas.openxmlformats.org/officeDocument/2006/relationships" id="272" r:id="Rcce04ccfe52b4a41"/>
+    <p:sldId xmlns:r="http://schemas.openxmlformats.org/officeDocument/2006/relationships" id="273" r:id="Re92c6108ba824ac0"/>
+    <p:sldId xmlns:r="http://schemas.openxmlformats.org/officeDocument/2006/relationships" id="274" r:id="Rc8644ab3b2794b63"/>
+    <p:sldId xmlns:r="http://schemas.openxmlformats.org/officeDocument/2006/relationships" id="275" r:id="R2fa45031d208438f"/>
+    <p:sldId xmlns:r="http://schemas.openxmlformats.org/officeDocument/2006/relationships" id="276" r:id="R2cf3cb36580a4335"/>
+    <p:sldId xmlns:r="http://schemas.openxmlformats.org/officeDocument/2006/relationships" id="277" r:id="R706185ecc8264bc7"/>
+    <p:sldId xmlns:r="http://schemas.openxmlformats.org/officeDocument/2006/relationships" id="278" r:id="R41b32191aec14cb8"/>
+    <p:sldId xmlns:r="http://schemas.openxmlformats.org/officeDocument/2006/relationships" id="279" r:id="Rc60f9706089b4068"/>
+    <p:sldId xmlns:r="http://schemas.openxmlformats.org/officeDocument/2006/relationships" id="280" r:id="Rae62fea89b144665"/>
   </p:sldIdLst>
   <p:sldSz cx="12192000" cy="6858000"/>
   <p:notesSz cx="6858000" cy="9144000"/>
@@ -465,7 +466,7 @@
           <a:lstStyle xmlns:a="http://schemas.openxmlformats.org/drawingml/2006/main"/>
           <a:p xmlns:a="http://schemas.openxmlformats.org/drawingml/2006/main">
             <a:r>
-              <a:t>Лабораторная работа № 5. Численные результаты относятся к горизонту 50 и фиксированным начальным состояниям генератора. Доля блокировок — наблюдаемая частота в выполненной серии. </a:t>
+              <a:t>Лабораторная работа № 5. Горизонт базового и параметрического экспериментов — 50; анимационного — 30. Использованы фиксированные начальные состояния генератора. Доля блокировок — наблюдаемая частота в выполненной серии. </a:t>
             </a:r>
           </a:p>
           <a:p xmlns:a="http://schemas.openxmlformats.org/drawingml/2006/main">
@@ -496,6 +497,16 @@
           <a:p xmlns:a="http://schemas.openxmlformats.org/drawingml/2006/main">
             <a:r>
               <a:t>- labs/lab05/project/scripts/02_parameter_scan.jl — параметрическое исследование.</a:t>
+            </a:r>
+          </a:p>
+          <a:p xmlns:a="http://schemas.openxmlformats.org/drawingml/2006/main">
+            <a:r>
+              <a:t>- labs/lab05/project/scripts/03_marking_animation.jl — анимационный опыт.</a:t>
+            </a:r>
+          </a:p>
+          <a:p xmlns:a="http://schemas.openxmlformats.org/drawingml/2006/main">
+            <a:r>
+              <a:t>- labs/lab05/project/scripts/04_comparative_report.jl — анализ сохранённых CSV.</a:t>
             </a:r>
           </a:p>
           <a:p xmlns:a="http://schemas.openxmlformats.org/drawingml/2006/main">
@@ -575,7 +586,7 @@
           <a:lstStyle xmlns:a="http://schemas.openxmlformats.org/drawingml/2006/main"/>
           <a:p xmlns:a="http://schemas.openxmlformats.org/drawingml/2006/main">
             <a:r>
-              <a:t>Лабораторная работа № 5. Численные результаты относятся к горизонту 50 и фиксированным начальным состояниям генератора. Доля блокировок — наблюдаемая частота в выполненной серии. </a:t>
+              <a:t>Лабораторная работа № 5. Горизонт базового и параметрического экспериментов — 50; анимационного — 30. Использованы фиксированные начальные состояния генератора. Доля блокировок — наблюдаемая частота в выполненной серии. </a:t>
             </a:r>
           </a:p>
           <a:p xmlns:a="http://schemas.openxmlformats.org/drawingml/2006/main">
@@ -606,6 +617,16 @@
           <a:p xmlns:a="http://schemas.openxmlformats.org/drawingml/2006/main">
             <a:r>
               <a:t>- labs/lab05/project/scripts/02_parameter_scan.jl — параметрическое исследование.</a:t>
+            </a:r>
+          </a:p>
+          <a:p xmlns:a="http://schemas.openxmlformats.org/drawingml/2006/main">
+            <a:r>
+              <a:t>- labs/lab05/project/scripts/03_marking_animation.jl — анимационный опыт.</a:t>
+            </a:r>
+          </a:p>
+          <a:p xmlns:a="http://schemas.openxmlformats.org/drawingml/2006/main">
+            <a:r>
+              <a:t>- labs/lab05/project/scripts/04_comparative_report.jl — анализ сохранённых CSV.</a:t>
             </a:r>
           </a:p>
           <a:p xmlns:a="http://schemas.openxmlformats.org/drawingml/2006/main">
@@ -685,7 +706,7 @@
           <a:lstStyle xmlns:a="http://schemas.openxmlformats.org/drawingml/2006/main"/>
           <a:p xmlns:a="http://schemas.openxmlformats.org/drawingml/2006/main">
             <a:r>
-              <a:t>Лабораторная работа № 5. Численные результаты относятся к горизонту 50 и фиксированным начальным состояниям генератора. Доля блокировок — наблюдаемая частота в выполненной серии. Иллюстрации: 02-terminal.png.</a:t>
+              <a:t>Лабораторная работа № 5. Горизонт базового и параметрического экспериментов — 50; анимационного — 30. Использованы фиксированные начальные состояния генератора. Доля блокировок — наблюдаемая частота в выполненной серии. Иллюстрации: 02-terminal.png.</a:t>
             </a:r>
           </a:p>
           <a:p xmlns:a="http://schemas.openxmlformats.org/drawingml/2006/main">
@@ -716,6 +737,16 @@
           <a:p xmlns:a="http://schemas.openxmlformats.org/drawingml/2006/main">
             <a:r>
               <a:t>- labs/lab05/project/scripts/02_parameter_scan.jl — параметрическое исследование.</a:t>
+            </a:r>
+          </a:p>
+          <a:p xmlns:a="http://schemas.openxmlformats.org/drawingml/2006/main">
+            <a:r>
+              <a:t>- labs/lab05/project/scripts/03_marking_animation.jl — анимационный опыт.</a:t>
+            </a:r>
+          </a:p>
+          <a:p xmlns:a="http://schemas.openxmlformats.org/drawingml/2006/main">
+            <a:r>
+              <a:t>- labs/lab05/project/scripts/04_comparative_report.jl — анализ сохранённых CSV.</a:t>
             </a:r>
           </a:p>
           <a:p xmlns:a="http://schemas.openxmlformats.org/drawingml/2006/main">
@@ -795,7 +826,7 @@
           <a:lstStyle xmlns:a="http://schemas.openxmlformats.org/drawingml/2006/main"/>
           <a:p xmlns:a="http://schemas.openxmlformats.org/drawingml/2006/main">
             <a:r>
-              <a:t>Лабораторная работа № 5. Численные результаты относятся к горизонту 50 и фиксированным начальным состояниям генератора. Доля блокировок — наблюдаемая частота в выполненной серии. </a:t>
+              <a:t>Лабораторная работа № 5. Горизонт базового и параметрического экспериментов — 50; анимационного — 30. Использованы фиксированные начальные состояния генератора. Доля блокировок — наблюдаемая частота в выполненной серии. </a:t>
             </a:r>
           </a:p>
           <a:p xmlns:a="http://schemas.openxmlformats.org/drawingml/2006/main">
@@ -826,6 +857,16 @@
           <a:p xmlns:a="http://schemas.openxmlformats.org/drawingml/2006/main">
             <a:r>
               <a:t>- labs/lab05/project/scripts/02_parameter_scan.jl — параметрическое исследование.</a:t>
+            </a:r>
+          </a:p>
+          <a:p xmlns:a="http://schemas.openxmlformats.org/drawingml/2006/main">
+            <a:r>
+              <a:t>- labs/lab05/project/scripts/03_marking_animation.jl — анимационный опыт.</a:t>
+            </a:r>
+          </a:p>
+          <a:p xmlns:a="http://schemas.openxmlformats.org/drawingml/2006/main">
+            <a:r>
+              <a:t>- labs/lab05/project/scripts/04_comparative_report.jl — анализ сохранённых CSV.</a:t>
             </a:r>
           </a:p>
           <a:p xmlns:a="http://schemas.openxmlformats.org/drawingml/2006/main">
@@ -905,7 +946,7 @@
           <a:lstStyle xmlns:a="http://schemas.openxmlformats.org/drawingml/2006/main"/>
           <a:p xmlns:a="http://schemas.openxmlformats.org/drawingml/2006/main">
             <a:r>
-              <a:t>Лабораторная работа № 5. Численные результаты относятся к горизонту 50 и фиксированным начальным состояниям генератора. Доля блокировок — наблюдаемая частота в выполненной серии. </a:t>
+              <a:t>Лабораторная работа № 5. Горизонт базового и параметрического экспериментов — 50; анимационного — 30. Использованы фиксированные начальные состояния генератора. Доля блокировок — наблюдаемая частота в выполненной серии. </a:t>
             </a:r>
           </a:p>
           <a:p xmlns:a="http://schemas.openxmlformats.org/drawingml/2006/main">
@@ -936,6 +977,16 @@
           <a:p xmlns:a="http://schemas.openxmlformats.org/drawingml/2006/main">
             <a:r>
               <a:t>- labs/lab05/project/scripts/02_parameter_scan.jl — параметрическое исследование.</a:t>
+            </a:r>
+          </a:p>
+          <a:p xmlns:a="http://schemas.openxmlformats.org/drawingml/2006/main">
+            <a:r>
+              <a:t>- labs/lab05/project/scripts/03_marking_animation.jl — анимационный опыт.</a:t>
+            </a:r>
+          </a:p>
+          <a:p xmlns:a="http://schemas.openxmlformats.org/drawingml/2006/main">
+            <a:r>
+              <a:t>- labs/lab05/project/scripts/04_comparative_report.jl — анализ сохранённых CSV.</a:t>
             </a:r>
           </a:p>
           <a:p xmlns:a="http://schemas.openxmlformats.org/drawingml/2006/main">
@@ -1015,7 +1066,7 @@
           <a:lstStyle xmlns:a="http://schemas.openxmlformats.org/drawingml/2006/main"/>
           <a:p xmlns:a="http://schemas.openxmlformats.org/drawingml/2006/main">
             <a:r>
-              <a:t>Лабораторная работа № 5. Численные результаты относятся к горизонту 50 и фиксированным начальным состояниям генератора. Доля блокировок — наблюдаемая частота в выполненной серии. Иллюстрации: 01-plot.png.</a:t>
+              <a:t>Лабораторная работа № 5. Горизонт базового и параметрического экспериментов — 50; анимационного — 30. Использованы фиксированные начальные состояния генератора. Доля блокировок — наблюдаемая частота в выполненной серии. Иллюстрации: 01-plot.png.</a:t>
             </a:r>
           </a:p>
           <a:p xmlns:a="http://schemas.openxmlformats.org/drawingml/2006/main">
@@ -1046,6 +1097,16 @@
           <a:p xmlns:a="http://schemas.openxmlformats.org/drawingml/2006/main">
             <a:r>
               <a:t>- labs/lab05/project/scripts/02_parameter_scan.jl — параметрическое исследование.</a:t>
+            </a:r>
+          </a:p>
+          <a:p xmlns:a="http://schemas.openxmlformats.org/drawingml/2006/main">
+            <a:r>
+              <a:t>- labs/lab05/project/scripts/03_marking_animation.jl — анимационный опыт.</a:t>
+            </a:r>
+          </a:p>
+          <a:p xmlns:a="http://schemas.openxmlformats.org/drawingml/2006/main">
+            <a:r>
+              <a:t>- labs/lab05/project/scripts/04_comparative_report.jl — анализ сохранённых CSV.</a:t>
             </a:r>
           </a:p>
           <a:p xmlns:a="http://schemas.openxmlformats.org/drawingml/2006/main">
@@ -1125,7 +1186,7 @@
           <a:lstStyle xmlns:a="http://schemas.openxmlformats.org/drawingml/2006/main"/>
           <a:p xmlns:a="http://schemas.openxmlformats.org/drawingml/2006/main">
             <a:r>
-              <a:t>Лабораторная работа № 5. Численные результаты относятся к горизонту 50 и фиксированным начальным состояниям генератора. Доля блокировок — наблюдаемая частота в выполненной серии. Иллюстрации: 02-plot.png.</a:t>
+              <a:t>Лабораторная работа № 5. Горизонт базового и параметрического экспериментов — 50; анимационного — 30. Использованы фиксированные начальные состояния генератора. Доля блокировок — наблюдаемая частота в выполненной серии. Иллюстрации: 02-plot.png.</a:t>
             </a:r>
           </a:p>
           <a:p xmlns:a="http://schemas.openxmlformats.org/drawingml/2006/main">
@@ -1156,6 +1217,16 @@
           <a:p xmlns:a="http://schemas.openxmlformats.org/drawingml/2006/main">
             <a:r>
               <a:t>- labs/lab05/project/scripts/02_parameter_scan.jl — параметрическое исследование.</a:t>
+            </a:r>
+          </a:p>
+          <a:p xmlns:a="http://schemas.openxmlformats.org/drawingml/2006/main">
+            <a:r>
+              <a:t>- labs/lab05/project/scripts/03_marking_animation.jl — анимационный опыт.</a:t>
+            </a:r>
+          </a:p>
+          <a:p xmlns:a="http://schemas.openxmlformats.org/drawingml/2006/main">
+            <a:r>
+              <a:t>- labs/lab05/project/scripts/04_comparative_report.jl — анализ сохранённых CSV.</a:t>
             </a:r>
           </a:p>
           <a:p xmlns:a="http://schemas.openxmlformats.org/drawingml/2006/main">
@@ -1235,7 +1306,7 @@
           <a:lstStyle xmlns:a="http://schemas.openxmlformats.org/drawingml/2006/main"/>
           <a:p xmlns:a="http://schemas.openxmlformats.org/drawingml/2006/main">
             <a:r>
-              <a:t>Лабораторная работа № 5. Численные результаты относятся к горизонту 50 и фиксированным начальным состояниям генератора. Доля блокировок — наблюдаемая частота в выполненной серии. Иллюстрации: 03-plot.png.</a:t>
+              <a:t>Лабораторная работа № 5. Горизонт базового и параметрического экспериментов — 50; анимационного — 30. Использованы фиксированные начальные состояния генератора. Доля блокировок — наблюдаемая частота в выполненной серии. Иллюстрации: 03-plot.png.</a:t>
             </a:r>
           </a:p>
           <a:p xmlns:a="http://schemas.openxmlformats.org/drawingml/2006/main">
@@ -1266,6 +1337,16 @@
           <a:p xmlns:a="http://schemas.openxmlformats.org/drawingml/2006/main">
             <a:r>
               <a:t>- labs/lab05/project/scripts/02_parameter_scan.jl — параметрическое исследование.</a:t>
+            </a:r>
+          </a:p>
+          <a:p xmlns:a="http://schemas.openxmlformats.org/drawingml/2006/main">
+            <a:r>
+              <a:t>- labs/lab05/project/scripts/03_marking_animation.jl — анимационный опыт.</a:t>
+            </a:r>
+          </a:p>
+          <a:p xmlns:a="http://schemas.openxmlformats.org/drawingml/2006/main">
+            <a:r>
+              <a:t>- labs/lab05/project/scripts/04_comparative_report.jl — анализ сохранённых CSV.</a:t>
             </a:r>
           </a:p>
           <a:p xmlns:a="http://schemas.openxmlformats.org/drawingml/2006/main">
@@ -1345,7 +1426,7 @@
           <a:lstStyle xmlns:a="http://schemas.openxmlformats.org/drawingml/2006/main"/>
           <a:p xmlns:a="http://schemas.openxmlformats.org/drawingml/2006/main">
             <a:r>
-              <a:t>Лабораторная работа № 5. Численные результаты относятся к горизонту 50 и фиксированным начальным состояниям генератора. Доля блокировок — наблюдаемая частота в выполненной серии. Иллюстрации: 04-plot.png.</a:t>
+              <a:t>Лабораторная работа № 5. Горизонт базового и параметрического экспериментов — 50; анимационного — 30. Использованы фиксированные начальные состояния генератора. Доля блокировок — наблюдаемая частота в выполненной серии. Иллюстрации: 08-plot.png.</a:t>
             </a:r>
           </a:p>
           <a:p xmlns:a="http://schemas.openxmlformats.org/drawingml/2006/main">
@@ -1376,6 +1457,16 @@
           <a:p xmlns:a="http://schemas.openxmlformats.org/drawingml/2006/main">
             <a:r>
               <a:t>- labs/lab05/project/scripts/02_parameter_scan.jl — параметрическое исследование.</a:t>
+            </a:r>
+          </a:p>
+          <a:p xmlns:a="http://schemas.openxmlformats.org/drawingml/2006/main">
+            <a:r>
+              <a:t>- labs/lab05/project/scripts/03_marking_animation.jl — анимационный опыт.</a:t>
+            </a:r>
+          </a:p>
+          <a:p xmlns:a="http://schemas.openxmlformats.org/drawingml/2006/main">
+            <a:r>
+              <a:t>- labs/lab05/project/scripts/04_comparative_report.jl — анализ сохранённых CSV.</a:t>
             </a:r>
           </a:p>
           <a:p xmlns:a="http://schemas.openxmlformats.org/drawingml/2006/main">
@@ -1455,7 +1546,7 @@
           <a:lstStyle xmlns:a="http://schemas.openxmlformats.org/drawingml/2006/main"/>
           <a:p xmlns:a="http://schemas.openxmlformats.org/drawingml/2006/main">
             <a:r>
-              <a:t>Лабораторная работа № 5. Численные результаты относятся к горизонту 50 и фиксированным начальным состояниям генератора. Доля блокировок — наблюдаемая частота в выполненной серии. </a:t>
+              <a:t>Лабораторная работа № 5. Горизонт базового и параметрического экспериментов — 50; анимационного — 30. Использованы фиксированные начальные состояния генератора. Доля блокировок — наблюдаемая частота в выполненной серии. Иллюстрации: 04-plot.png.</a:t>
             </a:r>
           </a:p>
           <a:p xmlns:a="http://schemas.openxmlformats.org/drawingml/2006/main">
@@ -1486,6 +1577,16 @@
           <a:p xmlns:a="http://schemas.openxmlformats.org/drawingml/2006/main">
             <a:r>
               <a:t>- labs/lab05/project/scripts/02_parameter_scan.jl — параметрическое исследование.</a:t>
+            </a:r>
+          </a:p>
+          <a:p xmlns:a="http://schemas.openxmlformats.org/drawingml/2006/main">
+            <a:r>
+              <a:t>- labs/lab05/project/scripts/03_marking_animation.jl — анимационный опыт.</a:t>
+            </a:r>
+          </a:p>
+          <a:p xmlns:a="http://schemas.openxmlformats.org/drawingml/2006/main">
+            <a:r>
+              <a:t>- labs/lab05/project/scripts/04_comparative_report.jl — анализ сохранённых CSV.</a:t>
             </a:r>
           </a:p>
           <a:p xmlns:a="http://schemas.openxmlformats.org/drawingml/2006/main">
@@ -1565,7 +1666,7 @@
           <a:lstStyle xmlns:a="http://schemas.openxmlformats.org/drawingml/2006/main"/>
           <a:p xmlns:a="http://schemas.openxmlformats.org/drawingml/2006/main">
             <a:r>
-              <a:t>Лабораторная работа № 5. Численные результаты относятся к горизонту 50 и фиксированным начальным состояниям генератора. Доля блокировок — наблюдаемая частота в выполненной серии. Иллюстрации: 06-plot.png.</a:t>
+              <a:t>Лабораторная работа № 5. Горизонт базового и параметрического экспериментов — 50; анимационного — 30. Использованы фиксированные начальные состояния генератора. Доля блокировок — наблюдаемая частота в выполненной серии. </a:t>
             </a:r>
           </a:p>
           <a:p xmlns:a="http://schemas.openxmlformats.org/drawingml/2006/main">
@@ -1596,6 +1697,16 @@
           <a:p xmlns:a="http://schemas.openxmlformats.org/drawingml/2006/main">
             <a:r>
               <a:t>- labs/lab05/project/scripts/02_parameter_scan.jl — параметрическое исследование.</a:t>
+            </a:r>
+          </a:p>
+          <a:p xmlns:a="http://schemas.openxmlformats.org/drawingml/2006/main">
+            <a:r>
+              <a:t>- labs/lab05/project/scripts/03_marking_animation.jl — анимационный опыт.</a:t>
+            </a:r>
+          </a:p>
+          <a:p xmlns:a="http://schemas.openxmlformats.org/drawingml/2006/main">
+            <a:r>
+              <a:t>- labs/lab05/project/scripts/04_comparative_report.jl — анализ сохранённых CSV.</a:t>
             </a:r>
           </a:p>
           <a:p xmlns:a="http://schemas.openxmlformats.org/drawingml/2006/main">
@@ -1675,7 +1786,7 @@
           <a:lstStyle xmlns:a="http://schemas.openxmlformats.org/drawingml/2006/main"/>
           <a:p xmlns:a="http://schemas.openxmlformats.org/drawingml/2006/main">
             <a:r>
-              <a:t>Лабораторная работа № 5. Численные результаты относятся к горизонту 50 и фиксированным начальным состояниям генератора. Доля блокировок — наблюдаемая частота в выполненной серии. </a:t>
+              <a:t>Лабораторная работа № 5. Горизонт базового и параметрического экспериментов — 50; анимационного — 30. Использованы фиксированные начальные состояния генератора. Доля блокировок — наблюдаемая частота в выполненной серии. </a:t>
             </a:r>
           </a:p>
           <a:p xmlns:a="http://schemas.openxmlformats.org/drawingml/2006/main">
@@ -1706,6 +1817,16 @@
           <a:p xmlns:a="http://schemas.openxmlformats.org/drawingml/2006/main">
             <a:r>
               <a:t>- labs/lab05/project/scripts/02_parameter_scan.jl — параметрическое исследование.</a:t>
+            </a:r>
+          </a:p>
+          <a:p xmlns:a="http://schemas.openxmlformats.org/drawingml/2006/main">
+            <a:r>
+              <a:t>- labs/lab05/project/scripts/03_marking_animation.jl — анимационный опыт.</a:t>
+            </a:r>
+          </a:p>
+          <a:p xmlns:a="http://schemas.openxmlformats.org/drawingml/2006/main">
+            <a:r>
+              <a:t>- labs/lab05/project/scripts/04_comparative_report.jl — анализ сохранённых CSV.</a:t>
             </a:r>
           </a:p>
           <a:p xmlns:a="http://schemas.openxmlformats.org/drawingml/2006/main">
@@ -1785,7 +1906,7 @@
           <a:lstStyle xmlns:a="http://schemas.openxmlformats.org/drawingml/2006/main"/>
           <a:p xmlns:a="http://schemas.openxmlformats.org/drawingml/2006/main">
             <a:r>
-              <a:t>Лабораторная работа № 5. Численные результаты относятся к горизонту 50 и фиксированным начальным состояниям генератора. Доля блокировок — наблюдаемая частота в выполненной серии. Иллюстрации: 07-plot.png.</a:t>
+              <a:t>Лабораторная работа № 5. Горизонт базового и параметрического экспериментов — 50; анимационного — 30. Использованы фиксированные начальные состояния генератора. Доля блокировок — наблюдаемая частота в выполненной серии. Иллюстрации: 06-plot.png.</a:t>
             </a:r>
           </a:p>
           <a:p xmlns:a="http://schemas.openxmlformats.org/drawingml/2006/main">
@@ -1816,6 +1937,16 @@
           <a:p xmlns:a="http://schemas.openxmlformats.org/drawingml/2006/main">
             <a:r>
               <a:t>- labs/lab05/project/scripts/02_parameter_scan.jl — параметрическое исследование.</a:t>
+            </a:r>
+          </a:p>
+          <a:p xmlns:a="http://schemas.openxmlformats.org/drawingml/2006/main">
+            <a:r>
+              <a:t>- labs/lab05/project/scripts/03_marking_animation.jl — анимационный опыт.</a:t>
+            </a:r>
+          </a:p>
+          <a:p xmlns:a="http://schemas.openxmlformats.org/drawingml/2006/main">
+            <a:r>
+              <a:t>- labs/lab05/project/scripts/04_comparative_report.jl — анализ сохранённых CSV.</a:t>
             </a:r>
           </a:p>
           <a:p xmlns:a="http://schemas.openxmlformats.org/drawingml/2006/main">
@@ -1895,7 +2026,7 @@
           <a:lstStyle xmlns:a="http://schemas.openxmlformats.org/drawingml/2006/main"/>
           <a:p xmlns:a="http://schemas.openxmlformats.org/drawingml/2006/main">
             <a:r>
-              <a:t>Лабораторная работа № 5. Численные результаты относятся к горизонту 50 и фиксированным начальным состояниям генератора. Доля блокировок — наблюдаемая частота в выполненной серии. Иллюстрации: 01-jupyter.png, 02-jupyter.png.</a:t>
+              <a:t>Лабораторная работа № 5. Горизонт базового и параметрического экспериментов — 50; анимационного — 30. Использованы фиксированные начальные состояния генератора. Доля блокировок — наблюдаемая частота в выполненной серии. Иллюстрации: 07-plot.png.</a:t>
             </a:r>
           </a:p>
           <a:p xmlns:a="http://schemas.openxmlformats.org/drawingml/2006/main">
@@ -1926,6 +2057,16 @@
           <a:p xmlns:a="http://schemas.openxmlformats.org/drawingml/2006/main">
             <a:r>
               <a:t>- labs/lab05/project/scripts/02_parameter_scan.jl — параметрическое исследование.</a:t>
+            </a:r>
+          </a:p>
+          <a:p xmlns:a="http://schemas.openxmlformats.org/drawingml/2006/main">
+            <a:r>
+              <a:t>- labs/lab05/project/scripts/03_marking_animation.jl — анимационный опыт.</a:t>
+            </a:r>
+          </a:p>
+          <a:p xmlns:a="http://schemas.openxmlformats.org/drawingml/2006/main">
+            <a:r>
+              <a:t>- labs/lab05/project/scripts/04_comparative_report.jl — анализ сохранённых CSV.</a:t>
             </a:r>
           </a:p>
           <a:p xmlns:a="http://schemas.openxmlformats.org/drawingml/2006/main">
@@ -2005,7 +2146,7 @@
           <a:lstStyle xmlns:a="http://schemas.openxmlformats.org/drawingml/2006/main"/>
           <a:p xmlns:a="http://schemas.openxmlformats.org/drawingml/2006/main">
             <a:r>
-              <a:t>Лабораторная работа № 5. Численные результаты относятся к горизонту 50 и фиксированным начальным состояниям генератора. Доля блокировок — наблюдаемая частота в выполненной серии. Иллюстрации: 03-terminal.png.</a:t>
+              <a:t>Лабораторная работа № 5. Горизонт базового и параметрического экспериментов — 50; анимационного — 30. Использованы фиксированные начальные состояния генератора. Доля блокировок — наблюдаемая частота в выполненной серии. Иллюстрации: 01-jupyter.png, 02-jupyter.png.</a:t>
             </a:r>
           </a:p>
           <a:p xmlns:a="http://schemas.openxmlformats.org/drawingml/2006/main">
@@ -2036,6 +2177,16 @@
           <a:p xmlns:a="http://schemas.openxmlformats.org/drawingml/2006/main">
             <a:r>
               <a:t>- labs/lab05/project/scripts/02_parameter_scan.jl — параметрическое исследование.</a:t>
+            </a:r>
+          </a:p>
+          <a:p xmlns:a="http://schemas.openxmlformats.org/drawingml/2006/main">
+            <a:r>
+              <a:t>- labs/lab05/project/scripts/03_marking_animation.jl — анимационный опыт.</a:t>
+            </a:r>
+          </a:p>
+          <a:p xmlns:a="http://schemas.openxmlformats.org/drawingml/2006/main">
+            <a:r>
+              <a:t>- labs/lab05/project/scripts/04_comparative_report.jl — анализ сохранённых CSV.</a:t>
             </a:r>
           </a:p>
           <a:p xmlns:a="http://schemas.openxmlformats.org/drawingml/2006/main">
@@ -2115,7 +2266,7 @@
           <a:lstStyle xmlns:a="http://schemas.openxmlformats.org/drawingml/2006/main"/>
           <a:p xmlns:a="http://schemas.openxmlformats.org/drawingml/2006/main">
             <a:r>
-              <a:t>Лабораторная работа № 5. Численные результаты относятся к горизонту 50 и фиксированным начальным состояниям генератора. Доля блокировок — наблюдаемая частота в выполненной серии. </a:t>
+              <a:t>Лабораторная работа № 5. Горизонт базового и параметрического экспериментов — 50; анимационного — 30. Использованы фиксированные начальные состояния генератора. Доля блокировок — наблюдаемая частота в выполненной серии. Иллюстрации: 03-terminal.png.</a:t>
             </a:r>
           </a:p>
           <a:p xmlns:a="http://schemas.openxmlformats.org/drawingml/2006/main">
@@ -2146,6 +2297,16 @@
           <a:p xmlns:a="http://schemas.openxmlformats.org/drawingml/2006/main">
             <a:r>
               <a:t>- labs/lab05/project/scripts/02_parameter_scan.jl — параметрическое исследование.</a:t>
+            </a:r>
+          </a:p>
+          <a:p xmlns:a="http://schemas.openxmlformats.org/drawingml/2006/main">
+            <a:r>
+              <a:t>- labs/lab05/project/scripts/03_marking_animation.jl — анимационный опыт.</a:t>
+            </a:r>
+          </a:p>
+          <a:p xmlns:a="http://schemas.openxmlformats.org/drawingml/2006/main">
+            <a:r>
+              <a:t>- labs/lab05/project/scripts/04_comparative_report.jl — анализ сохранённых CSV.</a:t>
             </a:r>
           </a:p>
           <a:p xmlns:a="http://schemas.openxmlformats.org/drawingml/2006/main">
@@ -2225,7 +2386,7 @@
           <a:lstStyle xmlns:a="http://schemas.openxmlformats.org/drawingml/2006/main"/>
           <a:p xmlns:a="http://schemas.openxmlformats.org/drawingml/2006/main">
             <a:r>
-              <a:t>Лабораторная работа № 5. Численные результаты относятся к горизонту 50 и фиксированным начальным состояниям генератора. Доля блокировок — наблюдаемая частота в выполненной серии. </a:t>
+              <a:t>Лабораторная работа № 5. Горизонт базового и параметрического экспериментов — 50; анимационного — 30. Использованы фиксированные начальные состояния генератора. Доля блокировок — наблюдаемая частота в выполненной серии. </a:t>
             </a:r>
           </a:p>
           <a:p xmlns:a="http://schemas.openxmlformats.org/drawingml/2006/main">
@@ -2256,6 +2417,136 @@
           <a:p xmlns:a="http://schemas.openxmlformats.org/drawingml/2006/main">
             <a:r>
               <a:t>- labs/lab05/project/scripts/02_parameter_scan.jl — параметрическое исследование.</a:t>
+            </a:r>
+          </a:p>
+          <a:p xmlns:a="http://schemas.openxmlformats.org/drawingml/2006/main">
+            <a:r>
+              <a:t>- labs/lab05/project/scripts/03_marking_animation.jl — анимационный опыт.</a:t>
+            </a:r>
+          </a:p>
+          <a:p xmlns:a="http://schemas.openxmlformats.org/drawingml/2006/main">
+            <a:r>
+              <a:t>- labs/lab05/project/scripts/04_comparative_report.jl — анализ сохранённых CSV.</a:t>
+            </a:r>
+          </a:p>
+          <a:p xmlns:a="http://schemas.openxmlformats.org/drawingml/2006/main">
+            <a:r>
+              <a:t>- labs/lab05/project/data — результаты вычислений.</a:t>
+            </a:r>
+          </a:p>
+          <a:p xmlns:a="http://schemas.openxmlformats.org/drawingml/2006/main">
+            <a:r>
+              <a:t>[/Sources]</a:t>
+            </a:r>
+          </a:p>
+        </p:txBody>
+      </p:sp>
+      <p:sp>
+        <p:nvSpPr>
+          <p:cNvPr id="4" name="Slide Number Placeholder 3"/>
+          <p:cNvSpPr>
+            <a:spLocks xmlns:a="http://schemas.openxmlformats.org/drawingml/2006/main" noGrp="1"/>
+          </p:cNvSpPr>
+          <p:nvPr>
+            <p:ph type="sldNum" idx="5"/>
+          </p:nvPr>
+        </p:nvSpPr>
+        <p:spPr/>
+        <p:txBody>
+          <a:bodyPr xmlns:a="http://schemas.openxmlformats.org/drawingml/2006/main"/>
+          <a:lstStyle xmlns:a="http://schemas.openxmlformats.org/drawingml/2006/main"/>
+          <a:p xmlns:a="http://schemas.openxmlformats.org/drawingml/2006/main"/>
+        </p:txBody>
+      </p:sp>
+    </p:spTree>
+  </p:cSld>
+  <p:clrMapOvr>
+    <a:masterClrMapping xmlns:a="http://schemas.openxmlformats.org/drawingml/2006/main"/>
+  </p:clrMapOvr>
+</p:notes>
+</file>
+
+<file path=ppt/notesSlides/notesSlide25.xml><?xml version="1.0" encoding="utf-8"?>
+<p:notes xmlns:p="http://schemas.openxmlformats.org/presentationml/2006/main">
+  <p:cSld>
+    <p:spTree>
+      <p:nvGrpSpPr>
+        <p:cNvPr id="1" name=""/>
+        <p:cNvGrpSpPr/>
+        <p:nvPr/>
+      </p:nvGrpSpPr>
+      <p:grpSpPr>
+        <a:xfrm xmlns:a="http://schemas.openxmlformats.org/drawingml/2006/main"/>
+      </p:grpSpPr>
+      <p:sp>
+        <p:nvSpPr>
+          <p:cNvPr id="2" name="Slide Image Placeholder 1"/>
+          <p:cNvSpPr>
+            <a:spLocks xmlns:a="http://schemas.openxmlformats.org/drawingml/2006/main" noGrp="1"/>
+          </p:cNvSpPr>
+          <p:nvPr>
+            <p:ph type="sldImg" idx="0"/>
+          </p:nvPr>
+        </p:nvSpPr>
+        <p:spPr/>
+      </p:sp>
+      <p:sp>
+        <p:nvSpPr>
+          <p:cNvPr id="3" name="Notes Placeholder 2"/>
+          <p:cNvSpPr>
+            <a:spLocks xmlns:a="http://schemas.openxmlformats.org/drawingml/2006/main" noGrp="1"/>
+          </p:cNvSpPr>
+          <p:nvPr>
+            <p:ph type="body" idx="1"/>
+          </p:nvPr>
+        </p:nvSpPr>
+        <p:spPr/>
+        <p:txBody>
+          <a:bodyPr xmlns:a="http://schemas.openxmlformats.org/drawingml/2006/main"/>
+          <a:lstStyle xmlns:a="http://schemas.openxmlformats.org/drawingml/2006/main"/>
+          <a:p xmlns:a="http://schemas.openxmlformats.org/drawingml/2006/main">
+            <a:r>
+              <a:t>Лабораторная работа № 5. Горизонт базового и параметрического экспериментов — 50; анимационного — 30. Использованы фиксированные начальные состояния генератора. Доля блокировок — наблюдаемая частота в выполненной серии. </a:t>
+            </a:r>
+          </a:p>
+          <a:p xmlns:a="http://schemas.openxmlformats.org/drawingml/2006/main">
+            <a:r>
+              <a:t/>
+            </a:r>
+          </a:p>
+          <a:p xmlns:a="http://schemas.openxmlformats.org/drawingml/2006/main">
+            <a:r>
+              <a:t>[Sources]</a:t>
+            </a:r>
+          </a:p>
+          <a:p xmlns:a="http://schemas.openxmlformats.org/drawingml/2006/main">
+            <a:r>
+              <a:t>- simulation-modeling-lab.pdf — глава «Аппарат сетей Петри».</a:t>
+            </a:r>
+          </a:p>
+          <a:p xmlns:a="http://schemas.openxmlformats.org/drawingml/2006/main">
+            <a:r>
+              <a:t>- labs/lab05/project/src/dining_philosophers.jl — модель и алгоритмы.</a:t>
+            </a:r>
+          </a:p>
+          <a:p xmlns:a="http://schemas.openxmlformats.org/drawingml/2006/main">
+            <a:r>
+              <a:t>- labs/lab05/project/scripts/01_dining_philosophers.jl — базовый эксперимент.</a:t>
+            </a:r>
+          </a:p>
+          <a:p xmlns:a="http://schemas.openxmlformats.org/drawingml/2006/main">
+            <a:r>
+              <a:t>- labs/lab05/project/scripts/02_parameter_scan.jl — параметрическое исследование.</a:t>
+            </a:r>
+          </a:p>
+          <a:p xmlns:a="http://schemas.openxmlformats.org/drawingml/2006/main">
+            <a:r>
+              <a:t>- labs/lab05/project/scripts/03_marking_animation.jl — анимационный опыт.</a:t>
+            </a:r>
+          </a:p>
+          <a:p xmlns:a="http://schemas.openxmlformats.org/drawingml/2006/main">
+            <a:r>
+              <a:t>- labs/lab05/project/scripts/04_comparative_report.jl — анализ сохранённых CSV.</a:t>
             </a:r>
           </a:p>
           <a:p xmlns:a="http://schemas.openxmlformats.org/drawingml/2006/main">
@@ -2335,7 +2626,7 @@
           <a:lstStyle xmlns:a="http://schemas.openxmlformats.org/drawingml/2006/main"/>
           <a:p xmlns:a="http://schemas.openxmlformats.org/drawingml/2006/main">
             <a:r>
-              <a:t>Лабораторная работа № 5. Численные результаты относятся к горизонту 50 и фиксированным начальным состояниям генератора. Доля блокировок — наблюдаемая частота в выполненной серии. </a:t>
+              <a:t>Лабораторная работа № 5. Горизонт базового и параметрического экспериментов — 50; анимационного — 30. Использованы фиксированные начальные состояния генератора. Доля блокировок — наблюдаемая частота в выполненной серии. </a:t>
             </a:r>
           </a:p>
           <a:p xmlns:a="http://schemas.openxmlformats.org/drawingml/2006/main">
@@ -2366,6 +2657,16 @@
           <a:p xmlns:a="http://schemas.openxmlformats.org/drawingml/2006/main">
             <a:r>
               <a:t>- labs/lab05/project/scripts/02_parameter_scan.jl — параметрическое исследование.</a:t>
+            </a:r>
+          </a:p>
+          <a:p xmlns:a="http://schemas.openxmlformats.org/drawingml/2006/main">
+            <a:r>
+              <a:t>- labs/lab05/project/scripts/03_marking_animation.jl — анимационный опыт.</a:t>
+            </a:r>
+          </a:p>
+          <a:p xmlns:a="http://schemas.openxmlformats.org/drawingml/2006/main">
+            <a:r>
+              <a:t>- labs/lab05/project/scripts/04_comparative_report.jl — анализ сохранённых CSV.</a:t>
             </a:r>
           </a:p>
           <a:p xmlns:a="http://schemas.openxmlformats.org/drawingml/2006/main">
@@ -2445,7 +2746,7 @@
           <a:lstStyle xmlns:a="http://schemas.openxmlformats.org/drawingml/2006/main"/>
           <a:p xmlns:a="http://schemas.openxmlformats.org/drawingml/2006/main">
             <a:r>
-              <a:t>Лабораторная работа № 5. Численные результаты относятся к горизонту 50 и фиксированным начальным состояниям генератора. Доля блокировок — наблюдаемая частота в выполненной серии. </a:t>
+              <a:t>Лабораторная работа № 5. Горизонт базового и параметрического экспериментов — 50; анимационного — 30. Использованы фиксированные начальные состояния генератора. Доля блокировок — наблюдаемая частота в выполненной серии. </a:t>
             </a:r>
           </a:p>
           <a:p xmlns:a="http://schemas.openxmlformats.org/drawingml/2006/main">
@@ -2476,6 +2777,16 @@
           <a:p xmlns:a="http://schemas.openxmlformats.org/drawingml/2006/main">
             <a:r>
               <a:t>- labs/lab05/project/scripts/02_parameter_scan.jl — параметрическое исследование.</a:t>
+            </a:r>
+          </a:p>
+          <a:p xmlns:a="http://schemas.openxmlformats.org/drawingml/2006/main">
+            <a:r>
+              <a:t>- labs/lab05/project/scripts/03_marking_animation.jl — анимационный опыт.</a:t>
+            </a:r>
+          </a:p>
+          <a:p xmlns:a="http://schemas.openxmlformats.org/drawingml/2006/main">
+            <a:r>
+              <a:t>- labs/lab05/project/scripts/04_comparative_report.jl — анализ сохранённых CSV.</a:t>
             </a:r>
           </a:p>
           <a:p xmlns:a="http://schemas.openxmlformats.org/drawingml/2006/main">
@@ -2555,7 +2866,7 @@
           <a:lstStyle xmlns:a="http://schemas.openxmlformats.org/drawingml/2006/main"/>
           <a:p xmlns:a="http://schemas.openxmlformats.org/drawingml/2006/main">
             <a:r>
-              <a:t>Лабораторная работа № 5. Численные результаты относятся к горизонту 50 и фиксированным начальным состояниям генератора. Доля блокировок — наблюдаемая частота в выполненной серии. </a:t>
+              <a:t>Лабораторная работа № 5. Горизонт базового и параметрического экспериментов — 50; анимационного — 30. Использованы фиксированные начальные состояния генератора. Доля блокировок — наблюдаемая частота в выполненной серии. </a:t>
             </a:r>
           </a:p>
           <a:p xmlns:a="http://schemas.openxmlformats.org/drawingml/2006/main">
@@ -2586,6 +2897,16 @@
           <a:p xmlns:a="http://schemas.openxmlformats.org/drawingml/2006/main">
             <a:r>
               <a:t>- labs/lab05/project/scripts/02_parameter_scan.jl — параметрическое исследование.</a:t>
+            </a:r>
+          </a:p>
+          <a:p xmlns:a="http://schemas.openxmlformats.org/drawingml/2006/main">
+            <a:r>
+              <a:t>- labs/lab05/project/scripts/03_marking_animation.jl — анимационный опыт.</a:t>
+            </a:r>
+          </a:p>
+          <a:p xmlns:a="http://schemas.openxmlformats.org/drawingml/2006/main">
+            <a:r>
+              <a:t>- labs/lab05/project/scripts/04_comparative_report.jl — анализ сохранённых CSV.</a:t>
             </a:r>
           </a:p>
           <a:p xmlns:a="http://schemas.openxmlformats.org/drawingml/2006/main">
@@ -2665,7 +2986,7 @@
           <a:lstStyle xmlns:a="http://schemas.openxmlformats.org/drawingml/2006/main"/>
           <a:p xmlns:a="http://schemas.openxmlformats.org/drawingml/2006/main">
             <a:r>
-              <a:t>Лабораторная работа № 5. Численные результаты относятся к горизонту 50 и фиксированным начальным состояниям генератора. Доля блокировок — наблюдаемая частота в выполненной серии. </a:t>
+              <a:t>Лабораторная работа № 5. Горизонт базового и параметрического экспериментов — 50; анимационного — 30. Использованы фиксированные начальные состояния генератора. Доля блокировок — наблюдаемая частота в выполненной серии. </a:t>
             </a:r>
           </a:p>
           <a:p xmlns:a="http://schemas.openxmlformats.org/drawingml/2006/main">
@@ -2696,6 +3017,16 @@
           <a:p xmlns:a="http://schemas.openxmlformats.org/drawingml/2006/main">
             <a:r>
               <a:t>- labs/lab05/project/scripts/02_parameter_scan.jl — параметрическое исследование.</a:t>
+            </a:r>
+          </a:p>
+          <a:p xmlns:a="http://schemas.openxmlformats.org/drawingml/2006/main">
+            <a:r>
+              <a:t>- labs/lab05/project/scripts/03_marking_animation.jl — анимационный опыт.</a:t>
+            </a:r>
+          </a:p>
+          <a:p xmlns:a="http://schemas.openxmlformats.org/drawingml/2006/main">
+            <a:r>
+              <a:t>- labs/lab05/project/scripts/04_comparative_report.jl — анализ сохранённых CSV.</a:t>
             </a:r>
           </a:p>
           <a:p xmlns:a="http://schemas.openxmlformats.org/drawingml/2006/main">
@@ -2775,7 +3106,7 @@
           <a:lstStyle xmlns:a="http://schemas.openxmlformats.org/drawingml/2006/main"/>
           <a:p xmlns:a="http://schemas.openxmlformats.org/drawingml/2006/main">
             <a:r>
-              <a:t>Лабораторная работа № 5. Численные результаты относятся к горизонту 50 и фиксированным начальным состояниям генератора. Доля блокировок — наблюдаемая частота в выполненной серии. </a:t>
+              <a:t>Лабораторная работа № 5. Горизонт базового и параметрического экспериментов — 50; анимационного — 30. Использованы фиксированные начальные состояния генератора. Доля блокировок — наблюдаемая частота в выполненной серии. </a:t>
             </a:r>
           </a:p>
           <a:p xmlns:a="http://schemas.openxmlformats.org/drawingml/2006/main">
@@ -2806,6 +3137,16 @@
           <a:p xmlns:a="http://schemas.openxmlformats.org/drawingml/2006/main">
             <a:r>
               <a:t>- labs/lab05/project/scripts/02_parameter_scan.jl — параметрическое исследование.</a:t>
+            </a:r>
+          </a:p>
+          <a:p xmlns:a="http://schemas.openxmlformats.org/drawingml/2006/main">
+            <a:r>
+              <a:t>- labs/lab05/project/scripts/03_marking_animation.jl — анимационный опыт.</a:t>
+            </a:r>
+          </a:p>
+          <a:p xmlns:a="http://schemas.openxmlformats.org/drawingml/2006/main">
+            <a:r>
+              <a:t>- labs/lab05/project/scripts/04_comparative_report.jl — анализ сохранённых CSV.</a:t>
             </a:r>
           </a:p>
           <a:p xmlns:a="http://schemas.openxmlformats.org/drawingml/2006/main">
@@ -2885,7 +3226,7 @@
           <a:lstStyle xmlns:a="http://schemas.openxmlformats.org/drawingml/2006/main"/>
           <a:p xmlns:a="http://schemas.openxmlformats.org/drawingml/2006/main">
             <a:r>
-              <a:t>Лабораторная работа № 5. Численные результаты относятся к горизонту 50 и фиксированным начальным состояниям генератора. Доля блокировок — наблюдаемая частота в выполненной серии. </a:t>
+              <a:t>Лабораторная работа № 5. Горизонт базового и параметрического экспериментов — 50; анимационного — 30. Использованы фиксированные начальные состояния генератора. Доля блокировок — наблюдаемая частота в выполненной серии. </a:t>
             </a:r>
           </a:p>
           <a:p xmlns:a="http://schemas.openxmlformats.org/drawingml/2006/main">
@@ -2916,6 +3257,16 @@
           <a:p xmlns:a="http://schemas.openxmlformats.org/drawingml/2006/main">
             <a:r>
               <a:t>- labs/lab05/project/scripts/02_parameter_scan.jl — параметрическое исследование.</a:t>
+            </a:r>
+          </a:p>
+          <a:p xmlns:a="http://schemas.openxmlformats.org/drawingml/2006/main">
+            <a:r>
+              <a:t>- labs/lab05/project/scripts/03_marking_animation.jl — анимационный опыт.</a:t>
+            </a:r>
+          </a:p>
+          <a:p xmlns:a="http://schemas.openxmlformats.org/drawingml/2006/main">
+            <a:r>
+              <a:t>- labs/lab05/project/scripts/04_comparative_report.jl — анализ сохранённых CSV.</a:t>
             </a:r>
           </a:p>
           <a:p xmlns:a="http://schemas.openxmlformats.org/drawingml/2006/main">
@@ -2995,7 +3346,7 @@
           <a:lstStyle xmlns:a="http://schemas.openxmlformats.org/drawingml/2006/main"/>
           <a:p xmlns:a="http://schemas.openxmlformats.org/drawingml/2006/main">
             <a:r>
-              <a:t>Лабораторная работа № 5. Численные результаты относятся к горизонту 50 и фиксированным начальным состояниям генератора. Доля блокировок — наблюдаемая частота в выполненной серии. Иллюстрации: 05-plot.png.</a:t>
+              <a:t>Лабораторная работа № 5. Горизонт базового и параметрического экспериментов — 50; анимационного — 30. Использованы фиксированные начальные состояния генератора. Доля блокировок — наблюдаемая частота в выполненной серии. Иллюстрации: 05-plot.png.</a:t>
             </a:r>
           </a:p>
           <a:p xmlns:a="http://schemas.openxmlformats.org/drawingml/2006/main">
@@ -3026,6 +3377,16 @@
           <a:p xmlns:a="http://schemas.openxmlformats.org/drawingml/2006/main">
             <a:r>
               <a:t>- labs/lab05/project/scripts/02_parameter_scan.jl — параметрическое исследование.</a:t>
+            </a:r>
+          </a:p>
+          <a:p xmlns:a="http://schemas.openxmlformats.org/drawingml/2006/main">
+            <a:r>
+              <a:t>- labs/lab05/project/scripts/03_marking_animation.jl — анимационный опыт.</a:t>
+            </a:r>
+          </a:p>
+          <a:p xmlns:a="http://schemas.openxmlformats.org/drawingml/2006/main">
+            <a:r>
+              <a:t>- labs/lab05/project/scripts/04_comparative_report.jl — анализ сохранённых CSV.</a:t>
             </a:r>
           </a:p>
           <a:p xmlns:a="http://schemas.openxmlformats.org/drawingml/2006/main">
@@ -3103,7 +3464,7 @@
   </p:cSld>
   <p:clrMap bg1="lt1" tx1="dk1" bg2="lt2" tx2="dk2" accent1="accent1" accent2="accent2" accent3="accent3" accent4="accent4" accent5="accent5" accent6="accent6" hlink="hlink" folHlink="folHlink"/>
   <p:sldLayoutIdLst>
-    <p:sldLayoutId xmlns:r="http://schemas.openxmlformats.org/officeDocument/2006/relationships" id="2147483649" r:id="Rae6c41bfe1ed4dc3"/>
+    <p:sldLayoutId xmlns:r="http://schemas.openxmlformats.org/officeDocument/2006/relationships" id="2147483649" r:id="R5fc6ef62f30942d7"/>
   </p:sldLayoutIdLst>
   <p:txStyles>
     <p:titleStyle>
@@ -3720,7 +4081,7 @@
           <p:nvPr/>
         </p:nvPicPr>
         <p:blipFill>
-          <a:blip xmlns:r="http://schemas.openxmlformats.org/officeDocument/2006/relationships" xmlns:a="http://schemas.openxmlformats.org/drawingml/2006/main" r:embed="R74c76afb7a8b4009"/>
+          <a:blip xmlns:r="http://schemas.openxmlformats.org/officeDocument/2006/relationships" xmlns:a="http://schemas.openxmlformats.org/drawingml/2006/main" r:embed="R6ae1e0ff643f4dde"/>
           <a:stretch xmlns:a="http://schemas.openxmlformats.org/drawingml/2006/main"/>
         </p:blipFill>
         <p:spPr>
@@ -4255,7 +4616,7 @@
           <p:nvPr/>
         </p:nvPicPr>
         <p:blipFill>
-          <a:blip xmlns:r="http://schemas.openxmlformats.org/officeDocument/2006/relationships" xmlns:a="http://schemas.openxmlformats.org/drawingml/2006/main" r:embed="Rf6c106d26f234caa"/>
+          <a:blip xmlns:r="http://schemas.openxmlformats.org/officeDocument/2006/relationships" xmlns:a="http://schemas.openxmlformats.org/drawingml/2006/main" r:embed="R02d6e54b06b94178"/>
           <a:stretch xmlns:a="http://schemas.openxmlformats.org/drawingml/2006/main"/>
         </p:blipFill>
         <p:spPr>
@@ -5111,7 +5472,7 @@
                 <a:ea typeface="Calibri"/>
                 <a:cs typeface="Calibri"/>
               </a:rPr>
-              <a:t>Вычислительный конвейер связывает исходники и результаты</a:t>
+              <a:t>Четыре сценария проходят один конвейер</a:t>
             </a:r>
           </a:p>
         </p:txBody>
@@ -5156,7 +5517,7 @@
           <p:nvPr/>
         </p:nvPicPr>
         <p:blipFill>
-          <a:blip xmlns:r="http://schemas.openxmlformats.org/officeDocument/2006/relationships" xmlns:a="http://schemas.openxmlformats.org/drawingml/2006/main" r:embed="Rc9b74c183fbc4419"/>
+          <a:blip xmlns:r="http://schemas.openxmlformats.org/officeDocument/2006/relationships" xmlns:a="http://schemas.openxmlformats.org/drawingml/2006/main" r:embed="R7ca3b5d59cea4284"/>
           <a:stretch xmlns:a="http://schemas.openxmlformats.org/drawingml/2006/main"/>
         </p:blipFill>
         <p:spPr>
@@ -5292,7 +5653,7 @@
           <p:nvPr/>
         </p:nvPicPr>
         <p:blipFill>
-          <a:blip xmlns:r="http://schemas.openxmlformats.org/officeDocument/2006/relationships" xmlns:a="http://schemas.openxmlformats.org/drawingml/2006/main" r:embed="Rfeaa4c96a3154fef"/>
+          <a:blip xmlns:r="http://schemas.openxmlformats.org/officeDocument/2006/relationships" xmlns:a="http://schemas.openxmlformats.org/drawingml/2006/main" r:embed="Rce64cbcbf2464bf1"/>
           <a:stretch xmlns:a="http://schemas.openxmlformats.org/drawingml/2006/main"/>
         </p:blipFill>
         <p:spPr>
@@ -5414,11 +5775,95 @@
                 <a:ea typeface="Calibri"/>
                 <a:cs typeface="Calibri"/>
               </a:rPr>
-              <a:t>Julia 1.11.9</a:t>
-            </a:r>
-          </a:p>
-          <a:p xmlns:a="http://schemas.openxmlformats.org/drawingml/2006/main">
-            <a:r>
+              <a:t>Базовая модель</a:t>
+            </a:r>
+          </a:p>
+          <a:p xmlns:a="http://schemas.openxmlformats.org/drawingml/2006/main">
+            <a:pPr algn="l">
+              <a:defRPr sz="1650">
+                <a:solidFill>
+                  <a:srgbClr val="17232D"/>
+                </a:solidFill>
+                <a:latin typeface="Calibri"/>
+                <a:ea typeface="Calibri"/>
+                <a:cs typeface="Calibri"/>
+              </a:defRPr>
+            </a:pPr>
+            <a:r>
+              <a:rPr sz="1650">
+                <a:solidFill>
+                  <a:srgbClr val="17232D"/>
+                </a:solidFill>
+                <a:latin typeface="Calibri"/>
+                <a:ea typeface="Calibri"/>
+                <a:cs typeface="Calibri"/>
+              </a:rPr>
+              <a:t>Серия параметров</a:t>
+            </a:r>
+          </a:p>
+          <a:p xmlns:a="http://schemas.openxmlformats.org/drawingml/2006/main">
+            <a:pPr algn="l">
+              <a:buNone/>
+              <a:defRPr sz="1650" b="0">
+                <a:solidFill>
+                  <a:srgbClr val="17232D"/>
+                </a:solidFill>
+                <a:latin typeface="Calibri"/>
+                <a:ea typeface="Calibri"/>
+                <a:cs typeface="Calibri"/>
+              </a:defRPr>
+            </a:pPr>
+            <a:r>
+              <a:rPr sz="1650" b="0">
+                <a:solidFill>
+                  <a:srgbClr val="17232D"/>
+                </a:solidFill>
+                <a:latin typeface="Calibri"/>
+                <a:ea typeface="Calibri"/>
+                <a:cs typeface="Calibri"/>
+              </a:rPr>
+              <a:t>Анимация маркировки</a:t>
+            </a:r>
+          </a:p>
+          <a:p xmlns:a="http://schemas.openxmlformats.org/drawingml/2006/main">
+            <a:pPr algn="l">
+              <a:buNone/>
+              <a:defRPr sz="1650" b="0">
+                <a:solidFill>
+                  <a:srgbClr val="17232D"/>
+                </a:solidFill>
+                <a:latin typeface="Calibri"/>
+                <a:ea typeface="Calibri"/>
+                <a:cs typeface="Calibri"/>
+              </a:defRPr>
+            </a:pPr>
+            <a:r>
+              <a:rPr sz="1650" b="0">
+                <a:solidFill>
+                  <a:srgbClr val="17232D"/>
+                </a:solidFill>
+                <a:latin typeface="Calibri"/>
+                <a:ea typeface="Calibri"/>
+                <a:cs typeface="Calibri"/>
+              </a:rPr>
+              <a:t>Анализ сохранённых CSV</a:t>
+            </a:r>
+          </a:p>
+          <a:p xmlns:a="http://schemas.openxmlformats.org/drawingml/2006/main">
+            <a:pPr algn="l">
+              <a:buNone/>
+              <a:defRPr sz="1650" b="0">
+                <a:solidFill>
+                  <a:srgbClr val="17232D"/>
+                </a:solidFill>
+              </a:defRPr>
+            </a:pPr>
+            <a:r>
+              <a:rPr sz="1650" b="0">
+                <a:solidFill>
+                  <a:srgbClr val="17232D"/>
+                </a:solidFill>
+              </a:rPr>
               <a:t/>
             </a:r>
           </a:p>
@@ -5443,13 +5888,12 @@
                 <a:ea typeface="Calibri"/>
                 <a:cs typeface="Calibri"/>
               </a:rPr>
-              <a:t>DifferentialEquations.jl</a:t>
-            </a:r>
-          </a:p>
-          <a:p xmlns:a="http://schemas.openxmlformats.org/drawingml/2006/main">
-            <a:pPr algn="l">
-              <a:buNone/>
-              <a:defRPr sz="1650" b="0">
+              <a:t>4 выполненных блокнота</a:t>
+            </a:r>
+          </a:p>
+          <a:p xmlns:a="http://schemas.openxmlformats.org/drawingml/2006/main">
+            <a:pPr algn="l">
+              <a:defRPr sz="1650">
                 <a:solidFill>
                   <a:srgbClr val="17232D"/>
                 </a:solidFill>
@@ -5459,7 +5903,7 @@
               </a:defRPr>
             </a:pPr>
             <a:r>
-              <a:rPr sz="1650" b="0">
+              <a:rPr sz="1650">
                 <a:solidFill>
                   <a:srgbClr val="17232D"/>
                 </a:solidFill>
@@ -5467,84 +5911,7 @@
                 <a:ea typeface="Calibri"/>
                 <a:cs typeface="Calibri"/>
               </a:rPr>
-              <a:t>DataFrames.jl и CSV.jl</a:t>
-            </a:r>
-          </a:p>
-          <a:p xmlns:a="http://schemas.openxmlformats.org/drawingml/2006/main">
-            <a:pPr algn="l">
-              <a:buNone/>
-              <a:defRPr sz="1650" b="0">
-                <a:solidFill>
-                  <a:srgbClr val="17232D"/>
-                </a:solidFill>
-                <a:latin typeface="Calibri"/>
-                <a:ea typeface="Calibri"/>
-                <a:cs typeface="Calibri"/>
-              </a:defRPr>
-            </a:pPr>
-            <a:r>
-              <a:rPr sz="1650" b="0">
-                <a:solidFill>
-                  <a:srgbClr val="17232D"/>
-                </a:solidFill>
-                <a:latin typeface="Calibri"/>
-                <a:ea typeface="Calibri"/>
-                <a:cs typeface="Calibri"/>
-              </a:rPr>
-              <a:t>Plots.jl</a:t>
-            </a:r>
-          </a:p>
-          <a:p xmlns:a="http://schemas.openxmlformats.org/drawingml/2006/main">
-            <a:pPr algn="l">
-              <a:buNone/>
-              <a:defRPr sz="1650" b="0">
-                <a:solidFill>
-                  <a:srgbClr val="17232D"/>
-                </a:solidFill>
-                <a:latin typeface="Calibri"/>
-                <a:ea typeface="Calibri"/>
-                <a:cs typeface="Calibri"/>
-              </a:defRPr>
-            </a:pPr>
-            <a:r>
-              <a:rPr sz="1650" b="0">
-                <a:solidFill>
-                  <a:srgbClr val="17232D"/>
-                </a:solidFill>
-                <a:latin typeface="Calibri"/>
-                <a:ea typeface="Calibri"/>
-                <a:cs typeface="Calibri"/>
-              </a:rPr>
-              <a:t>IJulia</a:t>
-            </a:r>
-          </a:p>
-          <a:p xmlns:a="http://schemas.openxmlformats.org/drawingml/2006/main">
-            <a:r>
-              <a:t/>
-            </a:r>
-          </a:p>
-          <a:p xmlns:a="http://schemas.openxmlformats.org/drawingml/2006/main">
-            <a:pPr algn="l">
-              <a:buNone/>
-              <a:defRPr sz="1650" b="0">
-                <a:solidFill>
-                  <a:srgbClr val="17232D"/>
-                </a:solidFill>
-                <a:latin typeface="Calibri"/>
-                <a:ea typeface="Calibri"/>
-                <a:cs typeface="Calibri"/>
-              </a:defRPr>
-            </a:pPr>
-            <a:r>
-              <a:rPr sz="1650" b="0">
-                <a:solidFill>
-                  <a:srgbClr val="17232D"/>
-                </a:solidFill>
-                <a:latin typeface="Calibri"/>
-                <a:ea typeface="Calibri"/>
-                <a:cs typeface="Calibri"/>
-              </a:rPr>
-              <a:t>23 автоматических теста.</a:t>
+              <a:t>56 проверок.</a:t>
             </a:r>
           </a:p>
         </p:txBody>
@@ -5618,7 +5985,7 @@
           <p:nvPr/>
         </p:nvPicPr>
         <p:blipFill>
-          <a:blip xmlns:r="http://schemas.openxmlformats.org/officeDocument/2006/relationships" xmlns:a="http://schemas.openxmlformats.org/drawingml/2006/main" r:embed="R3aa691d686d744b2"/>
+          <a:blip xmlns:r="http://schemas.openxmlformats.org/officeDocument/2006/relationships" xmlns:a="http://schemas.openxmlformats.org/drawingml/2006/main" r:embed="R89896da4f48541a3"/>
           <a:stretch xmlns:a="http://schemas.openxmlformats.org/drawingml/2006/main"/>
         </p:blipFill>
         <p:spPr>
@@ -6079,7 +6446,7 @@
           <p:nvPr/>
         </p:nvPicPr>
         <p:blipFill>
-          <a:blip xmlns:r="http://schemas.openxmlformats.org/officeDocument/2006/relationships" xmlns:a="http://schemas.openxmlformats.org/drawingml/2006/main" r:embed="Rd8ad8bb55a224afa"/>
+          <a:blip xmlns:r="http://schemas.openxmlformats.org/officeDocument/2006/relationships" xmlns:a="http://schemas.openxmlformats.org/drawingml/2006/main" r:embed="R567fd9802bf94e97"/>
           <a:stretch xmlns:a="http://schemas.openxmlformats.org/drawingml/2006/main"/>
         </p:blipFill>
         <p:spPr>
@@ -6684,7 +7051,7 @@
           <p:nvPr/>
         </p:nvPicPr>
         <p:blipFill>
-          <a:blip xmlns:r="http://schemas.openxmlformats.org/officeDocument/2006/relationships" xmlns:a="http://schemas.openxmlformats.org/drawingml/2006/main" r:embed="Rd0525358ec124954"/>
+          <a:blip xmlns:r="http://schemas.openxmlformats.org/officeDocument/2006/relationships" xmlns:a="http://schemas.openxmlformats.org/drawingml/2006/main" r:embed="Rcb39ce136a864250"/>
           <a:stretch xmlns:a="http://schemas.openxmlformats.org/drawingml/2006/main"/>
         </p:blipFill>
         <p:spPr>
@@ -6820,13 +7187,13 @@
           <p:nvPr/>
         </p:nvPicPr>
         <p:blipFill>
-          <a:blip xmlns:r="http://schemas.openxmlformats.org/officeDocument/2006/relationships" xmlns:a="http://schemas.openxmlformats.org/drawingml/2006/main" r:embed="R9648903fef4a4f4a"/>
+          <a:blip xmlns:r="http://schemas.openxmlformats.org/officeDocument/2006/relationships" xmlns:a="http://schemas.openxmlformats.org/drawingml/2006/main" r:embed="R9bc8eda820814b87"/>
           <a:stretch xmlns:a="http://schemas.openxmlformats.org/drawingml/2006/main"/>
         </p:blipFill>
         <p:spPr>
           <a:xfrm xmlns:a="http://schemas.openxmlformats.org/drawingml/2006/main">
-            <a:off x="495300" y="1105853"/>
-            <a:ext cx="7524750" cy="4665345"/>
+            <a:off x="629073" y="1105853"/>
+            <a:ext cx="7257203" cy="4665345"/>
           </a:xfrm>
           <a:prstGeom xmlns:a="http://schemas.openxmlformats.org/drawingml/2006/main" prst="rect">
             <a:avLst/>
@@ -7519,7 +7886,7 @@
           <p:nvPr/>
         </p:nvPicPr>
         <p:blipFill>
-          <a:blip xmlns:r="http://schemas.openxmlformats.org/officeDocument/2006/relationships" xmlns:a="http://schemas.openxmlformats.org/drawingml/2006/main" r:embed="R1dc4ea7781b64b58"/>
+          <a:blip xmlns:r="http://schemas.openxmlformats.org/officeDocument/2006/relationships" xmlns:a="http://schemas.openxmlformats.org/drawingml/2006/main" r:embed="R49af975156924f4a"/>
           <a:stretch xmlns:a="http://schemas.openxmlformats.org/drawingml/2006/main"/>
         </p:blipFill>
         <p:spPr>
@@ -7655,13 +8022,13 @@
           <p:nvPr/>
         </p:nvPicPr>
         <p:blipFill>
-          <a:blip xmlns:r="http://schemas.openxmlformats.org/officeDocument/2006/relationships" xmlns:a="http://schemas.openxmlformats.org/drawingml/2006/main" r:embed="Re283afa425074494"/>
+          <a:blip xmlns:r="http://schemas.openxmlformats.org/officeDocument/2006/relationships" xmlns:a="http://schemas.openxmlformats.org/drawingml/2006/main" r:embed="R31d8032b4a104d95"/>
           <a:stretch xmlns:a="http://schemas.openxmlformats.org/drawingml/2006/main"/>
         </p:blipFill>
         <p:spPr>
           <a:xfrm xmlns:a="http://schemas.openxmlformats.org/drawingml/2006/main">
-            <a:off x="495300" y="1105853"/>
-            <a:ext cx="7524750" cy="4665345"/>
+            <a:off x="629073" y="1105853"/>
+            <a:ext cx="7257203" cy="4665345"/>
           </a:xfrm>
           <a:prstGeom xmlns:a="http://schemas.openxmlformats.org/drawingml/2006/main" prst="rect">
             <a:avLst/>
@@ -8309,7 +8676,7 @@
                 <a:ea typeface="Calibri"/>
                 <a:cs typeface="Calibri"/>
               </a:rPr>
-              <a:t>Позиции Eat активируются только в рабочей сети</a:t>
+              <a:t>Отдельный сценарий анализирует сохранённые CSV</a:t>
             </a:r>
           </a:p>
         </p:txBody>
@@ -8354,7 +8721,7 @@
           <p:nvPr/>
         </p:nvPicPr>
         <p:blipFill>
-          <a:blip xmlns:r="http://schemas.openxmlformats.org/officeDocument/2006/relationships" xmlns:a="http://schemas.openxmlformats.org/drawingml/2006/main" r:embed="R73eac3cde11549bf"/>
+          <a:blip xmlns:r="http://schemas.openxmlformats.org/officeDocument/2006/relationships" xmlns:a="http://schemas.openxmlformats.org/drawingml/2006/main" r:embed="Rff3b1ae70bdb423a"/>
           <a:stretch xmlns:a="http://schemas.openxmlformats.org/drawingml/2006/main"/>
         </p:blipFill>
         <p:spPr>
@@ -8490,13 +8857,13 @@
           <p:nvPr/>
         </p:nvPicPr>
         <p:blipFill>
-          <a:blip xmlns:r="http://schemas.openxmlformats.org/officeDocument/2006/relationships" xmlns:a="http://schemas.openxmlformats.org/drawingml/2006/main" r:embed="R33d89feaa15c472c"/>
+          <a:blip xmlns:r="http://schemas.openxmlformats.org/officeDocument/2006/relationships" xmlns:a="http://schemas.openxmlformats.org/drawingml/2006/main" r:embed="Rffad513cdae64743"/>
           <a:stretch xmlns:a="http://schemas.openxmlformats.org/drawingml/2006/main"/>
         </p:blipFill>
         <p:spPr>
           <a:xfrm xmlns:a="http://schemas.openxmlformats.org/drawingml/2006/main">
-            <a:off x="1498451" y="1062228"/>
-            <a:ext cx="5613699" cy="4771644"/>
+            <a:off x="1217766" y="1062228"/>
+            <a:ext cx="6175069" cy="4771644"/>
           </a:xfrm>
           <a:prstGeom xmlns:a="http://schemas.openxmlformats.org/drawingml/2006/main" prst="rect">
             <a:avLst/>
@@ -8578,7 +8945,7 @@
                 <a:ea typeface="Calibri"/>
                 <a:cs typeface="Calibri"/>
               </a:rPr>
-              <a:t>0 приёмов пищи.</a:t>
+              <a:t>6 строк, deadlock.</a:t>
             </a:r>
           </a:p>
           <a:p xmlns:a="http://schemas.openxmlformats.org/drawingml/2006/main">
@@ -8643,12 +9010,18 @@
                 <a:ea typeface="Calibri"/>
                 <a:cs typeface="Calibri"/>
               </a:rPr>
-              <a:t>5, 10, 5, 5, 6</a:t>
-            </a:r>
-          </a:p>
-          <a:p xmlns:a="http://schemas.openxmlformats.org/drawingml/2006/main">
-            <a:pPr algn="l">
-              <a:defRPr sz="1725">
+              <a:t>99 строк, сеть активна.</a:t>
+            </a:r>
+          </a:p>
+          <a:p xmlns:a="http://schemas.openxmlformats.org/drawingml/2006/main">
+            <a:r>
+              <a:t/>
+            </a:r>
+          </a:p>
+          <a:p xmlns:a="http://schemas.openxmlformats.org/drawingml/2006/main">
+            <a:pPr algn="l">
+              <a:buNone/>
+              <a:defRPr sz="1725" b="0">
                 <a:solidFill>
                   <a:srgbClr val="17232D"/>
                 </a:solidFill>
@@ -8658,7 +9031,7 @@
               </a:defRPr>
             </a:pPr>
             <a:r>
-              <a:rPr sz="1725">
+              <a:rPr sz="1725" b="0">
                 <a:solidFill>
                   <a:srgbClr val="17232D"/>
                 </a:solidFill>
@@ -8666,7 +9039,7 @@
                 <a:ea typeface="Calibri"/>
                 <a:cs typeface="Calibri"/>
               </a:rPr>
-              <a:t>приёмов по философам.</a:t>
+              <a:t>Нового расчёта нет.</a:t>
             </a:r>
           </a:p>
         </p:txBody>
@@ -8723,7 +9096,7 @@
                 <a:ea typeface="Calibri"/>
                 <a:cs typeface="Calibri"/>
               </a:rPr>
-              <a:t>Отсутствие deadlock не означает одинаковое число приёмов пищи.</a:t>
+              <a:t>04_comparative_report.jl проверяет данные и сопоставляет Eatᵢ.</a:t>
             </a:r>
           </a:p>
         </p:txBody>
@@ -8871,7 +9244,7 @@
                 <a:ea typeface="Calibri"/>
                 <a:cs typeface="Calibri"/>
               </a:rPr>
-              <a:t>ODE дополняет дискретную траекторию</a:t>
+              <a:t>Анимация показывает образование deadlock</a:t>
             </a:r>
           </a:p>
         </p:txBody>
@@ -8916,7 +9289,7 @@
           <p:nvPr/>
         </p:nvPicPr>
         <p:blipFill>
-          <a:blip xmlns:r="http://schemas.openxmlformats.org/officeDocument/2006/relationships" xmlns:a="http://schemas.openxmlformats.org/drawingml/2006/main" r:embed="Rf3cfab885ef44d9b"/>
+          <a:blip xmlns:r="http://schemas.openxmlformats.org/officeDocument/2006/relationships" xmlns:a="http://schemas.openxmlformats.org/drawingml/2006/main" r:embed="R5fd9cf1297734dc1"/>
           <a:stretch xmlns:a="http://schemas.openxmlformats.org/drawingml/2006/main"/>
         </p:blipFill>
         <p:spPr>
@@ -9052,13 +9425,13 @@
           <p:nvPr/>
         </p:nvPicPr>
         <p:blipFill>
-          <a:blip xmlns:r="http://schemas.openxmlformats.org/officeDocument/2006/relationships" xmlns:a="http://schemas.openxmlformats.org/drawingml/2006/main" r:embed="R4607f276d484401c"/>
+          <a:blip xmlns:r="http://schemas.openxmlformats.org/officeDocument/2006/relationships" xmlns:a="http://schemas.openxmlformats.org/drawingml/2006/main" r:embed="Rb344fa0fde464f96"/>
           <a:stretch xmlns:a="http://schemas.openxmlformats.org/drawingml/2006/main"/>
         </p:blipFill>
         <p:spPr>
           <a:xfrm xmlns:a="http://schemas.openxmlformats.org/drawingml/2006/main">
-            <a:off x="1196578" y="1468636"/>
-            <a:ext cx="6369844" cy="3949303"/>
+            <a:off x="1431257" y="895350"/>
+            <a:ext cx="5900487" cy="5095875"/>
           </a:xfrm>
           <a:prstGeom xmlns:a="http://schemas.openxmlformats.org/drawingml/2006/main" prst="rect">
             <a:avLst/>
@@ -9117,11 +9490,47 @@
                 <a:ea typeface="Calibri"/>
                 <a:cs typeface="Calibri"/>
               </a:rPr>
-              <a:t>Массовое действие задаёт непрерывные потоки.</a:t>
-            </a:r>
-          </a:p>
-          <a:p xmlns:a="http://schemas.openxmlformats.org/drawingml/2006/main">
-            <a:r>
+              <a:t>Классическая сеть:</a:t>
+            </a:r>
+          </a:p>
+          <a:p xmlns:a="http://schemas.openxmlformats.org/drawingml/2006/main">
+            <a:pPr algn="l">
+              <a:defRPr sz="1650">
+                <a:solidFill>
+                  <a:srgbClr val="17232D"/>
+                </a:solidFill>
+                <a:latin typeface="Calibri"/>
+                <a:ea typeface="Calibri"/>
+                <a:cs typeface="Calibri"/>
+              </a:defRPr>
+            </a:pPr>
+            <a:r>
+              <a:rPr sz="1650">
+                <a:solidFill>
+                  <a:srgbClr val="17232D"/>
+                </a:solidFill>
+                <a:latin typeface="Calibri"/>
+                <a:ea typeface="Calibri"/>
+                <a:cs typeface="Calibri"/>
+              </a:rPr>
+              <a:t>N = 3, горизонт 30.</a:t>
+            </a:r>
+          </a:p>
+          <a:p xmlns:a="http://schemas.openxmlformats.org/drawingml/2006/main">
+            <a:pPr algn="l">
+              <a:buNone/>
+              <a:defRPr sz="1650" b="0">
+                <a:solidFill>
+                  <a:srgbClr val="17232D"/>
+                </a:solidFill>
+              </a:defRPr>
+            </a:pPr>
+            <a:r>
+              <a:rPr sz="1650" b="0">
+                <a:solidFill>
+                  <a:srgbClr val="17232D"/>
+                </a:solidFill>
+              </a:rPr>
               <a:t/>
             </a:r>
           </a:p>
@@ -9146,7 +9555,7 @@
                 <a:ea typeface="Calibri"/>
                 <a:cs typeface="Calibri"/>
               </a:rPr>
-              <a:t>Решение не является целочисленной маркировкой.</a:t>
+              <a:t>6 событий до deadlock</a:t>
             </a:r>
           </a:p>
           <a:p xmlns:a="http://schemas.openxmlformats.org/drawingml/2006/main">
@@ -9156,6 +9565,9 @@
                 <a:solidFill>
                   <a:srgbClr val="17232D"/>
                 </a:solidFill>
+                <a:latin typeface="Calibri"/>
+                <a:ea typeface="Calibri"/>
+                <a:cs typeface="Calibri"/>
               </a:defRPr>
             </a:pPr>
             <a:r>
@@ -9163,12 +9575,56 @@
                 <a:solidFill>
                   <a:srgbClr val="17232D"/>
                 </a:solidFill>
+                <a:latin typeface="Calibri"/>
+                <a:ea typeface="Calibri"/>
+                <a:cs typeface="Calibri"/>
+              </a:rPr>
+              <a:t>при t = 2,425484.</a:t>
+            </a:r>
+          </a:p>
+          <a:p xmlns:a="http://schemas.openxmlformats.org/drawingml/2006/main">
+            <a:pPr algn="l">
+              <a:buNone/>
+              <a:defRPr sz="1650" b="0">
+                <a:solidFill>
+                  <a:srgbClr val="17232D"/>
+                </a:solidFill>
+              </a:defRPr>
+            </a:pPr>
+            <a:r>
+              <a:rPr sz="1650" b="0">
+                <a:solidFill>
+                  <a:srgbClr val="17232D"/>
+                </a:solidFill>
               </a:rPr>
               <a:t/>
             </a:r>
           </a:p>
           <a:p xmlns:a="http://schemas.openxmlformats.org/drawingml/2006/main">
             <a:pPr algn="l">
+              <a:defRPr sz="1650">
+                <a:solidFill>
+                  <a:srgbClr val="17232D"/>
+                </a:solidFill>
+                <a:latin typeface="Calibri"/>
+                <a:ea typeface="Calibri"/>
+                <a:cs typeface="Calibri"/>
+              </a:defRPr>
+            </a:pPr>
+            <a:r>
+              <a:rPr sz="1650">
+                <a:solidFill>
+                  <a:srgbClr val="17232D"/>
+                </a:solidFill>
+                <a:latin typeface="Calibri"/>
+                <a:ea typeface="Calibri"/>
+                <a:cs typeface="Calibri"/>
+              </a:rPr>
+              <a:t>Арбитр: 36 событий</a:t>
+            </a:r>
+          </a:p>
+          <a:p xmlns:a="http://schemas.openxmlformats.org/drawingml/2006/main">
+            <a:pPr algn="l">
               <a:buNone/>
               <a:defRPr sz="1650" b="0">
                 <a:solidFill>
@@ -9188,7 +9644,7 @@
                 <a:ea typeface="Calibri"/>
                 <a:cs typeface="Calibri"/>
               </a:rPr>
-              <a:t>ODE не заменяет проверку дискретного deadlock.</a:t>
+              <a:t>без блокировки.</a:t>
             </a:r>
           </a:p>
         </p:txBody>
@@ -9224,10 +9680,10 @@
       </p:grpSpPr>
       <p:sp>
         <p:nvSpPr>
-          <p:cNvPr id="11" name="top-band">
-            <a:extLst xmlns:a="http://schemas.openxmlformats.org/drawingml/2006/main">
-              <a:ext uri="{FF2B5EF4-FFF2-40B4-BE49-F238E27FC236}">
-                <a16:creationId xmlns:a16="http://schemas.microsoft.com/office/drawing/2014/main" id="{48421A46-F9BD-480F-B275-C23896D5EE31}"/>
+          <p:cNvPr id="10" name="top-band">
+            <a:extLst xmlns:a="http://schemas.openxmlformats.org/drawingml/2006/main">
+              <a:ext uri="{FF2B5EF4-FFF2-40B4-BE49-F238E27FC236}">
+                <a16:creationId xmlns:a16="http://schemas.microsoft.com/office/drawing/2014/main" id="{4B4A040E-4FA4-4C92-9639-20B50A1DA80E}"/>
               </a:ext>
             </a:extLst>
           </p:cNvPr>
@@ -9258,7 +9714,7 @@
           <p:cNvPr id="2" name="top-accent">
             <a:extLst xmlns:a="http://schemas.openxmlformats.org/drawingml/2006/main">
               <a:ext uri="{FF2B5EF4-FFF2-40B4-BE49-F238E27FC236}">
-                <a16:creationId xmlns:a16="http://schemas.microsoft.com/office/drawing/2014/main" id="{90627352-F663-4A2E-9B7B-12B403F6F495}"/>
+                <a16:creationId xmlns:a16="http://schemas.microsoft.com/office/drawing/2014/main" id="{0E2760E0-2BFB-41A3-B4B9-FC44F2B820FF}"/>
               </a:ext>
             </a:extLst>
           </p:cNvPr>
@@ -9289,7 +9745,7 @@
           <p:cNvPr id="3" name="slide-title">
             <a:extLst xmlns:a="http://schemas.openxmlformats.org/drawingml/2006/main">
               <a:ext uri="{FF2B5EF4-FFF2-40B4-BE49-F238E27FC236}">
-                <a16:creationId xmlns:a16="http://schemas.microsoft.com/office/drawing/2014/main" id="{518DEB88-7101-47B0-B748-A400397B559B}"/>
+                <a16:creationId xmlns:a16="http://schemas.microsoft.com/office/drawing/2014/main" id="{BD12DDF8-2FD0-4D82-98E2-44AD868D120D}"/>
               </a:ext>
             </a:extLst>
           </p:cNvPr>
@@ -9336,7 +9792,7 @@
                 <a:ea typeface="Calibri"/>
                 <a:cs typeface="Calibri"/>
               </a:rPr>
-              <a:t>Параметрическая серия включает 960 траекторий</a:t>
+              <a:t>ODE дополняет дискретную траекторию</a:t>
             </a:r>
           </a:p>
         </p:txBody>
@@ -9346,7 +9802,7 @@
           <p:cNvPr id="4" name="footer-rule">
             <a:extLst xmlns:a="http://schemas.openxmlformats.org/drawingml/2006/main">
               <a:ext uri="{FF2B5EF4-FFF2-40B4-BE49-F238E27FC236}">
-                <a16:creationId xmlns:a16="http://schemas.microsoft.com/office/drawing/2014/main" id="{9CDEA9B6-8955-4F09-B9FA-546DA393B4F9}"/>
+                <a16:creationId xmlns:a16="http://schemas.microsoft.com/office/drawing/2014/main" id="{75E0F864-667E-4385-A6F2-CC1F5D66DDEE}"/>
               </a:ext>
             </a:extLst>
           </p:cNvPr>
@@ -9381,7 +9837,7 @@
           <p:nvPr/>
         </p:nvPicPr>
         <p:blipFill>
-          <a:blip xmlns:r="http://schemas.openxmlformats.org/officeDocument/2006/relationships" xmlns:a="http://schemas.openxmlformats.org/drawingml/2006/main" r:embed="R120579d1b98243b4"/>
+          <a:blip xmlns:r="http://schemas.openxmlformats.org/officeDocument/2006/relationships" xmlns:a="http://schemas.openxmlformats.org/drawingml/2006/main" r:embed="Re49e61f96da7466d"/>
           <a:stretch xmlns:a="http://schemas.openxmlformats.org/drawingml/2006/main"/>
         </p:blipFill>
         <p:spPr>
@@ -9399,7 +9855,7 @@
           <p:cNvPr id="6" name="footer">
             <a:extLst xmlns:a="http://schemas.openxmlformats.org/drawingml/2006/main">
               <a:ext uri="{FF2B5EF4-FFF2-40B4-BE49-F238E27FC236}">
-                <a16:creationId xmlns:a16="http://schemas.microsoft.com/office/drawing/2014/main" id="{B41B547B-6312-422F-97B9-B812308FCE3A}"/>
+                <a16:creationId xmlns:a16="http://schemas.microsoft.com/office/drawing/2014/main" id="{E83CD01B-7F94-4DBC-84F5-40CECFAF3CBC}"/>
               </a:ext>
             </a:extLst>
           </p:cNvPr>
@@ -9456,7 +9912,7 @@
           <p:cNvPr id="7" name="page-number">
             <a:extLst xmlns:a="http://schemas.openxmlformats.org/drawingml/2006/main">
               <a:ext uri="{FF2B5EF4-FFF2-40B4-BE49-F238E27FC236}">
-                <a16:creationId xmlns:a16="http://schemas.microsoft.com/office/drawing/2014/main" id="{C5D149F8-2B2A-45C2-ACB2-B531EF4A60FF}"/>
+                <a16:creationId xmlns:a16="http://schemas.microsoft.com/office/drawing/2014/main" id="{C3C7CEEC-053D-4D70-931C-82E3AD18B7D3}"/>
               </a:ext>
             </a:extLst>
           </p:cNvPr>
@@ -9508,24 +9964,46 @@
           </a:p>
         </p:txBody>
       </p:sp>
-      <p:sp>
-        <p:nvSpPr>
-          <p:cNvPr id="8" name="goal">
-            <a:extLst xmlns:a="http://schemas.openxmlformats.org/drawingml/2006/main">
-              <a:ext uri="{FF2B5EF4-FFF2-40B4-BE49-F238E27FC236}">
-                <a16:creationId xmlns:a16="http://schemas.microsoft.com/office/drawing/2014/main" id="{867F2279-946D-4402-B6C9-E80BAE1B4A47}"/>
-              </a:ext>
-            </a:extLst>
-          </p:cNvPr>
-          <p:cNvSpPr>
-            <a:spLocks xmlns:a="http://schemas.openxmlformats.org/drawingml/2006/main" noGrp="1"/>
-          </p:cNvSpPr>
-          <p:nvPr/>
-        </p:nvSpPr>
-        <p:spPr>
-          <a:xfrm xmlns:a="http://schemas.openxmlformats.org/drawingml/2006/main">
-            <a:off x="704850" y="933450"/>
-            <a:ext cx="10668000" cy="762000"/>
+      <p:pic>
+        <p:nvPicPr>
+          <p:cNvPr id="20" name=""/>
+          <p:cNvPicPr>
+            <a:picLocks xmlns:a="http://schemas.openxmlformats.org/drawingml/2006/main" noChangeAspect="1"/>
+          </p:cNvPicPr>
+          <p:nvPr/>
+        </p:nvPicPr>
+        <p:blipFill>
+          <a:blip xmlns:r="http://schemas.openxmlformats.org/officeDocument/2006/relationships" xmlns:a="http://schemas.openxmlformats.org/drawingml/2006/main" r:embed="Rb6588f05355c4042"/>
+          <a:stretch xmlns:a="http://schemas.openxmlformats.org/drawingml/2006/main"/>
+        </p:blipFill>
+        <p:spPr>
+          <a:xfrm xmlns:a="http://schemas.openxmlformats.org/drawingml/2006/main">
+            <a:off x="1196578" y="1468636"/>
+            <a:ext cx="6369844" cy="3949303"/>
+          </a:xfrm>
+          <a:prstGeom xmlns:a="http://schemas.openxmlformats.org/drawingml/2006/main" prst="rect">
+            <a:avLst/>
+          </a:prstGeom>
+        </p:spPr>
+      </p:pic>
+      <p:sp>
+        <p:nvSpPr>
+          <p:cNvPr id="9" name="states">
+            <a:extLst xmlns:a="http://schemas.openxmlformats.org/drawingml/2006/main">
+              <a:ext uri="{FF2B5EF4-FFF2-40B4-BE49-F238E27FC236}">
+                <a16:creationId xmlns:a16="http://schemas.microsoft.com/office/drawing/2014/main" id="{14E3F9B0-44C3-4EC1-8902-2CA766BD760E}"/>
+              </a:ext>
+            </a:extLst>
+          </p:cNvPr>
+          <p:cNvSpPr>
+            <a:spLocks xmlns:a="http://schemas.openxmlformats.org/drawingml/2006/main" noGrp="1"/>
+          </p:cNvSpPr>
+          <p:nvPr/>
+        </p:nvSpPr>
+        <p:spPr>
+          <a:xfrm xmlns:a="http://schemas.openxmlformats.org/drawingml/2006/main">
+            <a:off x="8572500" y="1219200"/>
+            <a:ext cx="2552700" cy="3657600"/>
           </a:xfrm>
           <a:prstGeom xmlns:a="http://schemas.openxmlformats.org/drawingml/2006/main" prst="rect">
             <a:avLst/>
@@ -9542,95 +10020,7 @@
           <a:p xmlns:a="http://schemas.openxmlformats.org/drawingml/2006/main">
             <a:pPr algn="l">
               <a:buNone/>
-              <a:defRPr sz="1800" b="1">
-                <a:solidFill>
-                  <a:srgbClr val="0B4778"/>
-                </a:solidFill>
-                <a:latin typeface="Calibri"/>
-                <a:ea typeface="Calibri"/>
-                <a:cs typeface="Calibri"/>
-              </a:defRPr>
-            </a:pPr>
-            <a:r>
-              <a:rPr sz="1800" b="1">
-                <a:solidFill>
-                  <a:srgbClr val="0B4778"/>
-                </a:solidFill>
-                <a:latin typeface="Calibri"/>
-                <a:ea typeface="Calibri"/>
-                <a:cs typeface="Calibri"/>
-              </a:rPr>
-              <a:t>Проверяется влияние числа философов и интенсивности захвата левой вилки.</a:t>
-            </a:r>
-          </a:p>
-        </p:txBody>
-      </p:sp>
-      <p:sp>
-        <p:nvSpPr>
-          <p:cNvPr id="9" name="left-rule">
-            <a:extLst xmlns:a="http://schemas.openxmlformats.org/drawingml/2006/main">
-              <a:ext uri="{FF2B5EF4-FFF2-40B4-BE49-F238E27FC236}">
-                <a16:creationId xmlns:a16="http://schemas.microsoft.com/office/drawing/2014/main" id="{0B205D5C-F4E6-46EE-8BE3-E1E85CA2FB3F}"/>
-              </a:ext>
-            </a:extLst>
-          </p:cNvPr>
-          <p:cNvSpPr>
-            <a:spLocks xmlns:a="http://schemas.openxmlformats.org/drawingml/2006/main" noGrp="1"/>
-          </p:cNvSpPr>
-          <p:nvPr/>
-        </p:nvSpPr>
-        <p:spPr>
-          <a:xfrm xmlns:a="http://schemas.openxmlformats.org/drawingml/2006/main">
-            <a:off x="704850" y="1952625"/>
-            <a:ext cx="57150" cy="3409950"/>
-          </a:xfrm>
-          <a:prstGeom xmlns:a="http://schemas.openxmlformats.org/drawingml/2006/main" prst="rect">
-            <a:avLst/>
-          </a:prstGeom>
-          <a:solidFill xmlns:a="http://schemas.openxmlformats.org/drawingml/2006/main">
-            <a:srgbClr val="35A9D3"/>
-          </a:solidFill>
-          <a:ln xmlns:a="http://schemas.openxmlformats.org/drawingml/2006/main" w="0">
-            <a:noFill/>
-            <a:prstDash val="solid"/>
-          </a:ln>
-        </p:spPr>
-      </p:sp>
-      <p:sp>
-        <p:nvSpPr>
-          <p:cNvPr id="10" name="tasks">
-            <a:extLst xmlns:a="http://schemas.openxmlformats.org/drawingml/2006/main">
-              <a:ext uri="{FF2B5EF4-FFF2-40B4-BE49-F238E27FC236}">
-                <a16:creationId xmlns:a16="http://schemas.microsoft.com/office/drawing/2014/main" id="{D0B8600E-8057-4E67-AFD8-8FFEDC555D89}"/>
-              </a:ext>
-            </a:extLst>
-          </p:cNvPr>
-          <p:cNvSpPr>
-            <a:spLocks xmlns:a="http://schemas.openxmlformats.org/drawingml/2006/main" noGrp="1"/>
-          </p:cNvSpPr>
-          <p:nvPr/>
-        </p:nvSpPr>
-        <p:spPr>
-          <a:xfrm xmlns:a="http://schemas.openxmlformats.org/drawingml/2006/main">
-            <a:off x="1009650" y="1847850"/>
-            <a:ext cx="9620250" cy="3714750"/>
-          </a:xfrm>
-          <a:prstGeom xmlns:a="http://schemas.openxmlformats.org/drawingml/2006/main" prst="rect">
-            <a:avLst/>
-          </a:prstGeom>
-          <a:noFill xmlns:a="http://schemas.openxmlformats.org/drawingml/2006/main"/>
-          <a:ln xmlns:a="http://schemas.openxmlformats.org/drawingml/2006/main" w="0">
-            <a:noFill/>
-            <a:prstDash val="solid"/>
-          </a:ln>
-        </p:spPr>
-        <p:txBody>
-          <a:bodyPr xmlns:a="http://schemas.openxmlformats.org/drawingml/2006/main" lIns="91440" tIns="45720" rIns="91440" bIns="45720" anchor="ctr"/>
-          <a:lstStyle xmlns:a="http://schemas.openxmlformats.org/drawingml/2006/main"/>
-          <a:p xmlns:a="http://schemas.openxmlformats.org/drawingml/2006/main">
-            <a:pPr algn="l">
-              <a:buNone/>
-              <a:defRPr sz="1725" b="0">
+              <a:defRPr sz="1650" b="0">
                 <a:solidFill>
                   <a:srgbClr val="17232D"/>
                 </a:solidFill>
@@ -9640,7 +10030,7 @@
               </a:defRPr>
             </a:pPr>
             <a:r>
-              <a:rPr sz="1725" b="0">
+              <a:rPr sz="1650" b="0">
                 <a:solidFill>
                   <a:srgbClr val="17232D"/>
                 </a:solidFill>
@@ -9648,7 +10038,7 @@
                 <a:ea typeface="Calibri"/>
                 <a:cs typeface="Calibri"/>
               </a:rPr>
-              <a:t>• N = 3, 4, 5, 6, 7, 8;</a:t>
+              <a:t>Массовое действие задаёт непрерывные потоки.</a:t>
             </a:r>
           </a:p>
           <a:p xmlns:a="http://schemas.openxmlformats.org/drawingml/2006/main">
@@ -9659,7 +10049,7 @@
           <a:p xmlns:a="http://schemas.openxmlformats.org/drawingml/2006/main">
             <a:pPr algn="l">
               <a:buNone/>
-              <a:defRPr sz="1725" b="0">
+              <a:defRPr sz="1650" b="0">
                 <a:solidFill>
                   <a:srgbClr val="17232D"/>
                 </a:solidFill>
@@ -9669,7 +10059,7 @@
               </a:defRPr>
             </a:pPr>
             <a:r>
-              <a:rPr sz="1725" b="0">
+              <a:rPr sz="1650" b="0">
                 <a:solidFill>
                   <a:srgbClr val="17232D"/>
                 </a:solidFill>
@@ -9677,18 +10067,31 @@
                 <a:ea typeface="Calibri"/>
                 <a:cs typeface="Calibri"/>
               </a:rPr>
-              <a:t>• λL = 1,0; 1,5; 2,0; 3,0;</a:t>
-            </a:r>
-          </a:p>
-          <a:p xmlns:a="http://schemas.openxmlformats.org/drawingml/2006/main">
-            <a:r>
+              <a:t>Решение не является целочисленной маркировкой.</a:t>
+            </a:r>
+          </a:p>
+          <a:p xmlns:a="http://schemas.openxmlformats.org/drawingml/2006/main">
+            <a:pPr algn="l">
+              <a:buNone/>
+              <a:defRPr sz="1650" b="0">
+                <a:solidFill>
+                  <a:srgbClr val="17232D"/>
+                </a:solidFill>
+              </a:defRPr>
+            </a:pPr>
+            <a:r>
+              <a:rPr sz="1650" b="0">
+                <a:solidFill>
+                  <a:srgbClr val="17232D"/>
+                </a:solidFill>
+              </a:rPr>
               <a:t/>
             </a:r>
           </a:p>
           <a:p xmlns:a="http://schemas.openxmlformats.org/drawingml/2006/main">
             <a:pPr algn="l">
               <a:buNone/>
-              <a:defRPr sz="1725" b="0">
+              <a:defRPr sz="1650" b="0">
                 <a:solidFill>
                   <a:srgbClr val="17232D"/>
                 </a:solidFill>
@@ -9698,7 +10101,7 @@
               </a:defRPr>
             </a:pPr>
             <a:r>
-              <a:rPr sz="1725" b="0">
+              <a:rPr sz="1650" b="0">
                 <a:solidFill>
                   <a:srgbClr val="17232D"/>
                 </a:solidFill>
@@ -9706,94 +10109,7 @@
                 <a:ea typeface="Calibri"/>
                 <a:cs typeface="Calibri"/>
               </a:rPr>
-              <a:t>• 20 повторов каждой комбинации;</a:t>
-            </a:r>
-          </a:p>
-          <a:p xmlns:a="http://schemas.openxmlformats.org/drawingml/2006/main">
-            <a:r>
-              <a:t/>
-            </a:r>
-          </a:p>
-          <a:p xmlns:a="http://schemas.openxmlformats.org/drawingml/2006/main">
-            <a:pPr algn="l">
-              <a:buNone/>
-              <a:defRPr sz="1725" b="0">
-                <a:solidFill>
-                  <a:srgbClr val="17232D"/>
-                </a:solidFill>
-                <a:latin typeface="Calibri"/>
-                <a:ea typeface="Calibri"/>
-                <a:cs typeface="Calibri"/>
-              </a:defRPr>
-            </a:pPr>
-            <a:r>
-              <a:rPr sz="1725" b="0">
-                <a:solidFill>
-                  <a:srgbClr val="17232D"/>
-                </a:solidFill>
-                <a:latin typeface="Calibri"/>
-                <a:ea typeface="Calibri"/>
-                <a:cs typeface="Calibri"/>
-              </a:rPr>
-              <a:t>• два варианта сети;</a:t>
-            </a:r>
-          </a:p>
-          <a:p xmlns:a="http://schemas.openxmlformats.org/drawingml/2006/main">
-            <a:r>
-              <a:t/>
-            </a:r>
-          </a:p>
-          <a:p xmlns:a="http://schemas.openxmlformats.org/drawingml/2006/main">
-            <a:pPr algn="l">
-              <a:buNone/>
-              <a:defRPr sz="1725" b="0">
-                <a:solidFill>
-                  <a:srgbClr val="17232D"/>
-                </a:solidFill>
-                <a:latin typeface="Calibri"/>
-                <a:ea typeface="Calibri"/>
-                <a:cs typeface="Calibri"/>
-              </a:defRPr>
-            </a:pPr>
-            <a:r>
-              <a:rPr sz="1725" b="0">
-                <a:solidFill>
-                  <a:srgbClr val="17232D"/>
-                </a:solidFill>
-                <a:latin typeface="Calibri"/>
-                <a:ea typeface="Calibri"/>
-                <a:cs typeface="Calibri"/>
-              </a:rPr>
-              <a:t>• горизонт каждого прогона: 50;</a:t>
-            </a:r>
-          </a:p>
-          <a:p xmlns:a="http://schemas.openxmlformats.org/drawingml/2006/main">
-            <a:r>
-              <a:t/>
-            </a:r>
-          </a:p>
-          <a:p xmlns:a="http://schemas.openxmlformats.org/drawingml/2006/main">
-            <a:pPr algn="l">
-              <a:buNone/>
-              <a:defRPr sz="1725" b="0">
-                <a:solidFill>
-                  <a:srgbClr val="17232D"/>
-                </a:solidFill>
-                <a:latin typeface="Calibri"/>
-                <a:ea typeface="Calibri"/>
-                <a:cs typeface="Calibri"/>
-              </a:defRPr>
-            </a:pPr>
-            <a:r>
-              <a:rPr sz="1725" b="0">
-                <a:solidFill>
-                  <a:srgbClr val="17232D"/>
-                </a:solidFill>
-                <a:latin typeface="Calibri"/>
-                <a:ea typeface="Calibri"/>
-                <a:cs typeface="Calibri"/>
-              </a:rPr>
-              <a:t>• фиксированные начальные состояния генератора.</a:t>
+              <a:t>ODE не заменяет проверку дискретного deadlock.</a:t>
             </a:r>
           </a:p>
         </p:txBody>
@@ -9801,7 +10117,7 @@
     </p:spTree>
     <p:extLst>
       <p:ext uri="{BB962C8B-B14F-4D97-AF65-F5344CB8AC3E}">
-        <p14:creationId xmlns:p14="http://schemas.microsoft.com/office/powerpoint/2010/main" val="1899172888"/>
+        <p14:creationId xmlns:p14="http://schemas.microsoft.com/office/powerpoint/2010/main" val="1586191248"/>
       </p:ext>
     </p:extLst>
   </p:cSld>
@@ -9832,7 +10148,7 @@
           <p:cNvPr id="11" name="top-band">
             <a:extLst xmlns:a="http://schemas.openxmlformats.org/drawingml/2006/main">
               <a:ext uri="{FF2B5EF4-FFF2-40B4-BE49-F238E27FC236}">
-                <a16:creationId xmlns:a16="http://schemas.microsoft.com/office/drawing/2014/main" id="{4B71F5F6-248A-493A-BFF4-DB5B4A22A606}"/>
+                <a16:creationId xmlns:a16="http://schemas.microsoft.com/office/drawing/2014/main" id="{48421A46-F9BD-480F-B275-C23896D5EE31}"/>
               </a:ext>
             </a:extLst>
           </p:cNvPr>
@@ -9863,7 +10179,7 @@
           <p:cNvPr id="2" name="top-accent">
             <a:extLst xmlns:a="http://schemas.openxmlformats.org/drawingml/2006/main">
               <a:ext uri="{FF2B5EF4-FFF2-40B4-BE49-F238E27FC236}">
-                <a16:creationId xmlns:a16="http://schemas.microsoft.com/office/drawing/2014/main" id="{BB5CB7FF-FF77-40E6-A4F7-D6586C902A95}"/>
+                <a16:creationId xmlns:a16="http://schemas.microsoft.com/office/drawing/2014/main" id="{90627352-F663-4A2E-9B7B-12B403F6F495}"/>
               </a:ext>
             </a:extLst>
           </p:cNvPr>
@@ -9894,7 +10210,7 @@
           <p:cNvPr id="3" name="slide-title">
             <a:extLst xmlns:a="http://schemas.openxmlformats.org/drawingml/2006/main">
               <a:ext uri="{FF2B5EF4-FFF2-40B4-BE49-F238E27FC236}">
-                <a16:creationId xmlns:a16="http://schemas.microsoft.com/office/drawing/2014/main" id="{22042EA1-0509-47F7-86ED-55527639D76A}"/>
+                <a16:creationId xmlns:a16="http://schemas.microsoft.com/office/drawing/2014/main" id="{518DEB88-7101-47B0-B748-A400397B559B}"/>
               </a:ext>
             </a:extLst>
           </p:cNvPr>
@@ -9941,7 +10257,7 @@
                 <a:ea typeface="Calibri"/>
                 <a:cs typeface="Calibri"/>
               </a:rPr>
-              <a:t>В серии deadlock наблюдался только без арбитра</a:t>
+              <a:t>Параметрическая серия включает 960 траекторий</a:t>
             </a:r>
           </a:p>
         </p:txBody>
@@ -9951,7 +10267,7 @@
           <p:cNvPr id="4" name="footer-rule">
             <a:extLst xmlns:a="http://schemas.openxmlformats.org/drawingml/2006/main">
               <a:ext uri="{FF2B5EF4-FFF2-40B4-BE49-F238E27FC236}">
-                <a16:creationId xmlns:a16="http://schemas.microsoft.com/office/drawing/2014/main" id="{B0DFCD4F-FB53-4C73-8295-9DB007AEAF7C}"/>
+                <a16:creationId xmlns:a16="http://schemas.microsoft.com/office/drawing/2014/main" id="{9CDEA9B6-8955-4F09-B9FA-546DA393B4F9}"/>
               </a:ext>
             </a:extLst>
           </p:cNvPr>
@@ -9979,14 +10295,14 @@
       </p:sp>
       <p:pic>
         <p:nvPicPr>
-          <p:cNvPr id="18" name=""/>
+          <p:cNvPr id="17" name=""/>
           <p:cNvPicPr>
             <a:picLocks xmlns:a="http://schemas.openxmlformats.org/drawingml/2006/main" noChangeAspect="1"/>
           </p:cNvPicPr>
           <p:nvPr/>
         </p:nvPicPr>
         <p:blipFill>
-          <a:blip xmlns:r="http://schemas.openxmlformats.org/officeDocument/2006/relationships" xmlns:a="http://schemas.openxmlformats.org/drawingml/2006/main" r:embed="R766bfd89d49d4e12"/>
+          <a:blip xmlns:r="http://schemas.openxmlformats.org/officeDocument/2006/relationships" xmlns:a="http://schemas.openxmlformats.org/drawingml/2006/main" r:embed="R3df45b1a042e4f75"/>
           <a:stretch xmlns:a="http://schemas.openxmlformats.org/drawingml/2006/main"/>
         </p:blipFill>
         <p:spPr>
@@ -10004,7 +10320,7 @@
           <p:cNvPr id="6" name="footer">
             <a:extLst xmlns:a="http://schemas.openxmlformats.org/drawingml/2006/main">
               <a:ext uri="{FF2B5EF4-FFF2-40B4-BE49-F238E27FC236}">
-                <a16:creationId xmlns:a16="http://schemas.microsoft.com/office/drawing/2014/main" id="{07E8B0EB-4DA1-4111-8E40-6CB1D9B0DDB1}"/>
+                <a16:creationId xmlns:a16="http://schemas.microsoft.com/office/drawing/2014/main" id="{B41B547B-6312-422F-97B9-B812308FCE3A}"/>
               </a:ext>
             </a:extLst>
           </p:cNvPr>
@@ -10061,7 +10377,7 @@
           <p:cNvPr id="7" name="page-number">
             <a:extLst xmlns:a="http://schemas.openxmlformats.org/drawingml/2006/main">
               <a:ext uri="{FF2B5EF4-FFF2-40B4-BE49-F238E27FC236}">
-                <a16:creationId xmlns:a16="http://schemas.microsoft.com/office/drawing/2014/main" id="{1C622E43-05B3-40DE-ABF3-C03225595873}"/>
+                <a16:creationId xmlns:a16="http://schemas.microsoft.com/office/drawing/2014/main" id="{C5D149F8-2B2A-45C2-ACB2-B531EF4A60FF}"/>
               </a:ext>
             </a:extLst>
           </p:cNvPr>
@@ -10113,46 +10429,24 @@
           </a:p>
         </p:txBody>
       </p:sp>
-      <p:pic>
-        <p:nvPicPr>
-          <p:cNvPr id="21" name=""/>
-          <p:cNvPicPr>
-            <a:picLocks xmlns:a="http://schemas.openxmlformats.org/drawingml/2006/main" noChangeAspect="1"/>
-          </p:cNvPicPr>
-          <p:nvPr/>
-        </p:nvPicPr>
-        <p:blipFill>
-          <a:blip xmlns:r="http://schemas.openxmlformats.org/officeDocument/2006/relationships" xmlns:a="http://schemas.openxmlformats.org/drawingml/2006/main" r:embed="Rc187308455aa49c9"/>
-          <a:stretch xmlns:a="http://schemas.openxmlformats.org/drawingml/2006/main"/>
-        </p:blipFill>
-        <p:spPr>
-          <a:xfrm xmlns:a="http://schemas.openxmlformats.org/drawingml/2006/main">
-            <a:off x="476250" y="1106329"/>
-            <a:ext cx="7477125" cy="4635818"/>
-          </a:xfrm>
-          <a:prstGeom xmlns:a="http://schemas.openxmlformats.org/drawingml/2006/main" prst="rect">
-            <a:avLst/>
-          </a:prstGeom>
-        </p:spPr>
-      </p:pic>
-      <p:sp>
-        <p:nvSpPr>
-          <p:cNvPr id="9" name="scan-table">
-            <a:extLst xmlns:a="http://schemas.openxmlformats.org/drawingml/2006/main">
-              <a:ext uri="{FF2B5EF4-FFF2-40B4-BE49-F238E27FC236}">
-                <a16:creationId xmlns:a16="http://schemas.microsoft.com/office/drawing/2014/main" id="{B690B6A6-A35B-4EFA-A6BD-EF554132BD91}"/>
-              </a:ext>
-            </a:extLst>
-          </p:cNvPr>
-          <p:cNvSpPr>
-            <a:spLocks xmlns:a="http://schemas.openxmlformats.org/drawingml/2006/main" noGrp="1"/>
-          </p:cNvSpPr>
-          <p:nvPr/>
-        </p:nvSpPr>
-        <p:spPr>
-          <a:xfrm xmlns:a="http://schemas.openxmlformats.org/drawingml/2006/main">
-            <a:off x="8334375" y="1257300"/>
-            <a:ext cx="2686050" cy="2381250"/>
+      <p:sp>
+        <p:nvSpPr>
+          <p:cNvPr id="8" name="goal">
+            <a:extLst xmlns:a="http://schemas.openxmlformats.org/drawingml/2006/main">
+              <a:ext uri="{FF2B5EF4-FFF2-40B4-BE49-F238E27FC236}">
+                <a16:creationId xmlns:a16="http://schemas.microsoft.com/office/drawing/2014/main" id="{867F2279-946D-4402-B6C9-E80BAE1B4A47}"/>
+              </a:ext>
+            </a:extLst>
+          </p:cNvPr>
+          <p:cNvSpPr>
+            <a:spLocks xmlns:a="http://schemas.openxmlformats.org/drawingml/2006/main" noGrp="1"/>
+          </p:cNvSpPr>
+          <p:nvPr/>
+        </p:nvSpPr>
+        <p:spPr>
+          <a:xfrm xmlns:a="http://schemas.openxmlformats.org/drawingml/2006/main">
+            <a:off x="704850" y="933450"/>
+            <a:ext cx="10668000" cy="762000"/>
           </a:xfrm>
           <a:prstGeom xmlns:a="http://schemas.openxmlformats.org/drawingml/2006/main" prst="rect">
             <a:avLst/>
@@ -10169,6 +10463,94 @@
           <a:p xmlns:a="http://schemas.openxmlformats.org/drawingml/2006/main">
             <a:pPr algn="l">
               <a:buNone/>
+              <a:defRPr sz="1800" b="1">
+                <a:solidFill>
+                  <a:srgbClr val="0B4778"/>
+                </a:solidFill>
+                <a:latin typeface="Calibri"/>
+                <a:ea typeface="Calibri"/>
+                <a:cs typeface="Calibri"/>
+              </a:defRPr>
+            </a:pPr>
+            <a:r>
+              <a:rPr sz="1800" b="1">
+                <a:solidFill>
+                  <a:srgbClr val="0B4778"/>
+                </a:solidFill>
+                <a:latin typeface="Calibri"/>
+                <a:ea typeface="Calibri"/>
+                <a:cs typeface="Calibri"/>
+              </a:rPr>
+              <a:t>Проверяется влияние числа философов и интенсивности захвата левой вилки.</a:t>
+            </a:r>
+          </a:p>
+        </p:txBody>
+      </p:sp>
+      <p:sp>
+        <p:nvSpPr>
+          <p:cNvPr id="9" name="left-rule">
+            <a:extLst xmlns:a="http://schemas.openxmlformats.org/drawingml/2006/main">
+              <a:ext uri="{FF2B5EF4-FFF2-40B4-BE49-F238E27FC236}">
+                <a16:creationId xmlns:a16="http://schemas.microsoft.com/office/drawing/2014/main" id="{0B205D5C-F4E6-46EE-8BE3-E1E85CA2FB3F}"/>
+              </a:ext>
+            </a:extLst>
+          </p:cNvPr>
+          <p:cNvSpPr>
+            <a:spLocks xmlns:a="http://schemas.openxmlformats.org/drawingml/2006/main" noGrp="1"/>
+          </p:cNvSpPr>
+          <p:nvPr/>
+        </p:nvSpPr>
+        <p:spPr>
+          <a:xfrm xmlns:a="http://schemas.openxmlformats.org/drawingml/2006/main">
+            <a:off x="704850" y="1952625"/>
+            <a:ext cx="57150" cy="3409950"/>
+          </a:xfrm>
+          <a:prstGeom xmlns:a="http://schemas.openxmlformats.org/drawingml/2006/main" prst="rect">
+            <a:avLst/>
+          </a:prstGeom>
+          <a:solidFill xmlns:a="http://schemas.openxmlformats.org/drawingml/2006/main">
+            <a:srgbClr val="35A9D3"/>
+          </a:solidFill>
+          <a:ln xmlns:a="http://schemas.openxmlformats.org/drawingml/2006/main" w="0">
+            <a:noFill/>
+            <a:prstDash val="solid"/>
+          </a:ln>
+        </p:spPr>
+      </p:sp>
+      <p:sp>
+        <p:nvSpPr>
+          <p:cNvPr id="10" name="tasks">
+            <a:extLst xmlns:a="http://schemas.openxmlformats.org/drawingml/2006/main">
+              <a:ext uri="{FF2B5EF4-FFF2-40B4-BE49-F238E27FC236}">
+                <a16:creationId xmlns:a16="http://schemas.microsoft.com/office/drawing/2014/main" id="{D0B8600E-8057-4E67-AFD8-8FFEDC555D89}"/>
+              </a:ext>
+            </a:extLst>
+          </p:cNvPr>
+          <p:cNvSpPr>
+            <a:spLocks xmlns:a="http://schemas.openxmlformats.org/drawingml/2006/main" noGrp="1"/>
+          </p:cNvSpPr>
+          <p:nvPr/>
+        </p:nvSpPr>
+        <p:spPr>
+          <a:xfrm xmlns:a="http://schemas.openxmlformats.org/drawingml/2006/main">
+            <a:off x="1009650" y="1847850"/>
+            <a:ext cx="9620250" cy="3714750"/>
+          </a:xfrm>
+          <a:prstGeom xmlns:a="http://schemas.openxmlformats.org/drawingml/2006/main" prst="rect">
+            <a:avLst/>
+          </a:prstGeom>
+          <a:noFill xmlns:a="http://schemas.openxmlformats.org/drawingml/2006/main"/>
+          <a:ln xmlns:a="http://schemas.openxmlformats.org/drawingml/2006/main" w="0">
+            <a:noFill/>
+            <a:prstDash val="solid"/>
+          </a:ln>
+        </p:spPr>
+        <p:txBody>
+          <a:bodyPr xmlns:a="http://schemas.openxmlformats.org/drawingml/2006/main" lIns="91440" tIns="45720" rIns="91440" bIns="45720" anchor="ctr"/>
+          <a:lstStyle xmlns:a="http://schemas.openxmlformats.org/drawingml/2006/main"/>
+          <a:p xmlns:a="http://schemas.openxmlformats.org/drawingml/2006/main">
+            <a:pPr algn="l">
+              <a:buNone/>
               <a:defRPr sz="1725" b="0">
                 <a:solidFill>
                   <a:srgbClr val="17232D"/>
@@ -10187,7 +10569,12 @@
                 <a:ea typeface="Calibri"/>
                 <a:cs typeface="Calibri"/>
               </a:rPr>
-              <a:t>Доля остановок:</a:t>
+              <a:t>• N = 3, 4, 5, 6, 7, 8;</a:t>
+            </a:r>
+          </a:p>
+          <a:p xmlns:a="http://schemas.openxmlformats.org/drawingml/2006/main">
+            <a:r>
+              <a:t/>
             </a:r>
           </a:p>
           <a:p xmlns:a="http://schemas.openxmlformats.org/drawingml/2006/main">
@@ -10197,6 +10584,9 @@
                 <a:solidFill>
                   <a:srgbClr val="17232D"/>
                 </a:solidFill>
+                <a:latin typeface="Calibri"/>
+                <a:ea typeface="Calibri"/>
+                <a:cs typeface="Calibri"/>
               </a:defRPr>
             </a:pPr>
             <a:r>
@@ -10204,7 +10594,15 @@
                 <a:solidFill>
                   <a:srgbClr val="17232D"/>
                 </a:solidFill>
-              </a:rPr>
+                <a:latin typeface="Calibri"/>
+                <a:ea typeface="Calibri"/>
+                <a:cs typeface="Calibri"/>
+              </a:rPr>
+              <a:t>• λL = 1,0; 1,5; 2,0; 3,0;</a:t>
+            </a:r>
+          </a:p>
+          <a:p xmlns:a="http://schemas.openxmlformats.org/drawingml/2006/main">
+            <a:r>
               <a:t/>
             </a:r>
           </a:p>
@@ -10229,7 +10627,12 @@
                 <a:ea typeface="Calibri"/>
                 <a:cs typeface="Calibri"/>
               </a:rPr>
-              <a:t>Классическая: 1,0</a:t>
+              <a:t>• 20 повторов каждой комбинации;</a:t>
+            </a:r>
+          </a:p>
+          <a:p xmlns:a="http://schemas.openxmlformats.org/drawingml/2006/main">
+            <a:r>
+              <a:t/>
             </a:r>
           </a:p>
           <a:p xmlns:a="http://schemas.openxmlformats.org/drawingml/2006/main">
@@ -10239,6 +10642,9 @@
                 <a:solidFill>
                   <a:srgbClr val="17232D"/>
                 </a:solidFill>
+                <a:latin typeface="Calibri"/>
+                <a:ea typeface="Calibri"/>
+                <a:cs typeface="Calibri"/>
               </a:defRPr>
             </a:pPr>
             <a:r>
@@ -10246,7 +10652,15 @@
                 <a:solidFill>
                   <a:srgbClr val="17232D"/>
                 </a:solidFill>
-              </a:rPr>
+                <a:latin typeface="Calibri"/>
+                <a:ea typeface="Calibri"/>
+                <a:cs typeface="Calibri"/>
+              </a:rPr>
+              <a:t>• два варианта сети;</a:t>
+            </a:r>
+          </a:p>
+          <a:p xmlns:a="http://schemas.openxmlformats.org/drawingml/2006/main">
+            <a:r>
               <a:t/>
             </a:r>
           </a:p>
@@ -10271,7 +10685,12 @@
                 <a:ea typeface="Calibri"/>
                 <a:cs typeface="Calibri"/>
               </a:rPr>
-              <a:t>С арбитром: 0,0</a:t>
+              <a:t>• горизонт каждого прогона: 50;</a:t>
+            </a:r>
+          </a:p>
+          <a:p xmlns:a="http://schemas.openxmlformats.org/drawingml/2006/main">
+            <a:r>
+              <a:t/>
             </a:r>
           </a:p>
           <a:p xmlns:a="http://schemas.openxmlformats.org/drawingml/2006/main">
@@ -10281,6 +10700,9 @@
                 <a:solidFill>
                   <a:srgbClr val="17232D"/>
                 </a:solidFill>
+                <a:latin typeface="Calibri"/>
+                <a:ea typeface="Calibri"/>
+                <a:cs typeface="Calibri"/>
               </a:defRPr>
             </a:pPr>
             <a:r>
@@ -10288,89 +10710,11 @@
                 <a:solidFill>
                   <a:srgbClr val="17232D"/>
                 </a:solidFill>
-              </a:rPr>
-              <a:t/>
-            </a:r>
-          </a:p>
-          <a:p xmlns:a="http://schemas.openxmlformats.org/drawingml/2006/main">
-            <a:pPr algn="l">
-              <a:buNone/>
-              <a:defRPr sz="1725" b="0">
-                <a:solidFill>
-                  <a:srgbClr val="17232D"/>
-                </a:solidFill>
-                <a:latin typeface="Calibri"/>
-                <a:ea typeface="Calibri"/>
-                <a:cs typeface="Calibri"/>
-              </a:defRPr>
-            </a:pPr>
-            <a:r>
-              <a:rPr sz="1725" b="0">
-                <a:solidFill>
-                  <a:srgbClr val="17232D"/>
-                </a:solidFill>
-                <a:latin typeface="Calibri"/>
-                <a:ea typeface="Calibri"/>
-                <a:cs typeface="Calibri"/>
-              </a:rPr>
-              <a:t>Всего 960 прогонов.</a:t>
-            </a:r>
-          </a:p>
-        </p:txBody>
-      </p:sp>
-      <p:sp>
-        <p:nvSpPr>
-          <p:cNvPr id="10" name="scan-takeaway">
-            <a:extLst xmlns:a="http://schemas.openxmlformats.org/drawingml/2006/main">
-              <a:ext uri="{FF2B5EF4-FFF2-40B4-BE49-F238E27FC236}">
-                <a16:creationId xmlns:a16="http://schemas.microsoft.com/office/drawing/2014/main" id="{8005A1C6-3D7F-4B44-8EF5-7DFA0DF1E7E4}"/>
-              </a:ext>
-            </a:extLst>
-          </p:cNvPr>
-          <p:cNvSpPr>
-            <a:spLocks xmlns:a="http://schemas.openxmlformats.org/drawingml/2006/main" noGrp="1"/>
-          </p:cNvSpPr>
-          <p:nvPr/>
-        </p:nvSpPr>
-        <p:spPr>
-          <a:xfrm xmlns:a="http://schemas.openxmlformats.org/drawingml/2006/main">
-            <a:off x="8143875" y="4000500"/>
-            <a:ext cx="3124200" cy="1200150"/>
-          </a:xfrm>
-          <a:prstGeom xmlns:a="http://schemas.openxmlformats.org/drawingml/2006/main" prst="rect">
-            <a:avLst/>
-          </a:prstGeom>
-          <a:noFill xmlns:a="http://schemas.openxmlformats.org/drawingml/2006/main"/>
-          <a:ln xmlns:a="http://schemas.openxmlformats.org/drawingml/2006/main" w="0">
-            <a:noFill/>
-            <a:prstDash val="solid"/>
-          </a:ln>
-        </p:spPr>
-        <p:txBody>
-          <a:bodyPr xmlns:a="http://schemas.openxmlformats.org/drawingml/2006/main" lIns="91440" tIns="45720" rIns="91440" bIns="45720" anchor="ctr"/>
-          <a:lstStyle xmlns:a="http://schemas.openxmlformats.org/drawingml/2006/main"/>
-          <a:p xmlns:a="http://schemas.openxmlformats.org/drawingml/2006/main">
-            <a:pPr algn="ctr">
-              <a:buNone/>
-              <a:defRPr sz="1650" b="1">
-                <a:solidFill>
-                  <a:srgbClr val="0B4778"/>
-                </a:solidFill>
-                <a:latin typeface="Calibri"/>
-                <a:ea typeface="Calibri"/>
-                <a:cs typeface="Calibri"/>
-              </a:defRPr>
-            </a:pPr>
-            <a:r>
-              <a:rPr sz="1650" b="1">
-                <a:solidFill>
-                  <a:srgbClr val="0B4778"/>
-                </a:solidFill>
-                <a:latin typeface="Calibri"/>
-                <a:ea typeface="Calibri"/>
-                <a:cs typeface="Calibri"/>
-              </a:rPr>
-              <a:t>Это наблюдаемая частота на заданном горизонте, а не оценка для всех возможных запусков.</a:t>
+                <a:latin typeface="Calibri"/>
+                <a:ea typeface="Calibri"/>
+                <a:cs typeface="Calibri"/>
+              </a:rPr>
+              <a:t>• фиксированные начальные состояния генератора.</a:t>
             </a:r>
           </a:p>
         </p:txBody>
@@ -10378,7 +10722,7 @@
     </p:spTree>
     <p:extLst>
       <p:ext uri="{BB962C8B-B14F-4D97-AF65-F5344CB8AC3E}">
-        <p14:creationId xmlns:p14="http://schemas.microsoft.com/office/powerpoint/2010/main" val="1575332896"/>
+        <p14:creationId xmlns:p14="http://schemas.microsoft.com/office/powerpoint/2010/main" val="1899172888"/>
       </p:ext>
     </p:extLst>
   </p:cSld>
@@ -10444,7 +10788,7 @@
           <p:nvPr/>
         </p:nvPicPr>
         <p:blipFill>
-          <a:blip xmlns:r="http://schemas.openxmlformats.org/officeDocument/2006/relationships" xmlns:a="http://schemas.openxmlformats.org/drawingml/2006/main" r:embed="R0c704e0af6df47a0"/>
+          <a:blip xmlns:r="http://schemas.openxmlformats.org/officeDocument/2006/relationships" xmlns:a="http://schemas.openxmlformats.org/drawingml/2006/main" r:embed="R7c62a02885ea4f47"/>
           <a:stretch xmlns:a="http://schemas.openxmlformats.org/drawingml/2006/main"/>
         </p:blipFill>
         <p:spPr>
@@ -10860,7 +11204,7 @@
                 <a:ea typeface="Calibri"/>
                 <a:cs typeface="Calibri"/>
               </a:rPr>
-              <a:t>Рабочая сеть сохраняет производительность</a:t>
+              <a:t>В серии deadlock наблюдался только без арбитра</a:t>
             </a:r>
           </a:p>
         </p:txBody>
@@ -10905,7 +11249,7 @@
           <p:nvPr/>
         </p:nvPicPr>
         <p:blipFill>
-          <a:blip xmlns:r="http://schemas.openxmlformats.org/officeDocument/2006/relationships" xmlns:a="http://schemas.openxmlformats.org/drawingml/2006/main" r:embed="R16b3cb994a934173"/>
+          <a:blip xmlns:r="http://schemas.openxmlformats.org/officeDocument/2006/relationships" xmlns:a="http://schemas.openxmlformats.org/drawingml/2006/main" r:embed="Rcc3d3f7fe08845df"/>
           <a:stretch xmlns:a="http://schemas.openxmlformats.org/drawingml/2006/main"/>
         </p:blipFill>
         <p:spPr>
@@ -11041,13 +11385,13 @@
           <p:nvPr/>
         </p:nvPicPr>
         <p:blipFill>
-          <a:blip xmlns:r="http://schemas.openxmlformats.org/officeDocument/2006/relationships" xmlns:a="http://schemas.openxmlformats.org/drawingml/2006/main" r:embed="Raa7e41dc71154b80"/>
+          <a:blip xmlns:r="http://schemas.openxmlformats.org/officeDocument/2006/relationships" xmlns:a="http://schemas.openxmlformats.org/drawingml/2006/main" r:embed="R4aa38a3fe3954f3b"/>
           <a:stretch xmlns:a="http://schemas.openxmlformats.org/drawingml/2006/main"/>
         </p:blipFill>
         <p:spPr>
           <a:xfrm xmlns:a="http://schemas.openxmlformats.org/drawingml/2006/main">
-            <a:off x="476250" y="1804194"/>
-            <a:ext cx="7477125" cy="3240088"/>
+            <a:off x="476250" y="1106329"/>
+            <a:ext cx="7477125" cy="4635818"/>
           </a:xfrm>
           <a:prstGeom xmlns:a="http://schemas.openxmlformats.org/drawingml/2006/main" prst="rect">
             <a:avLst/>
@@ -11106,7 +11450,7 @@
                 <a:ea typeface="Calibri"/>
                 <a:cs typeface="Calibri"/>
               </a:rPr>
-              <a:t>При λL = 2:</a:t>
+              <a:t>Доля остановок:</a:t>
             </a:r>
           </a:p>
           <a:p xmlns:a="http://schemas.openxmlformats.org/drawingml/2006/main">
@@ -11148,7 +11492,7 @@
                 <a:ea typeface="Calibri"/>
                 <a:cs typeface="Calibri"/>
               </a:rPr>
-              <a:t>29–31 приём пищи</a:t>
+              <a:t>Классическая: 1,0</a:t>
             </a:r>
           </a:p>
           <a:p xmlns:a="http://schemas.openxmlformats.org/drawingml/2006/main">
@@ -11158,9 +11502,6 @@
                 <a:solidFill>
                   <a:srgbClr val="17232D"/>
                 </a:solidFill>
-                <a:latin typeface="Calibri"/>
-                <a:ea typeface="Calibri"/>
-                <a:cs typeface="Calibri"/>
               </a:defRPr>
             </a:pPr>
             <a:r>
@@ -11168,11 +11509,8 @@
                 <a:solidFill>
                   <a:srgbClr val="17232D"/>
                 </a:solidFill>
-                <a:latin typeface="Calibri"/>
-                <a:ea typeface="Calibri"/>
-                <a:cs typeface="Calibri"/>
-              </a:rPr>
-              <a:t>в среднем.</a:t>
+              </a:rPr>
+              <a:t/>
             </a:r>
           </a:p>
           <a:p xmlns:a="http://schemas.openxmlformats.org/drawingml/2006/main">
@@ -11182,6 +11520,9 @@
                 <a:solidFill>
                   <a:srgbClr val="17232D"/>
                 </a:solidFill>
+                <a:latin typeface="Calibri"/>
+                <a:ea typeface="Calibri"/>
+                <a:cs typeface="Calibri"/>
               </a:defRPr>
             </a:pPr>
             <a:r>
@@ -11189,6 +11530,27 @@
                 <a:solidFill>
                   <a:srgbClr val="17232D"/>
                 </a:solidFill>
+                <a:latin typeface="Calibri"/>
+                <a:ea typeface="Calibri"/>
+                <a:cs typeface="Calibri"/>
+              </a:rPr>
+              <a:t>С арбитром: 0,0</a:t>
+            </a:r>
+          </a:p>
+          <a:p xmlns:a="http://schemas.openxmlformats.org/drawingml/2006/main">
+            <a:pPr algn="l">
+              <a:buNone/>
+              <a:defRPr sz="1725" b="0">
+                <a:solidFill>
+                  <a:srgbClr val="17232D"/>
+                </a:solidFill>
+              </a:defRPr>
+            </a:pPr>
+            <a:r>
+              <a:rPr sz="1725" b="0">
+                <a:solidFill>
+                  <a:srgbClr val="17232D"/>
+                </a:solidFill>
               </a:rPr>
               <a:t/>
             </a:r>
@@ -11214,31 +11576,7 @@
                 <a:ea typeface="Calibri"/>
                 <a:cs typeface="Calibri"/>
               </a:rPr>
-              <a:t>Индекс Джейна:</a:t>
-            </a:r>
-          </a:p>
-          <a:p xmlns:a="http://schemas.openxmlformats.org/drawingml/2006/main">
-            <a:pPr algn="l">
-              <a:buNone/>
-              <a:defRPr sz="1725" b="0">
-                <a:solidFill>
-                  <a:srgbClr val="17232D"/>
-                </a:solidFill>
-                <a:latin typeface="Calibri"/>
-                <a:ea typeface="Calibri"/>
-                <a:cs typeface="Calibri"/>
-              </a:defRPr>
-            </a:pPr>
-            <a:r>
-              <a:rPr sz="1725" b="0">
-                <a:solidFill>
-                  <a:srgbClr val="17232D"/>
-                </a:solidFill>
-                <a:latin typeface="Calibri"/>
-                <a:ea typeface="Calibri"/>
-                <a:cs typeface="Calibri"/>
-              </a:rPr>
-              <a:t>0,83–0,94.</a:t>
+              <a:t>Всего 960 прогонов.</a:t>
             </a:r>
           </a:p>
         </p:txBody>
@@ -11295,7 +11633,7 @@
                 <a:ea typeface="Calibri"/>
                 <a:cs typeface="Calibri"/>
               </a:rPr>
-              <a:t>Увеличение числа участников распределяет ограниченный ресурс между большим числом философов.</a:t>
+              <a:t>Это наблюдаемая частота на заданном горизонте, а не оценка для всех возможных запусков.</a:t>
             </a:r>
           </a:p>
         </p:txBody>
@@ -11331,10 +11669,10 @@
       </p:grpSpPr>
       <p:sp>
         <p:nvSpPr>
-          <p:cNvPr id="12" name="top-band">
-            <a:extLst xmlns:a="http://schemas.openxmlformats.org/drawingml/2006/main">
-              <a:ext uri="{FF2B5EF4-FFF2-40B4-BE49-F238E27FC236}">
-                <a16:creationId xmlns:a16="http://schemas.microsoft.com/office/drawing/2014/main" id="{AF2585DF-AC5B-4323-9E8D-F5DD6ADEA7E0}"/>
+          <p:cNvPr id="11" name="top-band">
+            <a:extLst xmlns:a="http://schemas.openxmlformats.org/drawingml/2006/main">
+              <a:ext uri="{FF2B5EF4-FFF2-40B4-BE49-F238E27FC236}">
+                <a16:creationId xmlns:a16="http://schemas.microsoft.com/office/drawing/2014/main" id="{4B71F5F6-248A-493A-BFF4-DB5B4A22A606}"/>
               </a:ext>
             </a:extLst>
           </p:cNvPr>
@@ -11365,7 +11703,7 @@
           <p:cNvPr id="2" name="top-accent">
             <a:extLst xmlns:a="http://schemas.openxmlformats.org/drawingml/2006/main">
               <a:ext uri="{FF2B5EF4-FFF2-40B4-BE49-F238E27FC236}">
-                <a16:creationId xmlns:a16="http://schemas.microsoft.com/office/drawing/2014/main" id="{F961FBD9-A3D3-4B4D-8148-6A8EA0582EC5}"/>
+                <a16:creationId xmlns:a16="http://schemas.microsoft.com/office/drawing/2014/main" id="{BB5CB7FF-FF77-40E6-A4F7-D6586C902A95}"/>
               </a:ext>
             </a:extLst>
           </p:cNvPr>
@@ -11396,7 +11734,7 @@
           <p:cNvPr id="3" name="slide-title">
             <a:extLst xmlns:a="http://schemas.openxmlformats.org/drawingml/2006/main">
               <a:ext uri="{FF2B5EF4-FFF2-40B4-BE49-F238E27FC236}">
-                <a16:creationId xmlns:a16="http://schemas.microsoft.com/office/drawing/2014/main" id="{611B50FA-2F33-49D5-92A3-2006E35CA51B}"/>
+                <a16:creationId xmlns:a16="http://schemas.microsoft.com/office/drawing/2014/main" id="{22042EA1-0509-47F7-86ED-55527639D76A}"/>
               </a:ext>
             </a:extLst>
           </p:cNvPr>
@@ -11443,7 +11781,7 @@
                 <a:ea typeface="Calibri"/>
                 <a:cs typeface="Calibri"/>
               </a:rPr>
-              <a:t>Блокноты сохраняют код и фактические результаты</a:t>
+              <a:t>Рабочая сеть сохраняет производительность</a:t>
             </a:r>
           </a:p>
         </p:txBody>
@@ -11453,7 +11791,7 @@
           <p:cNvPr id="4" name="footer-rule">
             <a:extLst xmlns:a="http://schemas.openxmlformats.org/drawingml/2006/main">
               <a:ext uri="{FF2B5EF4-FFF2-40B4-BE49-F238E27FC236}">
-                <a16:creationId xmlns:a16="http://schemas.microsoft.com/office/drawing/2014/main" id="{A624C76B-A866-4FC3-BD4F-676A5F42372C}"/>
+                <a16:creationId xmlns:a16="http://schemas.microsoft.com/office/drawing/2014/main" id="{B0DFCD4F-FB53-4C73-8295-9DB007AEAF7C}"/>
               </a:ext>
             </a:extLst>
           </p:cNvPr>
@@ -11481,14 +11819,14 @@
       </p:sp>
       <p:pic>
         <p:nvPicPr>
-          <p:cNvPr id="20" name=""/>
+          <p:cNvPr id="18" name=""/>
           <p:cNvPicPr>
             <a:picLocks xmlns:a="http://schemas.openxmlformats.org/drawingml/2006/main" noChangeAspect="1"/>
           </p:cNvPicPr>
           <p:nvPr/>
         </p:nvPicPr>
         <p:blipFill>
-          <a:blip xmlns:r="http://schemas.openxmlformats.org/officeDocument/2006/relationships" xmlns:a="http://schemas.openxmlformats.org/drawingml/2006/main" r:embed="R25ed79029fbb4c5b"/>
+          <a:blip xmlns:r="http://schemas.openxmlformats.org/officeDocument/2006/relationships" xmlns:a="http://schemas.openxmlformats.org/drawingml/2006/main" r:embed="R088bf822c39142b7"/>
           <a:stretch xmlns:a="http://schemas.openxmlformats.org/drawingml/2006/main"/>
         </p:blipFill>
         <p:spPr>
@@ -11506,7 +11844,7 @@
           <p:cNvPr id="6" name="footer">
             <a:extLst xmlns:a="http://schemas.openxmlformats.org/drawingml/2006/main">
               <a:ext uri="{FF2B5EF4-FFF2-40B4-BE49-F238E27FC236}">
-                <a16:creationId xmlns:a16="http://schemas.microsoft.com/office/drawing/2014/main" id="{8F359995-F295-4F48-BFC9-5FDCEDF7972C}"/>
+                <a16:creationId xmlns:a16="http://schemas.microsoft.com/office/drawing/2014/main" id="{07E8B0EB-4DA1-4111-8E40-6CB1D9B0DDB1}"/>
               </a:ext>
             </a:extLst>
           </p:cNvPr>
@@ -11563,7 +11901,7 @@
           <p:cNvPr id="7" name="page-number">
             <a:extLst xmlns:a="http://schemas.openxmlformats.org/drawingml/2006/main">
               <a:ext uri="{FF2B5EF4-FFF2-40B4-BE49-F238E27FC236}">
-                <a16:creationId xmlns:a16="http://schemas.microsoft.com/office/drawing/2014/main" id="{018B0D7C-16CB-40EC-970C-B3565A5F931F}"/>
+                <a16:creationId xmlns:a16="http://schemas.microsoft.com/office/drawing/2014/main" id="{1C622E43-05B3-40DE-ABF3-C03225595873}"/>
               </a:ext>
             </a:extLst>
           </p:cNvPr>
@@ -11617,66 +11955,44 @@
       </p:sp>
       <p:pic>
         <p:nvPicPr>
-          <p:cNvPr id="23" name=""/>
+          <p:cNvPr id="21" name=""/>
           <p:cNvPicPr>
             <a:picLocks xmlns:a="http://schemas.openxmlformats.org/drawingml/2006/main" noChangeAspect="1"/>
           </p:cNvPicPr>
           <p:nvPr/>
         </p:nvPicPr>
         <p:blipFill>
-          <a:blip xmlns:r="http://schemas.openxmlformats.org/officeDocument/2006/relationships" xmlns:a="http://schemas.openxmlformats.org/drawingml/2006/main" r:embed="Ra3fa54a79a1a4895"/>
+          <a:blip xmlns:r="http://schemas.openxmlformats.org/officeDocument/2006/relationships" xmlns:a="http://schemas.openxmlformats.org/drawingml/2006/main" r:embed="R893d23a828874121"/>
           <a:stretch xmlns:a="http://schemas.openxmlformats.org/drawingml/2006/main"/>
         </p:blipFill>
         <p:spPr>
           <a:xfrm xmlns:a="http://schemas.openxmlformats.org/drawingml/2006/main">
-            <a:off x="495300" y="1640086"/>
-            <a:ext cx="5429250" cy="3053953"/>
+            <a:off x="476250" y="1804194"/>
+            <a:ext cx="7477125" cy="3240088"/>
           </a:xfrm>
           <a:prstGeom xmlns:a="http://schemas.openxmlformats.org/drawingml/2006/main" prst="rect">
             <a:avLst/>
           </a:prstGeom>
         </p:spPr>
       </p:pic>
-      <p:pic>
-        <p:nvPicPr>
-          <p:cNvPr id="24" name=""/>
-          <p:cNvPicPr>
-            <a:picLocks xmlns:a="http://schemas.openxmlformats.org/drawingml/2006/main" noChangeAspect="1"/>
-          </p:cNvPicPr>
-          <p:nvPr/>
-        </p:nvPicPr>
-        <p:blipFill>
-          <a:blip xmlns:r="http://schemas.openxmlformats.org/officeDocument/2006/relationships" xmlns:a="http://schemas.openxmlformats.org/drawingml/2006/main" r:embed="R71f52d2fde4c4e74"/>
-          <a:stretch xmlns:a="http://schemas.openxmlformats.org/drawingml/2006/main"/>
-        </p:blipFill>
-        <p:spPr>
-          <a:xfrm xmlns:a="http://schemas.openxmlformats.org/drawingml/2006/main">
-            <a:off x="6267450" y="1640086"/>
-            <a:ext cx="5429250" cy="3053953"/>
-          </a:xfrm>
-          <a:prstGeom xmlns:a="http://schemas.openxmlformats.org/drawingml/2006/main" prst="rect">
-            <a:avLst/>
-          </a:prstGeom>
-        </p:spPr>
-      </p:pic>
-      <p:sp>
-        <p:nvSpPr>
-          <p:cNvPr id="10" name="sir-label">
-            <a:extLst xmlns:a="http://schemas.openxmlformats.org/drawingml/2006/main">
-              <a:ext uri="{FF2B5EF4-FFF2-40B4-BE49-F238E27FC236}">
-                <a16:creationId xmlns:a16="http://schemas.microsoft.com/office/drawing/2014/main" id="{2E8BCE43-1A01-4261-B5EA-2E52C7151B22}"/>
-              </a:ext>
-            </a:extLst>
-          </p:cNvPr>
-          <p:cNvSpPr>
-            <a:spLocks xmlns:a="http://schemas.openxmlformats.org/drawingml/2006/main" noGrp="1"/>
-          </p:cNvSpPr>
-          <p:nvPr/>
-        </p:nvSpPr>
-        <p:spPr>
-          <a:xfrm xmlns:a="http://schemas.openxmlformats.org/drawingml/2006/main">
-            <a:off x="1809750" y="5410200"/>
-            <a:ext cx="2762250" cy="400050"/>
+      <p:sp>
+        <p:nvSpPr>
+          <p:cNvPr id="9" name="scan-table">
+            <a:extLst xmlns:a="http://schemas.openxmlformats.org/drawingml/2006/main">
+              <a:ext uri="{FF2B5EF4-FFF2-40B4-BE49-F238E27FC236}">
+                <a16:creationId xmlns:a16="http://schemas.microsoft.com/office/drawing/2014/main" id="{B690B6A6-A35B-4EFA-A6BD-EF554132BD91}"/>
+              </a:ext>
+            </a:extLst>
+          </p:cNvPr>
+          <p:cNvSpPr>
+            <a:spLocks xmlns:a="http://schemas.openxmlformats.org/drawingml/2006/main" noGrp="1"/>
+          </p:cNvSpPr>
+          <p:nvPr/>
+        </p:nvSpPr>
+        <p:spPr>
+          <a:xfrm xmlns:a="http://schemas.openxmlformats.org/drawingml/2006/main">
+            <a:off x="8334375" y="1257300"/>
+            <a:ext cx="2686050" cy="2381250"/>
           </a:xfrm>
           <a:prstGeom xmlns:a="http://schemas.openxmlformats.org/drawingml/2006/main" prst="rect">
             <a:avLst/>
@@ -11691,9 +12007,198 @@
           <a:bodyPr xmlns:a="http://schemas.openxmlformats.org/drawingml/2006/main" lIns="91440" tIns="45720" rIns="91440" bIns="45720" anchor="ctr"/>
           <a:lstStyle xmlns:a="http://schemas.openxmlformats.org/drawingml/2006/main"/>
           <a:p xmlns:a="http://schemas.openxmlformats.org/drawingml/2006/main">
+            <a:pPr algn="l">
+              <a:buNone/>
+              <a:defRPr sz="1725" b="0">
+                <a:solidFill>
+                  <a:srgbClr val="17232D"/>
+                </a:solidFill>
+                <a:latin typeface="Calibri"/>
+                <a:ea typeface="Calibri"/>
+                <a:cs typeface="Calibri"/>
+              </a:defRPr>
+            </a:pPr>
+            <a:r>
+              <a:rPr sz="1725" b="0">
+                <a:solidFill>
+                  <a:srgbClr val="17232D"/>
+                </a:solidFill>
+                <a:latin typeface="Calibri"/>
+                <a:ea typeface="Calibri"/>
+                <a:cs typeface="Calibri"/>
+              </a:rPr>
+              <a:t>При λL = 2:</a:t>
+            </a:r>
+          </a:p>
+          <a:p xmlns:a="http://schemas.openxmlformats.org/drawingml/2006/main">
+            <a:pPr algn="l">
+              <a:buNone/>
+              <a:defRPr sz="1725" b="0">
+                <a:solidFill>
+                  <a:srgbClr val="17232D"/>
+                </a:solidFill>
+              </a:defRPr>
+            </a:pPr>
+            <a:r>
+              <a:rPr sz="1725" b="0">
+                <a:solidFill>
+                  <a:srgbClr val="17232D"/>
+                </a:solidFill>
+              </a:rPr>
+              <a:t/>
+            </a:r>
+          </a:p>
+          <a:p xmlns:a="http://schemas.openxmlformats.org/drawingml/2006/main">
+            <a:pPr algn="l">
+              <a:buNone/>
+              <a:defRPr sz="1725" b="0">
+                <a:solidFill>
+                  <a:srgbClr val="17232D"/>
+                </a:solidFill>
+                <a:latin typeface="Calibri"/>
+                <a:ea typeface="Calibri"/>
+                <a:cs typeface="Calibri"/>
+              </a:defRPr>
+            </a:pPr>
+            <a:r>
+              <a:rPr sz="1725" b="0">
+                <a:solidFill>
+                  <a:srgbClr val="17232D"/>
+                </a:solidFill>
+                <a:latin typeface="Calibri"/>
+                <a:ea typeface="Calibri"/>
+                <a:cs typeface="Calibri"/>
+              </a:rPr>
+              <a:t>29–31 приём пищи</a:t>
+            </a:r>
+          </a:p>
+          <a:p xmlns:a="http://schemas.openxmlformats.org/drawingml/2006/main">
+            <a:pPr algn="l">
+              <a:buNone/>
+              <a:defRPr sz="1725" b="0">
+                <a:solidFill>
+                  <a:srgbClr val="17232D"/>
+                </a:solidFill>
+                <a:latin typeface="Calibri"/>
+                <a:ea typeface="Calibri"/>
+                <a:cs typeface="Calibri"/>
+              </a:defRPr>
+            </a:pPr>
+            <a:r>
+              <a:rPr sz="1725" b="0">
+                <a:solidFill>
+                  <a:srgbClr val="17232D"/>
+                </a:solidFill>
+                <a:latin typeface="Calibri"/>
+                <a:ea typeface="Calibri"/>
+                <a:cs typeface="Calibri"/>
+              </a:rPr>
+              <a:t>в среднем.</a:t>
+            </a:r>
+          </a:p>
+          <a:p xmlns:a="http://schemas.openxmlformats.org/drawingml/2006/main">
+            <a:pPr algn="l">
+              <a:buNone/>
+              <a:defRPr sz="1725" b="0">
+                <a:solidFill>
+                  <a:srgbClr val="17232D"/>
+                </a:solidFill>
+              </a:defRPr>
+            </a:pPr>
+            <a:r>
+              <a:rPr sz="1725" b="0">
+                <a:solidFill>
+                  <a:srgbClr val="17232D"/>
+                </a:solidFill>
+              </a:rPr>
+              <a:t/>
+            </a:r>
+          </a:p>
+          <a:p xmlns:a="http://schemas.openxmlformats.org/drawingml/2006/main">
+            <a:pPr algn="l">
+              <a:buNone/>
+              <a:defRPr sz="1725" b="0">
+                <a:solidFill>
+                  <a:srgbClr val="17232D"/>
+                </a:solidFill>
+                <a:latin typeface="Calibri"/>
+                <a:ea typeface="Calibri"/>
+                <a:cs typeface="Calibri"/>
+              </a:defRPr>
+            </a:pPr>
+            <a:r>
+              <a:rPr sz="1725" b="0">
+                <a:solidFill>
+                  <a:srgbClr val="17232D"/>
+                </a:solidFill>
+                <a:latin typeface="Calibri"/>
+                <a:ea typeface="Calibri"/>
+                <a:cs typeface="Calibri"/>
+              </a:rPr>
+              <a:t>Индекс Джейна:</a:t>
+            </a:r>
+          </a:p>
+          <a:p xmlns:a="http://schemas.openxmlformats.org/drawingml/2006/main">
+            <a:pPr algn="l">
+              <a:buNone/>
+              <a:defRPr sz="1725" b="0">
+                <a:solidFill>
+                  <a:srgbClr val="17232D"/>
+                </a:solidFill>
+                <a:latin typeface="Calibri"/>
+                <a:ea typeface="Calibri"/>
+                <a:cs typeface="Calibri"/>
+              </a:defRPr>
+            </a:pPr>
+            <a:r>
+              <a:rPr sz="1725" b="0">
+                <a:solidFill>
+                  <a:srgbClr val="17232D"/>
+                </a:solidFill>
+                <a:latin typeface="Calibri"/>
+                <a:ea typeface="Calibri"/>
+                <a:cs typeface="Calibri"/>
+              </a:rPr>
+              <a:t>0,83–0,94.</a:t>
+            </a:r>
+          </a:p>
+        </p:txBody>
+      </p:sp>
+      <p:sp>
+        <p:nvSpPr>
+          <p:cNvPr id="10" name="scan-takeaway">
+            <a:extLst xmlns:a="http://schemas.openxmlformats.org/drawingml/2006/main">
+              <a:ext uri="{FF2B5EF4-FFF2-40B4-BE49-F238E27FC236}">
+                <a16:creationId xmlns:a16="http://schemas.microsoft.com/office/drawing/2014/main" id="{8005A1C6-3D7F-4B44-8EF5-7DFA0DF1E7E4}"/>
+              </a:ext>
+            </a:extLst>
+          </p:cNvPr>
+          <p:cNvSpPr>
+            <a:spLocks xmlns:a="http://schemas.openxmlformats.org/drawingml/2006/main" noGrp="1"/>
+          </p:cNvSpPr>
+          <p:nvPr/>
+        </p:nvSpPr>
+        <p:spPr>
+          <a:xfrm xmlns:a="http://schemas.openxmlformats.org/drawingml/2006/main">
+            <a:off x="8143875" y="4000500"/>
+            <a:ext cx="3124200" cy="1200150"/>
+          </a:xfrm>
+          <a:prstGeom xmlns:a="http://schemas.openxmlformats.org/drawingml/2006/main" prst="rect">
+            <a:avLst/>
+          </a:prstGeom>
+          <a:noFill xmlns:a="http://schemas.openxmlformats.org/drawingml/2006/main"/>
+          <a:ln xmlns:a="http://schemas.openxmlformats.org/drawingml/2006/main" w="0">
+            <a:noFill/>
+            <a:prstDash val="solid"/>
+          </a:ln>
+        </p:spPr>
+        <p:txBody>
+          <a:bodyPr xmlns:a="http://schemas.openxmlformats.org/drawingml/2006/main" lIns="91440" tIns="45720" rIns="91440" bIns="45720" anchor="ctr"/>
+          <a:lstStyle xmlns:a="http://schemas.openxmlformats.org/drawingml/2006/main"/>
+          <a:p xmlns:a="http://schemas.openxmlformats.org/drawingml/2006/main">
             <a:pPr algn="ctr">
               <a:buNone/>
-              <a:defRPr sz="1575" b="1">
+              <a:defRPr sz="1650" b="1">
                 <a:solidFill>
                   <a:srgbClr val="0B4778"/>
                 </a:solidFill>
@@ -11703,7 +12208,7 @@
               </a:defRPr>
             </a:pPr>
             <a:r>
-              <a:rPr sz="1575" b="1">
+              <a:rPr sz="1650" b="1">
                 <a:solidFill>
                   <a:srgbClr val="0B4778"/>
                 </a:solidFill>
@@ -11711,64 +12216,7 @@
                 <a:ea typeface="Calibri"/>
                 <a:cs typeface="Calibri"/>
               </a:rPr>
-              <a:t>Базовая траектория</a:t>
-            </a:r>
-          </a:p>
-        </p:txBody>
-      </p:sp>
-      <p:sp>
-        <p:nvSpPr>
-          <p:cNvPr id="11" name="lv-label">
-            <a:extLst xmlns:a="http://schemas.openxmlformats.org/drawingml/2006/main">
-              <a:ext uri="{FF2B5EF4-FFF2-40B4-BE49-F238E27FC236}">
-                <a16:creationId xmlns:a16="http://schemas.microsoft.com/office/drawing/2014/main" id="{9A8A30A9-3164-4FDB-BCBF-1144A37924B6}"/>
-              </a:ext>
-            </a:extLst>
-          </p:cNvPr>
-          <p:cNvSpPr>
-            <a:spLocks xmlns:a="http://schemas.openxmlformats.org/drawingml/2006/main" noGrp="1"/>
-          </p:cNvSpPr>
-          <p:nvPr/>
-        </p:nvSpPr>
-        <p:spPr>
-          <a:xfrm xmlns:a="http://schemas.openxmlformats.org/drawingml/2006/main">
-            <a:off x="7477125" y="5410200"/>
-            <a:ext cx="3048000" cy="400050"/>
-          </a:xfrm>
-          <a:prstGeom xmlns:a="http://schemas.openxmlformats.org/drawingml/2006/main" prst="rect">
-            <a:avLst/>
-          </a:prstGeom>
-          <a:noFill xmlns:a="http://schemas.openxmlformats.org/drawingml/2006/main"/>
-          <a:ln xmlns:a="http://schemas.openxmlformats.org/drawingml/2006/main" w="0">
-            <a:noFill/>
-            <a:prstDash val="solid"/>
-          </a:ln>
-        </p:spPr>
-        <p:txBody>
-          <a:bodyPr xmlns:a="http://schemas.openxmlformats.org/drawingml/2006/main" lIns="91440" tIns="45720" rIns="91440" bIns="45720" anchor="ctr"/>
-          <a:lstStyle xmlns:a="http://schemas.openxmlformats.org/drawingml/2006/main"/>
-          <a:p xmlns:a="http://schemas.openxmlformats.org/drawingml/2006/main">
-            <a:pPr algn="ctr">
-              <a:buNone/>
-              <a:defRPr sz="1575" b="1">
-                <a:solidFill>
-                  <a:srgbClr val="0B4778"/>
-                </a:solidFill>
-                <a:latin typeface="Calibri"/>
-                <a:ea typeface="Calibri"/>
-                <a:cs typeface="Calibri"/>
-              </a:defRPr>
-            </a:pPr>
-            <a:r>
-              <a:rPr sz="1575" b="1">
-                <a:solidFill>
-                  <a:srgbClr val="0B4778"/>
-                </a:solidFill>
-                <a:latin typeface="Calibri"/>
-                <a:ea typeface="Calibri"/>
-                <a:cs typeface="Calibri"/>
-              </a:rPr>
-              <a:t>Параметрическая серия</a:t>
+              <a:t>Увеличение числа участников распределяет ограниченный ресурс между большим числом философов.</a:t>
             </a:r>
           </a:p>
         </p:txBody>
@@ -11776,7 +12224,7 @@
     </p:spTree>
     <p:extLst>
       <p:ext uri="{BB962C8B-B14F-4D97-AF65-F5344CB8AC3E}">
-        <p14:creationId xmlns:p14="http://schemas.microsoft.com/office/powerpoint/2010/main" val="413898477"/>
+        <p14:creationId xmlns:p14="http://schemas.microsoft.com/office/powerpoint/2010/main" val="1575332896"/>
       </p:ext>
     </p:extLst>
   </p:cSld>
@@ -11804,10 +12252,10 @@
       </p:grpSpPr>
       <p:sp>
         <p:nvSpPr>
-          <p:cNvPr id="10" name="top-band">
-            <a:extLst xmlns:a="http://schemas.openxmlformats.org/drawingml/2006/main">
-              <a:ext uri="{FF2B5EF4-FFF2-40B4-BE49-F238E27FC236}">
-                <a16:creationId xmlns:a16="http://schemas.microsoft.com/office/drawing/2014/main" id="{6D573241-9EE9-4DF9-8086-F9A4F38D199C}"/>
+          <p:cNvPr id="12" name="top-band">
+            <a:extLst xmlns:a="http://schemas.openxmlformats.org/drawingml/2006/main">
+              <a:ext uri="{FF2B5EF4-FFF2-40B4-BE49-F238E27FC236}">
+                <a16:creationId xmlns:a16="http://schemas.microsoft.com/office/drawing/2014/main" id="{AF2585DF-AC5B-4323-9E8D-F5DD6ADEA7E0}"/>
               </a:ext>
             </a:extLst>
           </p:cNvPr>
@@ -11838,7 +12286,7 @@
           <p:cNvPr id="2" name="top-accent">
             <a:extLst xmlns:a="http://schemas.openxmlformats.org/drawingml/2006/main">
               <a:ext uri="{FF2B5EF4-FFF2-40B4-BE49-F238E27FC236}">
-                <a16:creationId xmlns:a16="http://schemas.microsoft.com/office/drawing/2014/main" id="{FF6378DF-5E8F-4722-97E0-1107CA5B62BB}"/>
+                <a16:creationId xmlns:a16="http://schemas.microsoft.com/office/drawing/2014/main" id="{F961FBD9-A3D3-4B4D-8148-6A8EA0582EC5}"/>
               </a:ext>
             </a:extLst>
           </p:cNvPr>
@@ -11869,7 +12317,7 @@
           <p:cNvPr id="3" name="slide-title">
             <a:extLst xmlns:a="http://schemas.openxmlformats.org/drawingml/2006/main">
               <a:ext uri="{FF2B5EF4-FFF2-40B4-BE49-F238E27FC236}">
-                <a16:creationId xmlns:a16="http://schemas.microsoft.com/office/drawing/2014/main" id="{6DD81CC7-CBD2-4703-970A-156532EFA1E9}"/>
+                <a16:creationId xmlns:a16="http://schemas.microsoft.com/office/drawing/2014/main" id="{611B50FA-2F33-49D5-92A3-2006E35CA51B}"/>
               </a:ext>
             </a:extLst>
           </p:cNvPr>
@@ -11916,7 +12364,7 @@
                 <a:ea typeface="Calibri"/>
                 <a:cs typeface="Calibri"/>
               </a:rPr>
-              <a:t>Все 23 теста модели пройдены</a:t>
+              <a:t>Блокноты сохраняют код и фактические результаты</a:t>
             </a:r>
           </a:p>
         </p:txBody>
@@ -11926,7 +12374,7 @@
           <p:cNvPr id="4" name="footer-rule">
             <a:extLst xmlns:a="http://schemas.openxmlformats.org/drawingml/2006/main">
               <a:ext uri="{FF2B5EF4-FFF2-40B4-BE49-F238E27FC236}">
-                <a16:creationId xmlns:a16="http://schemas.microsoft.com/office/drawing/2014/main" id="{F606674E-824A-4C30-AC07-9394E7D209DA}"/>
+                <a16:creationId xmlns:a16="http://schemas.microsoft.com/office/drawing/2014/main" id="{A624C76B-A866-4FC3-BD4F-676A5F42372C}"/>
               </a:ext>
             </a:extLst>
           </p:cNvPr>
@@ -11951,142 +12399,6 @@
             <a:prstDash val="solid"/>
           </a:ln>
         </p:spPr>
-      </p:sp>
-      <p:pic>
-        <p:nvPicPr>
-          <p:cNvPr id="17" name=""/>
-          <p:cNvPicPr>
-            <a:picLocks xmlns:a="http://schemas.openxmlformats.org/drawingml/2006/main" noChangeAspect="1"/>
-          </p:cNvPicPr>
-          <p:nvPr/>
-        </p:nvPicPr>
-        <p:blipFill>
-          <a:blip xmlns:r="http://schemas.openxmlformats.org/officeDocument/2006/relationships" xmlns:a="http://schemas.openxmlformats.org/drawingml/2006/main" r:embed="R20fbeeffce924ec7"/>
-          <a:stretch xmlns:a="http://schemas.openxmlformats.org/drawingml/2006/main"/>
-        </p:blipFill>
-        <p:spPr>
-          <a:xfrm xmlns:a="http://schemas.openxmlformats.org/drawingml/2006/main">
-            <a:off x="552450" y="6495443"/>
-            <a:ext cx="304800" cy="258389"/>
-          </a:xfrm>
-          <a:prstGeom xmlns:a="http://schemas.openxmlformats.org/drawingml/2006/main" prst="rect">
-            <a:avLst/>
-          </a:prstGeom>
-        </p:spPr>
-      </p:pic>
-      <p:sp>
-        <p:nvSpPr>
-          <p:cNvPr id="6" name="footer">
-            <a:extLst xmlns:a="http://schemas.openxmlformats.org/drawingml/2006/main">
-              <a:ext uri="{FF2B5EF4-FFF2-40B4-BE49-F238E27FC236}">
-                <a16:creationId xmlns:a16="http://schemas.microsoft.com/office/drawing/2014/main" id="{5B26CBF1-396E-4033-AAF9-489271389BCC}"/>
-              </a:ext>
-            </a:extLst>
-          </p:cNvPr>
-          <p:cNvSpPr>
-            <a:spLocks xmlns:a="http://schemas.openxmlformats.org/drawingml/2006/main" noGrp="1"/>
-          </p:cNvSpPr>
-          <p:nvPr/>
-        </p:nvSpPr>
-        <p:spPr>
-          <a:xfrm xmlns:a="http://schemas.openxmlformats.org/drawingml/2006/main">
-            <a:off x="971550" y="6486525"/>
-            <a:ext cx="7334250" cy="257175"/>
-          </a:xfrm>
-          <a:prstGeom xmlns:a="http://schemas.openxmlformats.org/drawingml/2006/main" prst="rect">
-            <a:avLst/>
-          </a:prstGeom>
-          <a:noFill xmlns:a="http://schemas.openxmlformats.org/drawingml/2006/main"/>
-          <a:ln xmlns:a="http://schemas.openxmlformats.org/drawingml/2006/main" w="0">
-            <a:noFill/>
-            <a:prstDash val="solid"/>
-          </a:ln>
-        </p:spPr>
-        <p:txBody>
-          <a:bodyPr xmlns:a="http://schemas.openxmlformats.org/drawingml/2006/main" lIns="91440" tIns="45720" rIns="91440" bIns="45720" anchor="ctr"/>
-          <a:lstStyle xmlns:a="http://schemas.openxmlformats.org/drawingml/2006/main"/>
-          <a:p xmlns:a="http://schemas.openxmlformats.org/drawingml/2006/main">
-            <a:pPr algn="l">
-              <a:buNone/>
-              <a:defRPr sz="900" b="0">
-                <a:solidFill>
-                  <a:srgbClr val="526675"/>
-                </a:solidFill>
-                <a:latin typeface="Calibri"/>
-                <a:ea typeface="Calibri"/>
-                <a:cs typeface="Calibri"/>
-              </a:defRPr>
-            </a:pPr>
-            <a:r>
-              <a:rPr sz="900" b="0">
-                <a:solidFill>
-                  <a:srgbClr val="526675"/>
-                </a:solidFill>
-                <a:latin typeface="Calibri"/>
-                <a:ea typeface="Calibri"/>
-                <a:cs typeface="Calibri"/>
-              </a:rPr>
-              <a:t>Имитационное моделирование · лабораторная работа № 5</a:t>
-            </a:r>
-          </a:p>
-        </p:txBody>
-      </p:sp>
-      <p:sp>
-        <p:nvSpPr>
-          <p:cNvPr id="7" name="page-number">
-            <a:extLst xmlns:a="http://schemas.openxmlformats.org/drawingml/2006/main">
-              <a:ext uri="{FF2B5EF4-FFF2-40B4-BE49-F238E27FC236}">
-                <a16:creationId xmlns:a16="http://schemas.microsoft.com/office/drawing/2014/main" id="{A5627C61-6ADF-48E9-A24A-976D6E940B6B}"/>
-              </a:ext>
-            </a:extLst>
-          </p:cNvPr>
-          <p:cNvSpPr>
-            <a:spLocks xmlns:a="http://schemas.openxmlformats.org/drawingml/2006/main" noGrp="1"/>
-          </p:cNvSpPr>
-          <p:nvPr/>
-        </p:nvSpPr>
-        <p:spPr>
-          <a:xfrm xmlns:a="http://schemas.openxmlformats.org/drawingml/2006/main">
-            <a:off x="10820400" y="6486525"/>
-            <a:ext cx="800100" cy="257175"/>
-          </a:xfrm>
-          <a:prstGeom xmlns:a="http://schemas.openxmlformats.org/drawingml/2006/main" prst="rect">
-            <a:avLst/>
-          </a:prstGeom>
-          <a:noFill xmlns:a="http://schemas.openxmlformats.org/drawingml/2006/main"/>
-          <a:ln xmlns:a="http://schemas.openxmlformats.org/drawingml/2006/main" w="0">
-            <a:noFill/>
-            <a:prstDash val="solid"/>
-          </a:ln>
-        </p:spPr>
-        <p:txBody>
-          <a:bodyPr xmlns:a="http://schemas.openxmlformats.org/drawingml/2006/main" lIns="91440" tIns="45720" rIns="91440" bIns="45720" anchor="ctr"/>
-          <a:lstStyle xmlns:a="http://schemas.openxmlformats.org/drawingml/2006/main"/>
-          <a:p xmlns:a="http://schemas.openxmlformats.org/drawingml/2006/main">
-            <a:pPr algn="ctr">
-              <a:buNone/>
-              <a:defRPr sz="975" b="1">
-                <a:solidFill>
-                  <a:srgbClr val="0B4778"/>
-                </a:solidFill>
-                <a:latin typeface="Calibri"/>
-                <a:ea typeface="Calibri"/>
-                <a:cs typeface="Calibri"/>
-              </a:defRPr>
-            </a:pPr>
-            <a:r>
-              <a:rPr sz="975" b="1">
-                <a:solidFill>
-                  <a:srgbClr val="0B4778"/>
-                </a:solidFill>
-                <a:latin typeface="Calibri"/>
-                <a:ea typeface="Calibri"/>
-                <a:cs typeface="Calibri"/>
-              </a:rPr>
-              <a:t>22</a:t>
-            </a:r>
-          </a:p>
-        </p:txBody>
       </p:sp>
       <p:pic>
         <p:nvPicPr>
@@ -12097,13 +12409,13 @@
           <p:nvPr/>
         </p:nvPicPr>
         <p:blipFill>
-          <a:blip xmlns:r="http://schemas.openxmlformats.org/officeDocument/2006/relationships" xmlns:a="http://schemas.openxmlformats.org/drawingml/2006/main" r:embed="R336b46161f8444de"/>
+          <a:blip xmlns:r="http://schemas.openxmlformats.org/officeDocument/2006/relationships" xmlns:a="http://schemas.openxmlformats.org/drawingml/2006/main" r:embed="R4815ba224c8d4ed5"/>
           <a:stretch xmlns:a="http://schemas.openxmlformats.org/drawingml/2006/main"/>
         </p:blipFill>
         <p:spPr>
           <a:xfrm xmlns:a="http://schemas.openxmlformats.org/drawingml/2006/main">
-            <a:off x="514350" y="1241822"/>
-            <a:ext cx="7200900" cy="4050506"/>
+            <a:off x="552450" y="6495443"/>
+            <a:ext cx="304800" cy="258389"/>
           </a:xfrm>
           <a:prstGeom xmlns:a="http://schemas.openxmlformats.org/drawingml/2006/main" prst="rect">
             <a:avLst/>
@@ -12112,22 +12424,22 @@
       </p:pic>
       <p:sp>
         <p:nvSpPr>
-          <p:cNvPr id="9" name="test-list">
-            <a:extLst xmlns:a="http://schemas.openxmlformats.org/drawingml/2006/main">
-              <a:ext uri="{FF2B5EF4-FFF2-40B4-BE49-F238E27FC236}">
-                <a16:creationId xmlns:a16="http://schemas.microsoft.com/office/drawing/2014/main" id="{C4D7CFCF-E677-40A4-ABD8-F9C618B52751}"/>
-              </a:ext>
-            </a:extLst>
-          </p:cNvPr>
-          <p:cNvSpPr>
-            <a:spLocks xmlns:a="http://schemas.openxmlformats.org/drawingml/2006/main" noGrp="1"/>
-          </p:cNvSpPr>
-          <p:nvPr/>
-        </p:nvSpPr>
-        <p:spPr>
-          <a:xfrm xmlns:a="http://schemas.openxmlformats.org/drawingml/2006/main">
-            <a:off x="8096250" y="1257300"/>
-            <a:ext cx="3219450" cy="3676650"/>
+          <p:cNvPr id="6" name="footer">
+            <a:extLst xmlns:a="http://schemas.openxmlformats.org/drawingml/2006/main">
+              <a:ext uri="{FF2B5EF4-FFF2-40B4-BE49-F238E27FC236}">
+                <a16:creationId xmlns:a16="http://schemas.microsoft.com/office/drawing/2014/main" id="{8F359995-F295-4F48-BFC9-5FDCEDF7972C}"/>
+              </a:ext>
+            </a:extLst>
+          </p:cNvPr>
+          <p:cNvSpPr>
+            <a:spLocks xmlns:a="http://schemas.openxmlformats.org/drawingml/2006/main" noGrp="1"/>
+          </p:cNvSpPr>
+          <p:nvPr/>
+        </p:nvSpPr>
+        <p:spPr>
+          <a:xfrm xmlns:a="http://schemas.openxmlformats.org/drawingml/2006/main">
+            <a:off x="971550" y="6486525"/>
+            <a:ext cx="7334250" cy="257175"/>
           </a:xfrm>
           <a:prstGeom xmlns:a="http://schemas.openxmlformats.org/drawingml/2006/main" prst="rect">
             <a:avLst/>
@@ -12144,197 +12456,240 @@
           <a:p xmlns:a="http://schemas.openxmlformats.org/drawingml/2006/main">
             <a:pPr algn="l">
               <a:buNone/>
-              <a:defRPr sz="1650" b="0">
-                <a:solidFill>
-                  <a:srgbClr val="17232D"/>
-                </a:solidFill>
-                <a:latin typeface="Calibri"/>
-                <a:ea typeface="Calibri"/>
-                <a:cs typeface="Calibri"/>
-              </a:defRPr>
-            </a:pPr>
-            <a:r>
-              <a:rPr sz="1650" b="0">
-                <a:solidFill>
-                  <a:srgbClr val="17232D"/>
-                </a:solidFill>
-                <a:latin typeface="Calibri"/>
-                <a:ea typeface="Calibri"/>
-                <a:cs typeface="Calibri"/>
-              </a:rPr>
-              <a:t>✓ размерности сетей</a:t>
-            </a:r>
-          </a:p>
-          <a:p xmlns:a="http://schemas.openxmlformats.org/drawingml/2006/main">
-            <a:pPr algn="l">
-              <a:buNone/>
-              <a:defRPr sz="1650" b="0">
-                <a:solidFill>
-                  <a:srgbClr val="17232D"/>
-                </a:solidFill>
-                <a:latin typeface="Calibri"/>
-                <a:ea typeface="Calibri"/>
-                <a:cs typeface="Calibri"/>
-              </a:defRPr>
-            </a:pPr>
-            <a:r>
-              <a:rPr sz="1650" b="0">
-                <a:solidFill>
-                  <a:srgbClr val="17232D"/>
-                </a:solidFill>
-                <a:latin typeface="Calibri"/>
-                <a:ea typeface="Calibri"/>
-                <a:cs typeface="Calibri"/>
-              </a:rPr>
-              <a:t>✓ начальная маркировка</a:t>
-            </a:r>
-          </a:p>
-          <a:p xmlns:a="http://schemas.openxmlformats.org/drawingml/2006/main">
-            <a:pPr algn="l">
-              <a:defRPr sz="1650">
-                <a:solidFill>
-                  <a:srgbClr val="17232D"/>
-                </a:solidFill>
-                <a:latin typeface="Calibri"/>
-                <a:ea typeface="Calibri"/>
-                <a:cs typeface="Calibri"/>
-              </a:defRPr>
-            </a:pPr>
-            <a:r>
-              <a:rPr sz="1650">
-                <a:solidFill>
-                  <a:srgbClr val="17232D"/>
-                </a:solidFill>
-                <a:latin typeface="Calibri"/>
-                <a:ea typeface="Calibri"/>
-                <a:cs typeface="Calibri"/>
-              </a:rPr>
-              <a:t>✓ срабатывание событий</a:t>
-            </a:r>
-          </a:p>
-          <a:p xmlns:a="http://schemas.openxmlformats.org/drawingml/2006/main">
-            <a:pPr algn="l">
-              <a:buNone/>
-              <a:defRPr sz="1650" b="0">
-                <a:solidFill>
-                  <a:srgbClr val="17232D"/>
-                </a:solidFill>
-                <a:latin typeface="Calibri"/>
-                <a:ea typeface="Calibri"/>
-                <a:cs typeface="Calibri"/>
-              </a:defRPr>
-            </a:pPr>
-            <a:r>
-              <a:rPr sz="1650" b="0">
-                <a:solidFill>
-                  <a:srgbClr val="17232D"/>
-                </a:solidFill>
-                <a:latin typeface="Calibri"/>
-                <a:ea typeface="Calibri"/>
-                <a:cs typeface="Calibri"/>
-              </a:rPr>
-              <a:t>✓ известный deadlock</a:t>
-            </a:r>
-          </a:p>
-          <a:p xmlns:a="http://schemas.openxmlformats.org/drawingml/2006/main">
-            <a:pPr algn="l">
-              <a:buNone/>
-              <a:defRPr sz="1650" b="0">
-                <a:solidFill>
-                  <a:srgbClr val="17232D"/>
-                </a:solidFill>
-                <a:latin typeface="Calibri"/>
-                <a:ea typeface="Calibri"/>
-                <a:cs typeface="Calibri"/>
-              </a:defRPr>
-            </a:pPr>
-            <a:r>
-              <a:rPr sz="1650" b="0">
-                <a:solidFill>
-                  <a:srgbClr val="17232D"/>
-                </a:solidFill>
-                <a:latin typeface="Calibri"/>
-                <a:ea typeface="Calibri"/>
-                <a:cs typeface="Calibri"/>
-              </a:rPr>
-              <a:t>✓ активность арбитра</a:t>
-            </a:r>
-          </a:p>
-          <a:p xmlns:a="http://schemas.openxmlformats.org/drawingml/2006/main">
-            <a:pPr algn="l">
-              <a:buNone/>
-              <a:defRPr sz="1650" b="0">
-                <a:solidFill>
-                  <a:srgbClr val="17232D"/>
-                </a:solidFill>
-                <a:latin typeface="Calibri"/>
-                <a:ea typeface="Calibri"/>
-                <a:cs typeface="Calibri"/>
-              </a:defRPr>
-            </a:pPr>
-            <a:r>
-              <a:rPr sz="1650" b="0">
-                <a:solidFill>
-                  <a:srgbClr val="17232D"/>
-                </a:solidFill>
-                <a:latin typeface="Calibri"/>
-                <a:ea typeface="Calibri"/>
-                <a:cs typeface="Calibri"/>
-              </a:rPr>
-              <a:t>✓ неотрицательность</a:t>
-            </a:r>
-          </a:p>
-          <a:p xmlns:a="http://schemas.openxmlformats.org/drawingml/2006/main">
-            <a:pPr algn="l">
-              <a:buNone/>
-              <a:defRPr sz="1650" b="0">
-                <a:solidFill>
-                  <a:srgbClr val="17232D"/>
-                </a:solidFill>
-                <a:latin typeface="Calibri"/>
-                <a:ea typeface="Calibri"/>
-                <a:cs typeface="Calibri"/>
-              </a:defRPr>
-            </a:pPr>
-            <a:r>
-              <a:rPr sz="1650" b="0">
-                <a:solidFill>
-                  <a:srgbClr val="17232D"/>
-                </a:solidFill>
-                <a:latin typeface="Calibri"/>
-                <a:ea typeface="Calibri"/>
-                <a:cs typeface="Calibri"/>
-              </a:rPr>
-              <a:t>✓ ODE и индекс Джейна</a:t>
-            </a:r>
-          </a:p>
-          <a:p xmlns:a="http://schemas.openxmlformats.org/drawingml/2006/main">
-            <a:r>
-              <a:t/>
-            </a:r>
-          </a:p>
-          <a:p xmlns:a="http://schemas.openxmlformats.org/drawingml/2006/main">
-            <a:pPr algn="l">
-              <a:buNone/>
-              <a:defRPr sz="1650" b="0">
-                <a:solidFill>
-                  <a:srgbClr val="17232D"/>
-                </a:solidFill>
-                <a:latin typeface="Calibri"/>
-                <a:ea typeface="Calibri"/>
-                <a:cs typeface="Calibri"/>
-              </a:defRPr>
-            </a:pPr>
-            <a:r>
-              <a:rPr sz="1650" b="0">
-                <a:solidFill>
-                  <a:srgbClr val="17232D"/>
-                </a:solidFill>
-                <a:latin typeface="Calibri"/>
-                <a:ea typeface="Calibri"/>
-                <a:cs typeface="Calibri"/>
-              </a:rPr>
-              <a:t>Ошибок не обнаружено.</a:t>
+              <a:defRPr sz="900" b="0">
+                <a:solidFill>
+                  <a:srgbClr val="526675"/>
+                </a:solidFill>
+                <a:latin typeface="Calibri"/>
+                <a:ea typeface="Calibri"/>
+                <a:cs typeface="Calibri"/>
+              </a:defRPr>
+            </a:pPr>
+            <a:r>
+              <a:rPr sz="900" b="0">
+                <a:solidFill>
+                  <a:srgbClr val="526675"/>
+                </a:solidFill>
+                <a:latin typeface="Calibri"/>
+                <a:ea typeface="Calibri"/>
+                <a:cs typeface="Calibri"/>
+              </a:rPr>
+              <a:t>Имитационное моделирование · лабораторная работа № 5</a:t>
+            </a:r>
+          </a:p>
+        </p:txBody>
+      </p:sp>
+      <p:sp>
+        <p:nvSpPr>
+          <p:cNvPr id="7" name="page-number">
+            <a:extLst xmlns:a="http://schemas.openxmlformats.org/drawingml/2006/main">
+              <a:ext uri="{FF2B5EF4-FFF2-40B4-BE49-F238E27FC236}">
+                <a16:creationId xmlns:a16="http://schemas.microsoft.com/office/drawing/2014/main" id="{018B0D7C-16CB-40EC-970C-B3565A5F931F}"/>
+              </a:ext>
+            </a:extLst>
+          </p:cNvPr>
+          <p:cNvSpPr>
+            <a:spLocks xmlns:a="http://schemas.openxmlformats.org/drawingml/2006/main" noGrp="1"/>
+          </p:cNvSpPr>
+          <p:nvPr/>
+        </p:nvSpPr>
+        <p:spPr>
+          <a:xfrm xmlns:a="http://schemas.openxmlformats.org/drawingml/2006/main">
+            <a:off x="10820400" y="6486525"/>
+            <a:ext cx="800100" cy="257175"/>
+          </a:xfrm>
+          <a:prstGeom xmlns:a="http://schemas.openxmlformats.org/drawingml/2006/main" prst="rect">
+            <a:avLst/>
+          </a:prstGeom>
+          <a:noFill xmlns:a="http://schemas.openxmlformats.org/drawingml/2006/main"/>
+          <a:ln xmlns:a="http://schemas.openxmlformats.org/drawingml/2006/main" w="0">
+            <a:noFill/>
+            <a:prstDash val="solid"/>
+          </a:ln>
+        </p:spPr>
+        <p:txBody>
+          <a:bodyPr xmlns:a="http://schemas.openxmlformats.org/drawingml/2006/main" lIns="91440" tIns="45720" rIns="91440" bIns="45720" anchor="ctr"/>
+          <a:lstStyle xmlns:a="http://schemas.openxmlformats.org/drawingml/2006/main"/>
+          <a:p xmlns:a="http://schemas.openxmlformats.org/drawingml/2006/main">
+            <a:pPr algn="ctr">
+              <a:buNone/>
+              <a:defRPr sz="975" b="1">
+                <a:solidFill>
+                  <a:srgbClr val="0B4778"/>
+                </a:solidFill>
+                <a:latin typeface="Calibri"/>
+                <a:ea typeface="Calibri"/>
+                <a:cs typeface="Calibri"/>
+              </a:defRPr>
+            </a:pPr>
+            <a:r>
+              <a:rPr sz="975" b="1">
+                <a:solidFill>
+                  <a:srgbClr val="0B4778"/>
+                </a:solidFill>
+                <a:latin typeface="Calibri"/>
+                <a:ea typeface="Calibri"/>
+                <a:cs typeface="Calibri"/>
+              </a:rPr>
+              <a:t>22</a:t>
+            </a:r>
+          </a:p>
+        </p:txBody>
+      </p:sp>
+      <p:pic>
+        <p:nvPicPr>
+          <p:cNvPr id="23" name=""/>
+          <p:cNvPicPr>
+            <a:picLocks xmlns:a="http://schemas.openxmlformats.org/drawingml/2006/main" noChangeAspect="1"/>
+          </p:cNvPicPr>
+          <p:nvPr/>
+        </p:nvPicPr>
+        <p:blipFill>
+          <a:blip xmlns:r="http://schemas.openxmlformats.org/officeDocument/2006/relationships" xmlns:a="http://schemas.openxmlformats.org/drawingml/2006/main" r:embed="R8bab96a685cd47e0"/>
+          <a:stretch xmlns:a="http://schemas.openxmlformats.org/drawingml/2006/main"/>
+        </p:blipFill>
+        <p:spPr>
+          <a:xfrm xmlns:a="http://schemas.openxmlformats.org/drawingml/2006/main">
+            <a:off x="495300" y="1640086"/>
+            <a:ext cx="5429250" cy="3053953"/>
+          </a:xfrm>
+          <a:prstGeom xmlns:a="http://schemas.openxmlformats.org/drawingml/2006/main" prst="rect">
+            <a:avLst/>
+          </a:prstGeom>
+        </p:spPr>
+      </p:pic>
+      <p:pic>
+        <p:nvPicPr>
+          <p:cNvPr id="24" name=""/>
+          <p:cNvPicPr>
+            <a:picLocks xmlns:a="http://schemas.openxmlformats.org/drawingml/2006/main" noChangeAspect="1"/>
+          </p:cNvPicPr>
+          <p:nvPr/>
+        </p:nvPicPr>
+        <p:blipFill>
+          <a:blip xmlns:r="http://schemas.openxmlformats.org/officeDocument/2006/relationships" xmlns:a="http://schemas.openxmlformats.org/drawingml/2006/main" r:embed="R4dde686e8fee455a"/>
+          <a:stretch xmlns:a="http://schemas.openxmlformats.org/drawingml/2006/main"/>
+        </p:blipFill>
+        <p:spPr>
+          <a:xfrm xmlns:a="http://schemas.openxmlformats.org/drawingml/2006/main">
+            <a:off x="6267450" y="1640086"/>
+            <a:ext cx="5429250" cy="3053953"/>
+          </a:xfrm>
+          <a:prstGeom xmlns:a="http://schemas.openxmlformats.org/drawingml/2006/main" prst="rect">
+            <a:avLst/>
+          </a:prstGeom>
+        </p:spPr>
+      </p:pic>
+      <p:sp>
+        <p:nvSpPr>
+          <p:cNvPr id="10" name="sir-label">
+            <a:extLst xmlns:a="http://schemas.openxmlformats.org/drawingml/2006/main">
+              <a:ext uri="{FF2B5EF4-FFF2-40B4-BE49-F238E27FC236}">
+                <a16:creationId xmlns:a16="http://schemas.microsoft.com/office/drawing/2014/main" id="{2E8BCE43-1A01-4261-B5EA-2E52C7151B22}"/>
+              </a:ext>
+            </a:extLst>
+          </p:cNvPr>
+          <p:cNvSpPr>
+            <a:spLocks xmlns:a="http://schemas.openxmlformats.org/drawingml/2006/main" noGrp="1"/>
+          </p:cNvSpPr>
+          <p:nvPr/>
+        </p:nvSpPr>
+        <p:spPr>
+          <a:xfrm xmlns:a="http://schemas.openxmlformats.org/drawingml/2006/main">
+            <a:off x="1809750" y="5410200"/>
+            <a:ext cx="2762250" cy="400050"/>
+          </a:xfrm>
+          <a:prstGeom xmlns:a="http://schemas.openxmlformats.org/drawingml/2006/main" prst="rect">
+            <a:avLst/>
+          </a:prstGeom>
+          <a:noFill xmlns:a="http://schemas.openxmlformats.org/drawingml/2006/main"/>
+          <a:ln xmlns:a="http://schemas.openxmlformats.org/drawingml/2006/main" w="0">
+            <a:noFill/>
+            <a:prstDash val="solid"/>
+          </a:ln>
+        </p:spPr>
+        <p:txBody>
+          <a:bodyPr xmlns:a="http://schemas.openxmlformats.org/drawingml/2006/main" lIns="91440" tIns="45720" rIns="91440" bIns="45720" anchor="ctr"/>
+          <a:lstStyle xmlns:a="http://schemas.openxmlformats.org/drawingml/2006/main"/>
+          <a:p xmlns:a="http://schemas.openxmlformats.org/drawingml/2006/main">
+            <a:pPr algn="ctr">
+              <a:buNone/>
+              <a:defRPr sz="1575" b="1">
+                <a:solidFill>
+                  <a:srgbClr val="0B4778"/>
+                </a:solidFill>
+                <a:latin typeface="Calibri"/>
+                <a:ea typeface="Calibri"/>
+                <a:cs typeface="Calibri"/>
+              </a:defRPr>
+            </a:pPr>
+            <a:r>
+              <a:rPr sz="1575" b="1">
+                <a:solidFill>
+                  <a:srgbClr val="0B4778"/>
+                </a:solidFill>
+                <a:latin typeface="Calibri"/>
+                <a:ea typeface="Calibri"/>
+                <a:cs typeface="Calibri"/>
+              </a:rPr>
+              <a:t>Базовая траектория</a:t>
+            </a:r>
+          </a:p>
+        </p:txBody>
+      </p:sp>
+      <p:sp>
+        <p:nvSpPr>
+          <p:cNvPr id="11" name="lv-label">
+            <a:extLst xmlns:a="http://schemas.openxmlformats.org/drawingml/2006/main">
+              <a:ext uri="{FF2B5EF4-FFF2-40B4-BE49-F238E27FC236}">
+                <a16:creationId xmlns:a16="http://schemas.microsoft.com/office/drawing/2014/main" id="{9A8A30A9-3164-4FDB-BCBF-1144A37924B6}"/>
+              </a:ext>
+            </a:extLst>
+          </p:cNvPr>
+          <p:cNvSpPr>
+            <a:spLocks xmlns:a="http://schemas.openxmlformats.org/drawingml/2006/main" noGrp="1"/>
+          </p:cNvSpPr>
+          <p:nvPr/>
+        </p:nvSpPr>
+        <p:spPr>
+          <a:xfrm xmlns:a="http://schemas.openxmlformats.org/drawingml/2006/main">
+            <a:off x="7477125" y="5410200"/>
+            <a:ext cx="3048000" cy="400050"/>
+          </a:xfrm>
+          <a:prstGeom xmlns:a="http://schemas.openxmlformats.org/drawingml/2006/main" prst="rect">
+            <a:avLst/>
+          </a:prstGeom>
+          <a:noFill xmlns:a="http://schemas.openxmlformats.org/drawingml/2006/main"/>
+          <a:ln xmlns:a="http://schemas.openxmlformats.org/drawingml/2006/main" w="0">
+            <a:noFill/>
+            <a:prstDash val="solid"/>
+          </a:ln>
+        </p:spPr>
+        <p:txBody>
+          <a:bodyPr xmlns:a="http://schemas.openxmlformats.org/drawingml/2006/main" lIns="91440" tIns="45720" rIns="91440" bIns="45720" anchor="ctr"/>
+          <a:lstStyle xmlns:a="http://schemas.openxmlformats.org/drawingml/2006/main"/>
+          <a:p xmlns:a="http://schemas.openxmlformats.org/drawingml/2006/main">
+            <a:pPr algn="ctr">
+              <a:buNone/>
+              <a:defRPr sz="1575" b="1">
+                <a:solidFill>
+                  <a:srgbClr val="0B4778"/>
+                </a:solidFill>
+                <a:latin typeface="Calibri"/>
+                <a:ea typeface="Calibri"/>
+                <a:cs typeface="Calibri"/>
+              </a:defRPr>
+            </a:pPr>
+            <a:r>
+              <a:rPr sz="1575" b="1">
+                <a:solidFill>
+                  <a:srgbClr val="0B4778"/>
+                </a:solidFill>
+                <a:latin typeface="Calibri"/>
+                <a:ea typeface="Calibri"/>
+                <a:cs typeface="Calibri"/>
+              </a:rPr>
+              <a:t>Параметрическая серия</a:t>
             </a:r>
           </a:p>
         </p:txBody>
@@ -12342,7 +12697,7 @@
     </p:spTree>
     <p:extLst>
       <p:ext uri="{BB962C8B-B14F-4D97-AF65-F5344CB8AC3E}">
-        <p14:creationId xmlns:p14="http://schemas.microsoft.com/office/powerpoint/2010/main" val="60678283"/>
+        <p14:creationId xmlns:p14="http://schemas.microsoft.com/office/powerpoint/2010/main" val="413898477"/>
       </p:ext>
     </p:extLst>
   </p:cSld>
@@ -12355,7 +12710,7 @@
     <p:bg>
       <p:bgPr>
         <a:solidFill xmlns:a="http://schemas.openxmlformats.org/drawingml/2006/main">
-          <a:srgbClr val="0B4778"/>
+          <a:srgbClr val="FFFFFF"/>
         </a:solidFill>
       </p:bgPr>
     </p:bg>
@@ -12370,10 +12725,10 @@
       </p:grpSpPr>
       <p:sp>
         <p:nvSpPr>
-          <p:cNvPr id="7" name="accent">
-            <a:extLst xmlns:a="http://schemas.openxmlformats.org/drawingml/2006/main">
-              <a:ext uri="{FF2B5EF4-FFF2-40B4-BE49-F238E27FC236}">
-                <a16:creationId xmlns:a16="http://schemas.microsoft.com/office/drawing/2014/main" id="{7EDC123F-A2A1-4A23-B400-58E76A7A62D7}"/>
+          <p:cNvPr id="10" name="top-band">
+            <a:extLst xmlns:a="http://schemas.openxmlformats.org/drawingml/2006/main">
+              <a:ext uri="{FF2B5EF4-FFF2-40B4-BE49-F238E27FC236}">
+                <a16:creationId xmlns:a16="http://schemas.microsoft.com/office/drawing/2014/main" id="{6D573241-9EE9-4DF9-8086-F9A4F38D199C}"/>
               </a:ext>
             </a:extLst>
           </p:cNvPr>
@@ -12385,7 +12740,38 @@
         <p:spPr>
           <a:xfrm xmlns:a="http://schemas.openxmlformats.org/drawingml/2006/main">
             <a:off x="0" y="0"/>
-            <a:ext cx="133350" cy="6858000"/>
+            <a:ext cx="12192000" cy="628650"/>
+          </a:xfrm>
+          <a:prstGeom xmlns:a="http://schemas.openxmlformats.org/drawingml/2006/main" prst="rect">
+            <a:avLst/>
+          </a:prstGeom>
+          <a:solidFill xmlns:a="http://schemas.openxmlformats.org/drawingml/2006/main">
+            <a:srgbClr val="0B4778"/>
+          </a:solidFill>
+          <a:ln xmlns:a="http://schemas.openxmlformats.org/drawingml/2006/main" w="0">
+            <a:noFill/>
+            <a:prstDash val="solid"/>
+          </a:ln>
+        </p:spPr>
+      </p:sp>
+      <p:sp>
+        <p:nvSpPr>
+          <p:cNvPr id="2" name="top-accent">
+            <a:extLst xmlns:a="http://schemas.openxmlformats.org/drawingml/2006/main">
+              <a:ext uri="{FF2B5EF4-FFF2-40B4-BE49-F238E27FC236}">
+                <a16:creationId xmlns:a16="http://schemas.microsoft.com/office/drawing/2014/main" id="{FF6378DF-5E8F-4722-97E0-1107CA5B62BB}"/>
+              </a:ext>
+            </a:extLst>
+          </p:cNvPr>
+          <p:cNvSpPr>
+            <a:spLocks xmlns:a="http://schemas.openxmlformats.org/drawingml/2006/main" noGrp="1"/>
+          </p:cNvSpPr>
+          <p:nvPr/>
+        </p:nvSpPr>
+        <p:spPr>
+          <a:xfrm xmlns:a="http://schemas.openxmlformats.org/drawingml/2006/main">
+            <a:off x="0" y="628650"/>
+            <a:ext cx="12192000" cy="47625"/>
           </a:xfrm>
           <a:prstGeom xmlns:a="http://schemas.openxmlformats.org/drawingml/2006/main" prst="rect">
             <a:avLst/>
@@ -12399,22 +12785,110 @@
           </a:ln>
         </p:spPr>
       </p:sp>
+      <p:sp>
+        <p:nvSpPr>
+          <p:cNvPr id="3" name="slide-title">
+            <a:extLst xmlns:a="http://schemas.openxmlformats.org/drawingml/2006/main">
+              <a:ext uri="{FF2B5EF4-FFF2-40B4-BE49-F238E27FC236}">
+                <a16:creationId xmlns:a16="http://schemas.microsoft.com/office/drawing/2014/main" id="{6DD81CC7-CBD2-4703-970A-156532EFA1E9}"/>
+              </a:ext>
+            </a:extLst>
+          </p:cNvPr>
+          <p:cNvSpPr>
+            <a:spLocks xmlns:a="http://schemas.openxmlformats.org/drawingml/2006/main" noGrp="1"/>
+          </p:cNvSpPr>
+          <p:nvPr/>
+        </p:nvSpPr>
+        <p:spPr>
+          <a:xfrm xmlns:a="http://schemas.openxmlformats.org/drawingml/2006/main">
+            <a:off x="609600" y="57150"/>
+            <a:ext cx="10763250" cy="523875"/>
+          </a:xfrm>
+          <a:prstGeom xmlns:a="http://schemas.openxmlformats.org/drawingml/2006/main" prst="rect">
+            <a:avLst/>
+          </a:prstGeom>
+          <a:noFill xmlns:a="http://schemas.openxmlformats.org/drawingml/2006/main"/>
+          <a:ln xmlns:a="http://schemas.openxmlformats.org/drawingml/2006/main" w="0">
+            <a:noFill/>
+            <a:prstDash val="solid"/>
+          </a:ln>
+        </p:spPr>
+        <p:txBody>
+          <a:bodyPr xmlns:a="http://schemas.openxmlformats.org/drawingml/2006/main" lIns="91440" tIns="45720" rIns="91440" bIns="45720" anchor="ctr"/>
+          <a:lstStyle xmlns:a="http://schemas.openxmlformats.org/drawingml/2006/main"/>
+          <a:p xmlns:a="http://schemas.openxmlformats.org/drawingml/2006/main">
+            <a:pPr algn="l">
+              <a:buNone/>
+              <a:defRPr sz="2250" b="1">
+                <a:solidFill>
+                  <a:srgbClr val="FFFFFF"/>
+                </a:solidFill>
+                <a:latin typeface="Calibri"/>
+                <a:ea typeface="Calibri"/>
+                <a:cs typeface="Calibri"/>
+              </a:defRPr>
+            </a:pPr>
+            <a:r>
+              <a:rPr sz="2250" b="1">
+                <a:solidFill>
+                  <a:srgbClr val="FFFFFF"/>
+                </a:solidFill>
+                <a:latin typeface="Calibri"/>
+                <a:ea typeface="Calibri"/>
+                <a:cs typeface="Calibri"/>
+              </a:rPr>
+              <a:t>Все 56 проверок модели пройдены</a:t>
+            </a:r>
+          </a:p>
+        </p:txBody>
+      </p:sp>
+      <p:sp>
+        <p:nvSpPr>
+          <p:cNvPr id="4" name="footer-rule">
+            <a:extLst xmlns:a="http://schemas.openxmlformats.org/drawingml/2006/main">
+              <a:ext uri="{FF2B5EF4-FFF2-40B4-BE49-F238E27FC236}">
+                <a16:creationId xmlns:a16="http://schemas.microsoft.com/office/drawing/2014/main" id="{F606674E-824A-4C30-AC07-9394E7D209DA}"/>
+              </a:ext>
+            </a:extLst>
+          </p:cNvPr>
+          <p:cNvSpPr>
+            <a:spLocks xmlns:a="http://schemas.openxmlformats.org/drawingml/2006/main" noGrp="1"/>
+          </p:cNvSpPr>
+          <p:nvPr/>
+        </p:nvSpPr>
+        <p:spPr>
+          <a:xfrm xmlns:a="http://schemas.openxmlformats.org/drawingml/2006/main">
+            <a:off x="514350" y="6419850"/>
+            <a:ext cx="11163300" cy="19050"/>
+          </a:xfrm>
+          <a:prstGeom xmlns:a="http://schemas.openxmlformats.org/drawingml/2006/main" prst="rect">
+            <a:avLst/>
+          </a:prstGeom>
+          <a:solidFill xmlns:a="http://schemas.openxmlformats.org/drawingml/2006/main">
+            <a:srgbClr val="B9D9E8"/>
+          </a:solidFill>
+          <a:ln xmlns:a="http://schemas.openxmlformats.org/drawingml/2006/main" w="0">
+            <a:noFill/>
+            <a:prstDash val="solid"/>
+          </a:ln>
+        </p:spPr>
+      </p:sp>
       <p:pic>
         <p:nvPicPr>
-          <p:cNvPr id="10" name=""/>
+          <p:cNvPr id="17" name=""/>
           <p:cNvPicPr>
             <a:picLocks xmlns:a="http://schemas.openxmlformats.org/drawingml/2006/main" noChangeAspect="1"/>
           </p:cNvPicPr>
           <p:nvPr/>
         </p:nvPicPr>
         <p:blipFill>
-          <a:blip xmlns:r="http://schemas.openxmlformats.org/officeDocument/2006/relationships" xmlns:a="http://schemas.openxmlformats.org/drawingml/2006/main" r:embed="R8f15656585e74b47"/>
+          <a:blip xmlns:r="http://schemas.openxmlformats.org/officeDocument/2006/relationships" xmlns:a="http://schemas.openxmlformats.org/drawingml/2006/main" r:embed="R3addc9e78a5e470e"/>
           <a:stretch xmlns:a="http://schemas.openxmlformats.org/drawingml/2006/main"/>
         </p:blipFill>
         <p:spPr>
           <a:xfrm xmlns:a="http://schemas.openxmlformats.org/drawingml/2006/main">
-            <a:off x="742950" y="716689"/>
-            <a:ext cx="781050" cy="662123"/>
+            <a:off x="552450" y="6495443"/>
+            <a:ext cx="304800" cy="258389"/>
           </a:xfrm>
           <a:prstGeom xmlns:a="http://schemas.openxmlformats.org/drawingml/2006/main" prst="rect">
             <a:avLst/>
@@ -12423,22 +12897,22 @@
       </p:pic>
       <p:sp>
         <p:nvSpPr>
-          <p:cNvPr id="3" name="conclusion-title">
-            <a:extLst xmlns:a="http://schemas.openxmlformats.org/drawingml/2006/main">
-              <a:ext uri="{FF2B5EF4-FFF2-40B4-BE49-F238E27FC236}">
-                <a16:creationId xmlns:a16="http://schemas.microsoft.com/office/drawing/2014/main" id="{05B54D60-5BA6-4B1C-AA38-11674D76AE8D}"/>
-              </a:ext>
-            </a:extLst>
-          </p:cNvPr>
-          <p:cNvSpPr>
-            <a:spLocks xmlns:a="http://schemas.openxmlformats.org/drawingml/2006/main" noGrp="1"/>
-          </p:cNvSpPr>
-          <p:nvPr/>
-        </p:nvSpPr>
-        <p:spPr>
-          <a:xfrm xmlns:a="http://schemas.openxmlformats.org/drawingml/2006/main">
-            <a:off x="1943100" y="723900"/>
-            <a:ext cx="8858250" cy="1257300"/>
+          <p:cNvPr id="6" name="footer">
+            <a:extLst xmlns:a="http://schemas.openxmlformats.org/drawingml/2006/main">
+              <a:ext uri="{FF2B5EF4-FFF2-40B4-BE49-F238E27FC236}">
+                <a16:creationId xmlns:a16="http://schemas.microsoft.com/office/drawing/2014/main" id="{5B26CBF1-396E-4033-AAF9-489271389BCC}"/>
+              </a:ext>
+            </a:extLst>
+          </p:cNvPr>
+          <p:cNvSpPr>
+            <a:spLocks xmlns:a="http://schemas.openxmlformats.org/drawingml/2006/main" noGrp="1"/>
+          </p:cNvSpPr>
+          <p:nvPr/>
+        </p:nvSpPr>
+        <p:spPr>
+          <a:xfrm xmlns:a="http://schemas.openxmlformats.org/drawingml/2006/main">
+            <a:off x="971550" y="6486525"/>
+            <a:ext cx="7334250" cy="257175"/>
           </a:xfrm>
           <a:prstGeom xmlns:a="http://schemas.openxmlformats.org/drawingml/2006/main" prst="rect">
             <a:avLst/>
@@ -12455,78 +12929,47 @@
           <a:p xmlns:a="http://schemas.openxmlformats.org/drawingml/2006/main">
             <a:pPr algn="l">
               <a:buNone/>
-              <a:defRPr sz="3150" b="1">
-                <a:solidFill>
-                  <a:srgbClr val="FFFFFF"/>
-                </a:solidFill>
-                <a:latin typeface="Calibri"/>
-                <a:ea typeface="Calibri"/>
-                <a:cs typeface="Calibri"/>
-              </a:defRPr>
-            </a:pPr>
-            <a:r>
-              <a:rPr sz="3150" b="1">
-                <a:solidFill>
-                  <a:srgbClr val="FFFFFF"/>
-                </a:solidFill>
-                <a:latin typeface="Calibri"/>
-                <a:ea typeface="Calibri"/>
-                <a:cs typeface="Calibri"/>
-              </a:rPr>
-              <a:t>Заключение</a:t>
-            </a:r>
-          </a:p>
-        </p:txBody>
-      </p:sp>
-      <p:sp>
-        <p:nvSpPr>
-          <p:cNvPr id="4" name="conclusion-rule">
-            <a:extLst xmlns:a="http://schemas.openxmlformats.org/drawingml/2006/main">
-              <a:ext uri="{FF2B5EF4-FFF2-40B4-BE49-F238E27FC236}">
-                <a16:creationId xmlns:a16="http://schemas.microsoft.com/office/drawing/2014/main" id="{A6F50DB3-5845-402B-875A-F3D971960FB8}"/>
-              </a:ext>
-            </a:extLst>
-          </p:cNvPr>
-          <p:cNvSpPr>
-            <a:spLocks xmlns:a="http://schemas.openxmlformats.org/drawingml/2006/main" noGrp="1"/>
-          </p:cNvSpPr>
-          <p:nvPr/>
-        </p:nvSpPr>
-        <p:spPr>
-          <a:xfrm xmlns:a="http://schemas.openxmlformats.org/drawingml/2006/main">
-            <a:off x="1943100" y="2133600"/>
-            <a:ext cx="6286500" cy="38100"/>
-          </a:xfrm>
-          <a:prstGeom xmlns:a="http://schemas.openxmlformats.org/drawingml/2006/main" prst="rect">
-            <a:avLst/>
-          </a:prstGeom>
-          <a:solidFill xmlns:a="http://schemas.openxmlformats.org/drawingml/2006/main">
-            <a:srgbClr val="35A9D3"/>
-          </a:solidFill>
-          <a:ln xmlns:a="http://schemas.openxmlformats.org/drawingml/2006/main" w="0">
-            <a:noFill/>
-            <a:prstDash val="solid"/>
-          </a:ln>
-        </p:spPr>
-      </p:sp>
-      <p:sp>
-        <p:nvSpPr>
-          <p:cNvPr id="5" name="conclusions">
-            <a:extLst xmlns:a="http://schemas.openxmlformats.org/drawingml/2006/main">
-              <a:ext uri="{FF2B5EF4-FFF2-40B4-BE49-F238E27FC236}">
-                <a16:creationId xmlns:a16="http://schemas.microsoft.com/office/drawing/2014/main" id="{80C76B1D-E492-4AF8-A98B-ACC10B47E441}"/>
-              </a:ext>
-            </a:extLst>
-          </p:cNvPr>
-          <p:cNvSpPr>
-            <a:spLocks xmlns:a="http://schemas.openxmlformats.org/drawingml/2006/main" noGrp="1"/>
-          </p:cNvSpPr>
-          <p:nvPr/>
-        </p:nvSpPr>
-        <p:spPr>
-          <a:xfrm xmlns:a="http://schemas.openxmlformats.org/drawingml/2006/main">
-            <a:off x="1943100" y="2552700"/>
-            <a:ext cx="8953500" cy="3219450"/>
+              <a:defRPr sz="900" b="0">
+                <a:solidFill>
+                  <a:srgbClr val="526675"/>
+                </a:solidFill>
+                <a:latin typeface="Calibri"/>
+                <a:ea typeface="Calibri"/>
+                <a:cs typeface="Calibri"/>
+              </a:defRPr>
+            </a:pPr>
+            <a:r>
+              <a:rPr sz="900" b="0">
+                <a:solidFill>
+                  <a:srgbClr val="526675"/>
+                </a:solidFill>
+                <a:latin typeface="Calibri"/>
+                <a:ea typeface="Calibri"/>
+                <a:cs typeface="Calibri"/>
+              </a:rPr>
+              <a:t>Имитационное моделирование · лабораторная работа № 5</a:t>
+            </a:r>
+          </a:p>
+        </p:txBody>
+      </p:sp>
+      <p:sp>
+        <p:nvSpPr>
+          <p:cNvPr id="7" name="page-number">
+            <a:extLst xmlns:a="http://schemas.openxmlformats.org/drawingml/2006/main">
+              <a:ext uri="{FF2B5EF4-FFF2-40B4-BE49-F238E27FC236}">
+                <a16:creationId xmlns:a16="http://schemas.microsoft.com/office/drawing/2014/main" id="{A5627C61-6ADF-48E9-A24A-976D6E940B6B}"/>
+              </a:ext>
+            </a:extLst>
+          </p:cNvPr>
+          <p:cNvSpPr>
+            <a:spLocks xmlns:a="http://schemas.openxmlformats.org/drawingml/2006/main" noGrp="1"/>
+          </p:cNvSpPr>
+          <p:nvPr/>
+        </p:nvSpPr>
+        <p:spPr>
+          <a:xfrm xmlns:a="http://schemas.openxmlformats.org/drawingml/2006/main">
+            <a:off x="10820400" y="6486525"/>
+            <a:ext cx="800100" cy="257175"/>
           </a:xfrm>
           <a:prstGeom xmlns:a="http://schemas.openxmlformats.org/drawingml/2006/main" prst="rect">
             <a:avLst/>
@@ -12541,27 +12984,249 @@
           <a:bodyPr xmlns:a="http://schemas.openxmlformats.org/drawingml/2006/main" lIns="91440" tIns="45720" rIns="91440" bIns="45720" anchor="ctr"/>
           <a:lstStyle xmlns:a="http://schemas.openxmlformats.org/drawingml/2006/main"/>
           <a:p xmlns:a="http://schemas.openxmlformats.org/drawingml/2006/main">
-            <a:pPr algn="l">
-              <a:buNone/>
-              <a:defRPr sz="1875" b="0">
-                <a:solidFill>
-                  <a:srgbClr val="FFFFFF"/>
-                </a:solidFill>
-                <a:latin typeface="Calibri"/>
-                <a:ea typeface="Calibri"/>
-                <a:cs typeface="Calibri"/>
-              </a:defRPr>
-            </a:pPr>
-            <a:r>
-              <a:rPr sz="1875" b="0">
-                <a:solidFill>
-                  <a:srgbClr val="FFFFFF"/>
-                </a:solidFill>
-                <a:latin typeface="Calibri"/>
-                <a:ea typeface="Calibri"/>
-                <a:cs typeface="Calibri"/>
-              </a:rPr>
-              <a:t>• Классическая стратегия допускает глобальную остановку.</a:t>
+            <a:pPr algn="ctr">
+              <a:buNone/>
+              <a:defRPr sz="975" b="1">
+                <a:solidFill>
+                  <a:srgbClr val="0B4778"/>
+                </a:solidFill>
+                <a:latin typeface="Calibri"/>
+                <a:ea typeface="Calibri"/>
+                <a:cs typeface="Calibri"/>
+              </a:defRPr>
+            </a:pPr>
+            <a:r>
+              <a:rPr sz="975" b="1">
+                <a:solidFill>
+                  <a:srgbClr val="0B4778"/>
+                </a:solidFill>
+                <a:latin typeface="Calibri"/>
+                <a:ea typeface="Calibri"/>
+                <a:cs typeface="Calibri"/>
+              </a:rPr>
+              <a:t>23</a:t>
+            </a:r>
+          </a:p>
+        </p:txBody>
+      </p:sp>
+      <p:pic>
+        <p:nvPicPr>
+          <p:cNvPr id="20" name=""/>
+          <p:cNvPicPr>
+            <a:picLocks xmlns:a="http://schemas.openxmlformats.org/drawingml/2006/main" noChangeAspect="1"/>
+          </p:cNvPicPr>
+          <p:nvPr/>
+        </p:nvPicPr>
+        <p:blipFill>
+          <a:blip xmlns:r="http://schemas.openxmlformats.org/officeDocument/2006/relationships" xmlns:a="http://schemas.openxmlformats.org/drawingml/2006/main" r:embed="R97aba65aa0e246dc"/>
+          <a:stretch xmlns:a="http://schemas.openxmlformats.org/drawingml/2006/main"/>
+        </p:blipFill>
+        <p:spPr>
+          <a:xfrm xmlns:a="http://schemas.openxmlformats.org/drawingml/2006/main">
+            <a:off x="514350" y="1241822"/>
+            <a:ext cx="7200900" cy="4050506"/>
+          </a:xfrm>
+          <a:prstGeom xmlns:a="http://schemas.openxmlformats.org/drawingml/2006/main" prst="rect">
+            <a:avLst/>
+          </a:prstGeom>
+        </p:spPr>
+      </p:pic>
+      <p:sp>
+        <p:nvSpPr>
+          <p:cNvPr id="9" name="test-list">
+            <a:extLst xmlns:a="http://schemas.openxmlformats.org/drawingml/2006/main">
+              <a:ext uri="{FF2B5EF4-FFF2-40B4-BE49-F238E27FC236}">
+                <a16:creationId xmlns:a16="http://schemas.microsoft.com/office/drawing/2014/main" id="{C4D7CFCF-E677-40A4-ABD8-F9C618B52751}"/>
+              </a:ext>
+            </a:extLst>
+          </p:cNvPr>
+          <p:cNvSpPr>
+            <a:spLocks xmlns:a="http://schemas.openxmlformats.org/drawingml/2006/main" noGrp="1"/>
+          </p:cNvSpPr>
+          <p:nvPr/>
+        </p:nvSpPr>
+        <p:spPr>
+          <a:xfrm xmlns:a="http://schemas.openxmlformats.org/drawingml/2006/main">
+            <a:off x="8096250" y="1257300"/>
+            <a:ext cx="3219450" cy="3676650"/>
+          </a:xfrm>
+          <a:prstGeom xmlns:a="http://schemas.openxmlformats.org/drawingml/2006/main" prst="rect">
+            <a:avLst/>
+          </a:prstGeom>
+          <a:noFill xmlns:a="http://schemas.openxmlformats.org/drawingml/2006/main"/>
+          <a:ln xmlns:a="http://schemas.openxmlformats.org/drawingml/2006/main" w="0">
+            <a:noFill/>
+            <a:prstDash val="solid"/>
+          </a:ln>
+        </p:spPr>
+        <p:txBody>
+          <a:bodyPr xmlns:a="http://schemas.openxmlformats.org/drawingml/2006/main" lIns="91440" tIns="45720" rIns="91440" bIns="45720" anchor="ctr"/>
+          <a:lstStyle xmlns:a="http://schemas.openxmlformats.org/drawingml/2006/main"/>
+          <a:p xmlns:a="http://schemas.openxmlformats.org/drawingml/2006/main">
+            <a:pPr algn="l">
+              <a:buNone/>
+              <a:defRPr sz="1650" b="0">
+                <a:solidFill>
+                  <a:srgbClr val="17232D"/>
+                </a:solidFill>
+                <a:latin typeface="Calibri"/>
+                <a:ea typeface="Calibri"/>
+                <a:cs typeface="Calibri"/>
+              </a:defRPr>
+            </a:pPr>
+            <a:r>
+              <a:rPr sz="1650" b="0">
+                <a:solidFill>
+                  <a:srgbClr val="17232D"/>
+                </a:solidFill>
+                <a:latin typeface="Calibri"/>
+                <a:ea typeface="Calibri"/>
+                <a:cs typeface="Calibri"/>
+              </a:rPr>
+              <a:t>✓ структура и переходы</a:t>
+            </a:r>
+          </a:p>
+          <a:p xmlns:a="http://schemas.openxmlformats.org/drawingml/2006/main">
+            <a:pPr algn="l">
+              <a:buNone/>
+              <a:defRPr sz="1650" b="0">
+                <a:solidFill>
+                  <a:srgbClr val="17232D"/>
+                </a:solidFill>
+                <a:latin typeface="Calibri"/>
+                <a:ea typeface="Calibri"/>
+                <a:cs typeface="Calibri"/>
+              </a:defRPr>
+            </a:pPr>
+            <a:r>
+              <a:rPr sz="1650" b="0">
+                <a:solidFill>
+                  <a:srgbClr val="17232D"/>
+                </a:solidFill>
+                <a:latin typeface="Calibri"/>
+                <a:ea typeface="Calibri"/>
+                <a:cs typeface="Calibri"/>
+              </a:rPr>
+              <a:t>✓ инварианты ресурсов</a:t>
+            </a:r>
+          </a:p>
+          <a:p xmlns:a="http://schemas.openxmlformats.org/drawingml/2006/main">
+            <a:pPr algn="l">
+              <a:defRPr sz="1650">
+                <a:solidFill>
+                  <a:srgbClr val="17232D"/>
+                </a:solidFill>
+                <a:latin typeface="Calibri"/>
+                <a:ea typeface="Calibri"/>
+                <a:cs typeface="Calibri"/>
+              </a:defRPr>
+            </a:pPr>
+            <a:r>
+              <a:rPr sz="1650">
+                <a:solidFill>
+                  <a:srgbClr val="17232D"/>
+                </a:solidFill>
+                <a:latin typeface="Calibri"/>
+                <a:ea typeface="Calibri"/>
+                <a:cs typeface="Calibri"/>
+              </a:rPr>
+              <a:t>✓ классический deadlock</a:t>
+            </a:r>
+          </a:p>
+          <a:p xmlns:a="http://schemas.openxmlformats.org/drawingml/2006/main">
+            <a:pPr algn="l">
+              <a:buNone/>
+              <a:defRPr sz="1650" b="0">
+                <a:solidFill>
+                  <a:srgbClr val="17232D"/>
+                </a:solidFill>
+                <a:latin typeface="Calibri"/>
+                <a:ea typeface="Calibri"/>
+                <a:cs typeface="Calibri"/>
+              </a:defRPr>
+            </a:pPr>
+            <a:r>
+              <a:rPr sz="1650" b="0">
+                <a:solidFill>
+                  <a:srgbClr val="17232D"/>
+                </a:solidFill>
+                <a:latin typeface="Calibri"/>
+                <a:ea typeface="Calibri"/>
+                <a:cs typeface="Calibri"/>
+              </a:rPr>
+              <a:t>✓ анимация при N = 3</a:t>
+            </a:r>
+          </a:p>
+          <a:p xmlns:a="http://schemas.openxmlformats.org/drawingml/2006/main">
+            <a:pPr algn="l">
+              <a:buNone/>
+              <a:defRPr sz="1650" b="0">
+                <a:solidFill>
+                  <a:srgbClr val="17232D"/>
+                </a:solidFill>
+                <a:latin typeface="Calibri"/>
+                <a:ea typeface="Calibri"/>
+                <a:cs typeface="Calibri"/>
+              </a:defRPr>
+            </a:pPr>
+            <a:r>
+              <a:rPr sz="1650" b="0">
+                <a:solidFill>
+                  <a:srgbClr val="17232D"/>
+                </a:solidFill>
+                <a:latin typeface="Calibri"/>
+                <a:ea typeface="Calibri"/>
+                <a:cs typeface="Calibri"/>
+              </a:rPr>
+              <a:t>✓ анализ сохранённых CSV</a:t>
+            </a:r>
+          </a:p>
+          <a:p xmlns:a="http://schemas.openxmlformats.org/drawingml/2006/main">
+            <a:pPr algn="l">
+              <a:buNone/>
+              <a:defRPr sz="1650" b="0">
+                <a:solidFill>
+                  <a:srgbClr val="17232D"/>
+                </a:solidFill>
+                <a:latin typeface="Calibri"/>
+                <a:ea typeface="Calibri"/>
+                <a:cs typeface="Calibri"/>
+              </a:defRPr>
+            </a:pPr>
+            <a:r>
+              <a:rPr sz="1650" b="0">
+                <a:solidFill>
+                  <a:srgbClr val="17232D"/>
+                </a:solidFill>
+                <a:latin typeface="Calibri"/>
+                <a:ea typeface="Calibri"/>
+                <a:cs typeface="Calibri"/>
+              </a:rPr>
+              <a:t>✓ ODE и индекс Джейна</a:t>
+            </a:r>
+          </a:p>
+          <a:p xmlns:a="http://schemas.openxmlformats.org/drawingml/2006/main">
+            <a:pPr algn="l">
+              <a:buNone/>
+              <a:defRPr sz="1650" b="0">
+                <a:solidFill>
+                  <a:srgbClr val="17232D"/>
+                </a:solidFill>
+                <a:latin typeface="Calibri"/>
+                <a:ea typeface="Calibri"/>
+                <a:cs typeface="Calibri"/>
+              </a:defRPr>
+            </a:pPr>
+            <a:r>
+              <a:rPr sz="1650" b="0">
+                <a:solidFill>
+                  <a:srgbClr val="17232D"/>
+                </a:solidFill>
+                <a:latin typeface="Calibri"/>
+                <a:ea typeface="Calibri"/>
+                <a:cs typeface="Calibri"/>
+              </a:rPr>
+              <a:t>✓ форматы 4 сценариев</a:t>
             </a:r>
           </a:p>
           <a:p xmlns:a="http://schemas.openxmlformats.org/drawingml/2006/main">
@@ -12572,111 +13237,25 @@
           <a:p xmlns:a="http://schemas.openxmlformats.org/drawingml/2006/main">
             <a:pPr algn="l">
               <a:buNone/>
-              <a:defRPr sz="1875" b="0">
-                <a:solidFill>
-                  <a:srgbClr val="FFFFFF"/>
-                </a:solidFill>
-                <a:latin typeface="Calibri"/>
-                <a:ea typeface="Calibri"/>
-                <a:cs typeface="Calibri"/>
-              </a:defRPr>
-            </a:pPr>
-            <a:r>
-              <a:rPr sz="1875" b="0">
-                <a:solidFill>
-                  <a:srgbClr val="FFFFFF"/>
-                </a:solidFill>
-                <a:latin typeface="Calibri"/>
-                <a:ea typeface="Calibri"/>
-                <a:cs typeface="Calibri"/>
-              </a:rPr>
-              <a:t>• Арбитр устраняет цикл захвата всех вилок.</a:t>
-            </a:r>
-          </a:p>
-          <a:p xmlns:a="http://schemas.openxmlformats.org/drawingml/2006/main">
-            <a:r>
-              <a:t/>
-            </a:r>
-          </a:p>
-          <a:p xmlns:a="http://schemas.openxmlformats.org/drawingml/2006/main">
-            <a:pPr algn="l">
-              <a:buNone/>
-              <a:defRPr sz="1875" b="0">
-                <a:solidFill>
-                  <a:srgbClr val="FFFFFF"/>
-                </a:solidFill>
-                <a:latin typeface="Calibri"/>
-                <a:ea typeface="Calibri"/>
-                <a:cs typeface="Calibri"/>
-              </a:defRPr>
-            </a:pPr>
-            <a:r>
-              <a:rPr sz="1875" b="0">
-                <a:solidFill>
-                  <a:srgbClr val="FFFFFF"/>
-                </a:solidFill>
-                <a:latin typeface="Calibri"/>
-                <a:ea typeface="Calibri"/>
-                <a:cs typeface="Calibri"/>
-              </a:rPr>
-              <a:t>• Данные, блокноты и тесты согласуются с устройством сети.</a:t>
-            </a:r>
-          </a:p>
-        </p:txBody>
-      </p:sp>
-      <p:sp>
-        <p:nvSpPr>
-          <p:cNvPr id="6" name="final">
-            <a:extLst xmlns:a="http://schemas.openxmlformats.org/drawingml/2006/main">
-              <a:ext uri="{FF2B5EF4-FFF2-40B4-BE49-F238E27FC236}">
-                <a16:creationId xmlns:a16="http://schemas.microsoft.com/office/drawing/2014/main" id="{FCC7524D-04B4-4E2B-BB4A-218A72DF3564}"/>
-              </a:ext>
-            </a:extLst>
-          </p:cNvPr>
-          <p:cNvSpPr>
-            <a:spLocks xmlns:a="http://schemas.openxmlformats.org/drawingml/2006/main" noGrp="1"/>
-          </p:cNvSpPr>
-          <p:nvPr/>
-        </p:nvSpPr>
-        <p:spPr>
-          <a:xfrm xmlns:a="http://schemas.openxmlformats.org/drawingml/2006/main">
-            <a:off x="1943100" y="5924550"/>
-            <a:ext cx="5715000" cy="495300"/>
-          </a:xfrm>
-          <a:prstGeom xmlns:a="http://schemas.openxmlformats.org/drawingml/2006/main" prst="rect">
-            <a:avLst/>
-          </a:prstGeom>
-          <a:noFill xmlns:a="http://schemas.openxmlformats.org/drawingml/2006/main"/>
-          <a:ln xmlns:a="http://schemas.openxmlformats.org/drawingml/2006/main" w="0">
-            <a:noFill/>
-            <a:prstDash val="solid"/>
-          </a:ln>
-        </p:spPr>
-        <p:txBody>
-          <a:bodyPr xmlns:a="http://schemas.openxmlformats.org/drawingml/2006/main" lIns="91440" tIns="45720" rIns="91440" bIns="45720" anchor="ctr"/>
-          <a:lstStyle xmlns:a="http://schemas.openxmlformats.org/drawingml/2006/main"/>
-          <a:p xmlns:a="http://schemas.openxmlformats.org/drawingml/2006/main">
-            <a:pPr algn="l">
-              <a:buNone/>
-              <a:defRPr sz="1650" b="1">
-                <a:solidFill>
-                  <a:srgbClr val="35A9D3"/>
-                </a:solidFill>
-                <a:latin typeface="Calibri"/>
-                <a:ea typeface="Calibri"/>
-                <a:cs typeface="Calibri"/>
-              </a:defRPr>
-            </a:pPr>
-            <a:r>
-              <a:rPr sz="1650" b="1">
-                <a:solidFill>
-                  <a:srgbClr val="35A9D3"/>
-                </a:solidFill>
-                <a:latin typeface="Calibri"/>
-                <a:ea typeface="Calibri"/>
-                <a:cs typeface="Calibri"/>
-              </a:rPr>
-              <a:t>Лабораторная работа № 5</a:t>
+              <a:defRPr sz="1650" b="0">
+                <a:solidFill>
+                  <a:srgbClr val="17232D"/>
+                </a:solidFill>
+                <a:latin typeface="Calibri"/>
+                <a:ea typeface="Calibri"/>
+                <a:cs typeface="Calibri"/>
+              </a:defRPr>
+            </a:pPr>
+            <a:r>
+              <a:rPr sz="1650" b="0">
+                <a:solidFill>
+                  <a:srgbClr val="17232D"/>
+                </a:solidFill>
+                <a:latin typeface="Calibri"/>
+                <a:ea typeface="Calibri"/>
+                <a:cs typeface="Calibri"/>
+              </a:rPr>
+              <a:t>Ошибок не обнаружено.</a:t>
             </a:r>
           </a:p>
         </p:txBody>
@@ -12684,7 +13263,7 @@
     </p:spTree>
     <p:extLst>
       <p:ext uri="{BB962C8B-B14F-4D97-AF65-F5344CB8AC3E}">
-        <p14:creationId xmlns:p14="http://schemas.microsoft.com/office/powerpoint/2010/main" val="509539714"/>
+        <p14:creationId xmlns:p14="http://schemas.microsoft.com/office/powerpoint/2010/main" val="60678283"/>
       </p:ext>
     </p:extLst>
   </p:cSld>
@@ -12750,7 +13329,349 @@
           <p:nvPr/>
         </p:nvPicPr>
         <p:blipFill>
-          <a:blip xmlns:r="http://schemas.openxmlformats.org/officeDocument/2006/relationships" xmlns:a="http://schemas.openxmlformats.org/drawingml/2006/main" r:embed="R134ab77165cc4fad"/>
+          <a:blip xmlns:r="http://schemas.openxmlformats.org/officeDocument/2006/relationships" xmlns:a="http://schemas.openxmlformats.org/drawingml/2006/main" r:embed="R417001dd062e4ab3"/>
+          <a:stretch xmlns:a="http://schemas.openxmlformats.org/drawingml/2006/main"/>
+        </p:blipFill>
+        <p:spPr>
+          <a:xfrm xmlns:a="http://schemas.openxmlformats.org/drawingml/2006/main">
+            <a:off x="742950" y="716689"/>
+            <a:ext cx="781050" cy="662123"/>
+          </a:xfrm>
+          <a:prstGeom xmlns:a="http://schemas.openxmlformats.org/drawingml/2006/main" prst="rect">
+            <a:avLst/>
+          </a:prstGeom>
+        </p:spPr>
+      </p:pic>
+      <p:sp>
+        <p:nvSpPr>
+          <p:cNvPr id="3" name="conclusion-title">
+            <a:extLst xmlns:a="http://schemas.openxmlformats.org/drawingml/2006/main">
+              <a:ext uri="{FF2B5EF4-FFF2-40B4-BE49-F238E27FC236}">
+                <a16:creationId xmlns:a16="http://schemas.microsoft.com/office/drawing/2014/main" id="{05B54D60-5BA6-4B1C-AA38-11674D76AE8D}"/>
+              </a:ext>
+            </a:extLst>
+          </p:cNvPr>
+          <p:cNvSpPr>
+            <a:spLocks xmlns:a="http://schemas.openxmlformats.org/drawingml/2006/main" noGrp="1"/>
+          </p:cNvSpPr>
+          <p:nvPr/>
+        </p:nvSpPr>
+        <p:spPr>
+          <a:xfrm xmlns:a="http://schemas.openxmlformats.org/drawingml/2006/main">
+            <a:off x="1943100" y="723900"/>
+            <a:ext cx="8858250" cy="1257300"/>
+          </a:xfrm>
+          <a:prstGeom xmlns:a="http://schemas.openxmlformats.org/drawingml/2006/main" prst="rect">
+            <a:avLst/>
+          </a:prstGeom>
+          <a:noFill xmlns:a="http://schemas.openxmlformats.org/drawingml/2006/main"/>
+          <a:ln xmlns:a="http://schemas.openxmlformats.org/drawingml/2006/main" w="0">
+            <a:noFill/>
+            <a:prstDash val="solid"/>
+          </a:ln>
+        </p:spPr>
+        <p:txBody>
+          <a:bodyPr xmlns:a="http://schemas.openxmlformats.org/drawingml/2006/main" lIns="91440" tIns="45720" rIns="91440" bIns="45720" anchor="ctr"/>
+          <a:lstStyle xmlns:a="http://schemas.openxmlformats.org/drawingml/2006/main"/>
+          <a:p xmlns:a="http://schemas.openxmlformats.org/drawingml/2006/main">
+            <a:pPr algn="l">
+              <a:buNone/>
+              <a:defRPr sz="3150" b="1">
+                <a:solidFill>
+                  <a:srgbClr val="FFFFFF"/>
+                </a:solidFill>
+                <a:latin typeface="Calibri"/>
+                <a:ea typeface="Calibri"/>
+                <a:cs typeface="Calibri"/>
+              </a:defRPr>
+            </a:pPr>
+            <a:r>
+              <a:rPr sz="3150" b="1">
+                <a:solidFill>
+                  <a:srgbClr val="FFFFFF"/>
+                </a:solidFill>
+                <a:latin typeface="Calibri"/>
+                <a:ea typeface="Calibri"/>
+                <a:cs typeface="Calibri"/>
+              </a:rPr>
+              <a:t>Заключение</a:t>
+            </a:r>
+          </a:p>
+        </p:txBody>
+      </p:sp>
+      <p:sp>
+        <p:nvSpPr>
+          <p:cNvPr id="4" name="conclusion-rule">
+            <a:extLst xmlns:a="http://schemas.openxmlformats.org/drawingml/2006/main">
+              <a:ext uri="{FF2B5EF4-FFF2-40B4-BE49-F238E27FC236}">
+                <a16:creationId xmlns:a16="http://schemas.microsoft.com/office/drawing/2014/main" id="{A6F50DB3-5845-402B-875A-F3D971960FB8}"/>
+              </a:ext>
+            </a:extLst>
+          </p:cNvPr>
+          <p:cNvSpPr>
+            <a:spLocks xmlns:a="http://schemas.openxmlformats.org/drawingml/2006/main" noGrp="1"/>
+          </p:cNvSpPr>
+          <p:nvPr/>
+        </p:nvSpPr>
+        <p:spPr>
+          <a:xfrm xmlns:a="http://schemas.openxmlformats.org/drawingml/2006/main">
+            <a:off x="1943100" y="2133600"/>
+            <a:ext cx="6286500" cy="38100"/>
+          </a:xfrm>
+          <a:prstGeom xmlns:a="http://schemas.openxmlformats.org/drawingml/2006/main" prst="rect">
+            <a:avLst/>
+          </a:prstGeom>
+          <a:solidFill xmlns:a="http://schemas.openxmlformats.org/drawingml/2006/main">
+            <a:srgbClr val="35A9D3"/>
+          </a:solidFill>
+          <a:ln xmlns:a="http://schemas.openxmlformats.org/drawingml/2006/main" w="0">
+            <a:noFill/>
+            <a:prstDash val="solid"/>
+          </a:ln>
+        </p:spPr>
+      </p:sp>
+      <p:sp>
+        <p:nvSpPr>
+          <p:cNvPr id="5" name="conclusions">
+            <a:extLst xmlns:a="http://schemas.openxmlformats.org/drawingml/2006/main">
+              <a:ext uri="{FF2B5EF4-FFF2-40B4-BE49-F238E27FC236}">
+                <a16:creationId xmlns:a16="http://schemas.microsoft.com/office/drawing/2014/main" id="{80C76B1D-E492-4AF8-A98B-ACC10B47E441}"/>
+              </a:ext>
+            </a:extLst>
+          </p:cNvPr>
+          <p:cNvSpPr>
+            <a:spLocks xmlns:a="http://schemas.openxmlformats.org/drawingml/2006/main" noGrp="1"/>
+          </p:cNvSpPr>
+          <p:nvPr/>
+        </p:nvSpPr>
+        <p:spPr>
+          <a:xfrm xmlns:a="http://schemas.openxmlformats.org/drawingml/2006/main">
+            <a:off x="1943100" y="2552700"/>
+            <a:ext cx="8953500" cy="3219450"/>
+          </a:xfrm>
+          <a:prstGeom xmlns:a="http://schemas.openxmlformats.org/drawingml/2006/main" prst="rect">
+            <a:avLst/>
+          </a:prstGeom>
+          <a:noFill xmlns:a="http://schemas.openxmlformats.org/drawingml/2006/main"/>
+          <a:ln xmlns:a="http://schemas.openxmlformats.org/drawingml/2006/main" w="0">
+            <a:noFill/>
+            <a:prstDash val="solid"/>
+          </a:ln>
+        </p:spPr>
+        <p:txBody>
+          <a:bodyPr xmlns:a="http://schemas.openxmlformats.org/drawingml/2006/main" lIns="91440" tIns="45720" rIns="91440" bIns="45720" anchor="ctr"/>
+          <a:lstStyle xmlns:a="http://schemas.openxmlformats.org/drawingml/2006/main"/>
+          <a:p xmlns:a="http://schemas.openxmlformats.org/drawingml/2006/main">
+            <a:pPr algn="l">
+              <a:buNone/>
+              <a:defRPr sz="1875" b="0">
+                <a:solidFill>
+                  <a:srgbClr val="FFFFFF"/>
+                </a:solidFill>
+                <a:latin typeface="Calibri"/>
+                <a:ea typeface="Calibri"/>
+                <a:cs typeface="Calibri"/>
+              </a:defRPr>
+            </a:pPr>
+            <a:r>
+              <a:rPr sz="1875" b="0">
+                <a:solidFill>
+                  <a:srgbClr val="FFFFFF"/>
+                </a:solidFill>
+                <a:latin typeface="Calibri"/>
+                <a:ea typeface="Calibri"/>
+                <a:cs typeface="Calibri"/>
+              </a:rPr>
+              <a:t>• Классическая стратегия допускает глобальную остановку.</a:t>
+            </a:r>
+          </a:p>
+          <a:p xmlns:a="http://schemas.openxmlformats.org/drawingml/2006/main">
+            <a:r>
+              <a:t/>
+            </a:r>
+          </a:p>
+          <a:p xmlns:a="http://schemas.openxmlformats.org/drawingml/2006/main">
+            <a:pPr algn="l">
+              <a:buNone/>
+              <a:defRPr sz="1875" b="0">
+                <a:solidFill>
+                  <a:srgbClr val="FFFFFF"/>
+                </a:solidFill>
+                <a:latin typeface="Calibri"/>
+                <a:ea typeface="Calibri"/>
+                <a:cs typeface="Calibri"/>
+              </a:defRPr>
+            </a:pPr>
+            <a:r>
+              <a:rPr sz="1875" b="0">
+                <a:solidFill>
+                  <a:srgbClr val="FFFFFF"/>
+                </a:solidFill>
+                <a:latin typeface="Calibri"/>
+                <a:ea typeface="Calibri"/>
+                <a:cs typeface="Calibri"/>
+              </a:rPr>
+              <a:t>• Арбитр устраняет цикл захвата всех вилок.</a:t>
+            </a:r>
+          </a:p>
+          <a:p xmlns:a="http://schemas.openxmlformats.org/drawingml/2006/main">
+            <a:r>
+              <a:t/>
+            </a:r>
+          </a:p>
+          <a:p xmlns:a="http://schemas.openxmlformats.org/drawingml/2006/main">
+            <a:pPr algn="l">
+              <a:buNone/>
+              <a:defRPr sz="1875" b="0">
+                <a:solidFill>
+                  <a:srgbClr val="FFFFFF"/>
+                </a:solidFill>
+                <a:latin typeface="Calibri"/>
+                <a:ea typeface="Calibri"/>
+                <a:cs typeface="Calibri"/>
+              </a:defRPr>
+            </a:pPr>
+            <a:r>
+              <a:rPr sz="1875" b="0">
+                <a:solidFill>
+                  <a:srgbClr val="FFFFFF"/>
+                </a:solidFill>
+                <a:latin typeface="Calibri"/>
+                <a:ea typeface="Calibri"/>
+                <a:cs typeface="Calibri"/>
+              </a:rPr>
+              <a:t>• Данные, блокноты и тесты согласуются с устройством сети.</a:t>
+            </a:r>
+          </a:p>
+        </p:txBody>
+      </p:sp>
+      <p:sp>
+        <p:nvSpPr>
+          <p:cNvPr id="6" name="final">
+            <a:extLst xmlns:a="http://schemas.openxmlformats.org/drawingml/2006/main">
+              <a:ext uri="{FF2B5EF4-FFF2-40B4-BE49-F238E27FC236}">
+                <a16:creationId xmlns:a16="http://schemas.microsoft.com/office/drawing/2014/main" id="{FCC7524D-04B4-4E2B-BB4A-218A72DF3564}"/>
+              </a:ext>
+            </a:extLst>
+          </p:cNvPr>
+          <p:cNvSpPr>
+            <a:spLocks xmlns:a="http://schemas.openxmlformats.org/drawingml/2006/main" noGrp="1"/>
+          </p:cNvSpPr>
+          <p:nvPr/>
+        </p:nvSpPr>
+        <p:spPr>
+          <a:xfrm xmlns:a="http://schemas.openxmlformats.org/drawingml/2006/main">
+            <a:off x="1943100" y="5924550"/>
+            <a:ext cx="5715000" cy="495300"/>
+          </a:xfrm>
+          <a:prstGeom xmlns:a="http://schemas.openxmlformats.org/drawingml/2006/main" prst="rect">
+            <a:avLst/>
+          </a:prstGeom>
+          <a:noFill xmlns:a="http://schemas.openxmlformats.org/drawingml/2006/main"/>
+          <a:ln xmlns:a="http://schemas.openxmlformats.org/drawingml/2006/main" w="0">
+            <a:noFill/>
+            <a:prstDash val="solid"/>
+          </a:ln>
+        </p:spPr>
+        <p:txBody>
+          <a:bodyPr xmlns:a="http://schemas.openxmlformats.org/drawingml/2006/main" lIns="91440" tIns="45720" rIns="91440" bIns="45720" anchor="ctr"/>
+          <a:lstStyle xmlns:a="http://schemas.openxmlformats.org/drawingml/2006/main"/>
+          <a:p xmlns:a="http://schemas.openxmlformats.org/drawingml/2006/main">
+            <a:pPr algn="l">
+              <a:buNone/>
+              <a:defRPr sz="1650" b="1">
+                <a:solidFill>
+                  <a:srgbClr val="35A9D3"/>
+                </a:solidFill>
+                <a:latin typeface="Calibri"/>
+                <a:ea typeface="Calibri"/>
+                <a:cs typeface="Calibri"/>
+              </a:defRPr>
+            </a:pPr>
+            <a:r>
+              <a:rPr sz="1650" b="1">
+                <a:solidFill>
+                  <a:srgbClr val="35A9D3"/>
+                </a:solidFill>
+                <a:latin typeface="Calibri"/>
+                <a:ea typeface="Calibri"/>
+                <a:cs typeface="Calibri"/>
+              </a:rPr>
+              <a:t>Лабораторная работа № 5</a:t>
+            </a:r>
+          </a:p>
+        </p:txBody>
+      </p:sp>
+    </p:spTree>
+    <p:extLst>
+      <p:ext uri="{BB962C8B-B14F-4D97-AF65-F5344CB8AC3E}">
+        <p14:creationId xmlns:p14="http://schemas.microsoft.com/office/powerpoint/2010/main" val="509539714"/>
+      </p:ext>
+    </p:extLst>
+  </p:cSld>
+</p:sld>
+</file>
+
+<file path=ppt/slides/slide25.xml><?xml version="1.0" encoding="utf-8"?>
+<p:sld xmlns:p="http://schemas.openxmlformats.org/presentationml/2006/main">
+  <p:cSld>
+    <p:bg>
+      <p:bgPr>
+        <a:solidFill xmlns:a="http://schemas.openxmlformats.org/drawingml/2006/main">
+          <a:srgbClr val="0B4778"/>
+        </a:solidFill>
+      </p:bgPr>
+    </p:bg>
+    <p:spTree>
+      <p:nvGrpSpPr>
+        <p:cNvPr id="1" name=""/>
+        <p:cNvGrpSpPr/>
+        <p:nvPr/>
+      </p:nvGrpSpPr>
+      <p:grpSpPr>
+        <a:xfrm xmlns:a="http://schemas.openxmlformats.org/drawingml/2006/main"/>
+      </p:grpSpPr>
+      <p:sp>
+        <p:nvSpPr>
+          <p:cNvPr id="7" name="accent">
+            <a:extLst xmlns:a="http://schemas.openxmlformats.org/drawingml/2006/main">
+              <a:ext uri="{FF2B5EF4-FFF2-40B4-BE49-F238E27FC236}">
+                <a16:creationId xmlns:a16="http://schemas.microsoft.com/office/drawing/2014/main" id="{7EDC123F-A2A1-4A23-B400-58E76A7A62D7}"/>
+              </a:ext>
+            </a:extLst>
+          </p:cNvPr>
+          <p:cNvSpPr>
+            <a:spLocks xmlns:a="http://schemas.openxmlformats.org/drawingml/2006/main" noGrp="1"/>
+          </p:cNvSpPr>
+          <p:nvPr/>
+        </p:nvSpPr>
+        <p:spPr>
+          <a:xfrm xmlns:a="http://schemas.openxmlformats.org/drawingml/2006/main">
+            <a:off x="0" y="0"/>
+            <a:ext cx="133350" cy="6858000"/>
+          </a:xfrm>
+          <a:prstGeom xmlns:a="http://schemas.openxmlformats.org/drawingml/2006/main" prst="rect">
+            <a:avLst/>
+          </a:prstGeom>
+          <a:solidFill xmlns:a="http://schemas.openxmlformats.org/drawingml/2006/main">
+            <a:srgbClr val="35A9D3"/>
+          </a:solidFill>
+          <a:ln xmlns:a="http://schemas.openxmlformats.org/drawingml/2006/main" w="0">
+            <a:noFill/>
+            <a:prstDash val="solid"/>
+          </a:ln>
+        </p:spPr>
+      </p:sp>
+      <p:pic>
+        <p:nvPicPr>
+          <p:cNvPr id="10" name=""/>
+          <p:cNvPicPr>
+            <a:picLocks xmlns:a="http://schemas.openxmlformats.org/drawingml/2006/main" noChangeAspect="1"/>
+          </p:cNvPicPr>
+          <p:nvPr/>
+        </p:nvPicPr>
+        <p:blipFill>
+          <a:blip xmlns:r="http://schemas.openxmlformats.org/officeDocument/2006/relationships" xmlns:a="http://schemas.openxmlformats.org/drawingml/2006/main" r:embed="Rdd23dd4a88354f69"/>
           <a:stretch xmlns:a="http://schemas.openxmlformats.org/drawingml/2006/main"/>
         </p:blipFill>
         <p:spPr>
@@ -13293,7 +14214,7 @@
           <p:nvPr/>
         </p:nvPicPr>
         <p:blipFill>
-          <a:blip xmlns:r="http://schemas.openxmlformats.org/officeDocument/2006/relationships" xmlns:a="http://schemas.openxmlformats.org/drawingml/2006/main" r:embed="Rb25ce708cc4c49ea"/>
+          <a:blip xmlns:r="http://schemas.openxmlformats.org/officeDocument/2006/relationships" xmlns:a="http://schemas.openxmlformats.org/drawingml/2006/main" r:embed="R5e9fa0c2e82c4d61"/>
           <a:stretch xmlns:a="http://schemas.openxmlformats.org/drawingml/2006/main"/>
         </p:blipFill>
         <p:spPr>
@@ -13898,7 +14819,7 @@
           <p:nvPr/>
         </p:nvPicPr>
         <p:blipFill>
-          <a:blip xmlns:r="http://schemas.openxmlformats.org/officeDocument/2006/relationships" xmlns:a="http://schemas.openxmlformats.org/drawingml/2006/main" r:embed="R046b65d7e5394adf"/>
+          <a:blip xmlns:r="http://schemas.openxmlformats.org/officeDocument/2006/relationships" xmlns:a="http://schemas.openxmlformats.org/drawingml/2006/main" r:embed="R3415d10c6ea241cd"/>
           <a:stretch xmlns:a="http://schemas.openxmlformats.org/drawingml/2006/main"/>
         </p:blipFill>
         <p:spPr>
@@ -14799,7 +15720,7 @@
           <p:nvPr/>
         </p:nvPicPr>
         <p:blipFill>
-          <a:blip xmlns:r="http://schemas.openxmlformats.org/officeDocument/2006/relationships" xmlns:a="http://schemas.openxmlformats.org/drawingml/2006/main" r:embed="R1174d220ee704f9d"/>
+          <a:blip xmlns:r="http://schemas.openxmlformats.org/officeDocument/2006/relationships" xmlns:a="http://schemas.openxmlformats.org/drawingml/2006/main" r:embed="R9cb9b489f9414f5e"/>
           <a:stretch xmlns:a="http://schemas.openxmlformats.org/drawingml/2006/main"/>
         </p:blipFill>
         <p:spPr>
@@ -15285,7 +16206,7 @@
           <p:nvPr/>
         </p:nvPicPr>
         <p:blipFill>
-          <a:blip xmlns:r="http://schemas.openxmlformats.org/officeDocument/2006/relationships" xmlns:a="http://schemas.openxmlformats.org/drawingml/2006/main" r:embed="R5ec2107ffea046fc"/>
+          <a:blip xmlns:r="http://schemas.openxmlformats.org/officeDocument/2006/relationships" xmlns:a="http://schemas.openxmlformats.org/drawingml/2006/main" r:embed="Red20c27374a344b3"/>
           <a:stretch xmlns:a="http://schemas.openxmlformats.org/drawingml/2006/main"/>
         </p:blipFill>
         <p:spPr>
@@ -15746,7 +16667,7 @@
           <p:nvPr/>
         </p:nvPicPr>
         <p:blipFill>
-          <a:blip xmlns:r="http://schemas.openxmlformats.org/officeDocument/2006/relationships" xmlns:a="http://schemas.openxmlformats.org/drawingml/2006/main" r:embed="Rc4ebf709517e4613"/>
+          <a:blip xmlns:r="http://schemas.openxmlformats.org/officeDocument/2006/relationships" xmlns:a="http://schemas.openxmlformats.org/drawingml/2006/main" r:embed="R357c667453764c56"/>
           <a:stretch xmlns:a="http://schemas.openxmlformats.org/drawingml/2006/main"/>
         </p:blipFill>
         <p:spPr>
@@ -16677,7 +17598,7 @@
           <p:nvPr/>
         </p:nvPicPr>
         <p:blipFill>
-          <a:blip xmlns:r="http://schemas.openxmlformats.org/officeDocument/2006/relationships" xmlns:a="http://schemas.openxmlformats.org/drawingml/2006/main" r:embed="Re29bb13e62b24a2a"/>
+          <a:blip xmlns:r="http://schemas.openxmlformats.org/officeDocument/2006/relationships" xmlns:a="http://schemas.openxmlformats.org/drawingml/2006/main" r:embed="R1c7554b2423848d7"/>
           <a:stretch xmlns:a="http://schemas.openxmlformats.org/drawingml/2006/main"/>
         </p:blipFill>
         <p:spPr>
@@ -17578,7 +18499,7 @@
           <p:nvPr/>
         </p:nvPicPr>
         <p:blipFill>
-          <a:blip xmlns:r="http://schemas.openxmlformats.org/officeDocument/2006/relationships" xmlns:a="http://schemas.openxmlformats.org/drawingml/2006/main" r:embed="R31fec0ede30948bb"/>
+          <a:blip xmlns:r="http://schemas.openxmlformats.org/officeDocument/2006/relationships" xmlns:a="http://schemas.openxmlformats.org/drawingml/2006/main" r:embed="R1d3a7cbe08c6434c"/>
           <a:stretch xmlns:a="http://schemas.openxmlformats.org/drawingml/2006/main"/>
         </p:blipFill>
         <p:spPr>
@@ -17714,7 +18635,7 @@
           <p:nvPr/>
         </p:nvPicPr>
         <p:blipFill>
-          <a:blip xmlns:r="http://schemas.openxmlformats.org/officeDocument/2006/relationships" xmlns:a="http://schemas.openxmlformats.org/drawingml/2006/main" r:embed="R39ef5d68561f45e2"/>
+          <a:blip xmlns:r="http://schemas.openxmlformats.org/officeDocument/2006/relationships" xmlns:a="http://schemas.openxmlformats.org/drawingml/2006/main" r:embed="Re09b8db8038c4641"/>
           <a:stretch xmlns:a="http://schemas.openxmlformats.org/drawingml/2006/main"/>
         </p:blipFill>
         <p:spPr>

</xml_diff>